<commit_message>
ECG picture, history reorder, and diagnosis slide
- Slide 14 (ECG): replace stylized trace with a generated 12-lead ECG
  printout on ECG paper (AF with rapid ventricular response, 146 bpm)
- Reorder background history to Drug -> Medical -> Surgical
- Add a Differential & Final Diagnosis slide after the echocardiography
  slide (differentials excluded on ECG grounds; final Dx = AF with RVR in
  a structurally normal heart)

Updates both the standalone case deck (19 slides) and the combined
case+topic deck (37 slides); page numbering stays continuous.

Co-Authored-By: Claude Opus 4.8 <noreply@anthropic.com>
Claude-Session: https://claude.ai/code/session_01S7QW8AwqyMReKwuqyBkBBv
</commit_message>
<xml_diff>
--- a/presentations/Clinicopathological-Conference.pptx
+++ b/presentations/Clinicopathological-Conference.pptx
@@ -23,9 +23,10 @@
     <p:sldId id="271" r:id="rId17"/>
     <p:sldId id="272" r:id="rId18"/>
     <p:sldId id="273" r:id="rId19"/>
+    <p:sldId id="274" r:id="rId20"/>
   </p:sldIdLst>
   <p:notesMasterIdLst>
-    <p:notesMasterId r:id="rId20"/>
+    <p:notesMasterId r:id="rId21"/>
   </p:notesMasterIdLst>
   <p:sldSz cx="12191695" cy="6858000"/>
   <p:notesSz cx="6858000" cy="12191695"/>
@@ -1335,6 +1336,94 @@
             <a:fld id="{F7021451-1387-4CA6-816F-3879F97B5CBC}" type="slidenum">
               <a:rPr lang="en-US"/>
               <a:t>18</a:t>
+            </a:fld>
+            <a:endParaRPr lang="en-US"/>
+          </a:p>
+        </p:txBody>
+      </p:sp>
+    </p:spTree>
+    <p:extLst>
+      <p:ext uri="{BB962C8B-B14F-4D97-AF65-F5344CB8AC3E}">
+        <p14:creationId xmlns:p14="http://schemas.microsoft.com/office/powerpoint/2010/main" val="1024086991"/>
+      </p:ext>
+    </p:extLst>
+  </p:cSld>
+  <p:clrMapOvr>
+    <a:masterClrMapping/>
+  </p:clrMapOvr>
+</p:notes>
+</file>
+
+<file path=ppt/notesSlides/notesSlide19.xml><?xml version="1.0" encoding="utf-8"?>
+<p:notes xmlns:a="http://schemas.openxmlformats.org/drawingml/2006/main" xmlns:r="http://schemas.openxmlformats.org/officeDocument/2006/relationships" xmlns:p="http://schemas.openxmlformats.org/presentationml/2006/main">
+  <p:cSld>
+    <p:spTree>
+      <p:nvGrpSpPr>
+        <p:cNvPr id="1" name=""/>
+        <p:cNvGrpSpPr/>
+        <p:nvPr/>
+      </p:nvGrpSpPr>
+      <p:grpSpPr>
+        <a:xfrm>
+          <a:off x="0" y="0"/>
+          <a:ext cx="0" cy="0"/>
+          <a:chOff x="0" y="0"/>
+          <a:chExt cx="0" cy="0"/>
+        </a:xfrm>
+      </p:grpSpPr>
+      <p:sp>
+        <p:nvSpPr>
+          <p:cNvPr id="2" name="Slide Image Placeholder 1"/>
+          <p:cNvSpPr>
+            <a:spLocks noGrp="1" noRot="1" noChangeAspect="1"/>
+          </p:cNvSpPr>
+          <p:nvPr>
+            <p:ph type="sldImg"/>
+          </p:nvPr>
+        </p:nvSpPr>
+        <p:spPr/>
+      </p:sp>
+      <p:sp>
+        <p:nvSpPr>
+          <p:cNvPr id="3" name="Notes Placeholder 2"/>
+          <p:cNvSpPr>
+            <a:spLocks noGrp="1"/>
+          </p:cNvSpPr>
+          <p:nvPr>
+            <p:ph type="body" idx="1"/>
+          </p:nvPr>
+        </p:nvSpPr>
+        <p:spPr/>
+        <p:txBody>
+          <a:bodyPr/>
+          <a:lstStyle/>
+          <a:p>
+            <a:r>
+              <a:rPr lang="en-US" dirty="0"/>
+              <a:t/>
+            </a:r>
+            <a:endParaRPr lang="en-US" dirty="0"/>
+          </a:p>
+        </p:txBody>
+      </p:sp>
+      <p:sp>
+        <p:nvSpPr>
+          <p:cNvPr id="4" name="Slide Number Placeholder 3"/>
+          <p:cNvSpPr>
+            <a:spLocks noGrp="1"/>
+          </p:cNvSpPr>
+          <p:nvPr>
+            <p:ph type="sldNum" sz="quarter" idx="10"/>
+          </p:nvPr>
+        </p:nvSpPr>
+        <p:spPr/>
+        <p:txBody>
+          <a:bodyPr/>
+          <a:lstStyle/>
+          <a:p>
+            <a:fld id="{F7021451-1387-4CA6-816F-3879F97B5CBC}" type="slidenum">
+              <a:rPr lang="en-US"/>
+              <a:t>19</a:t>
             </a:fld>
             <a:endParaRPr lang="en-US"/>
           </a:p>
@@ -6374,12 +6463,12 @@
         </p:nvSpPr>
         <p:spPr>
           <a:xfrm>
-            <a:off x="502920" y="1627632"/>
-            <a:ext cx="11183112" cy="1078992"/>
+            <a:off x="502920" y="1600200"/>
+            <a:ext cx="11183112" cy="896112"/>
           </a:xfrm>
           <a:prstGeom prst="roundRect">
             <a:avLst>
-              <a:gd name="adj" fmla="val 10169"/>
+              <a:gd name="adj" fmla="val 12245"/>
             </a:avLst>
           </a:prstGeom>
           <a:solidFill>
@@ -6403,8 +6492,8 @@
         </p:nvSpPr>
         <p:spPr>
           <a:xfrm>
-            <a:off x="777240" y="1856232"/>
-            <a:ext cx="621792" cy="621792"/>
+            <a:off x="749808" y="1801368"/>
+            <a:ext cx="512064" cy="512064"/>
           </a:xfrm>
           <a:prstGeom prst="ellipse">
             <a:avLst/>
@@ -6431,8 +6520,8 @@
         </p:blipFill>
         <p:spPr>
           <a:xfrm>
-            <a:off x="932688" y="2011680"/>
-            <a:ext cx="310896" cy="310896"/>
+            <a:off x="877824" y="1929384"/>
+            <a:ext cx="256032" cy="256032"/>
           </a:xfrm>
           <a:prstGeom prst="rect">
             <a:avLst/>
@@ -6447,8 +6536,8 @@
         </p:nvSpPr>
         <p:spPr>
           <a:xfrm>
-            <a:off x="1600200" y="1783080"/>
-            <a:ext cx="9921240" cy="566928"/>
+            <a:off x="1463040" y="1600200"/>
+            <a:ext cx="7498080" cy="896112"/>
           </a:xfrm>
           <a:prstGeom prst="rect">
             <a:avLst/>
@@ -6464,7 +6553,7 @@
               <a:buNone/>
             </a:pPr>
             <a:r>
-              <a:rPr lang="en-US" sz="2800" b="1" dirty="0">
+              <a:rPr lang="en-US" sz="2200" b="1" dirty="0">
                 <a:solidFill>
                   <a:srgbClr val="FFFFFF"/>
                 </a:solidFill>
@@ -6474,7 +6563,7 @@
               </a:rPr>
               <a:t>Atrial Fibrillation with Rapid Ventricular Response</a:t>
             </a:r>
-            <a:endParaRPr lang="en-US" sz="2800" dirty="0"/>
+            <a:endParaRPr lang="en-US" sz="2200" dirty="0"/>
           </a:p>
         </p:txBody>
       </p:sp>
@@ -6486,24 +6575,38 @@
         </p:nvSpPr>
         <p:spPr>
           <a:xfrm>
-            <a:off x="1600200" y="2331720"/>
-            <a:ext cx="9921240" cy="274320"/>
-          </a:xfrm>
-          <a:prstGeom prst="rect">
-            <a:avLst/>
-          </a:prstGeom>
-          <a:noFill/>
-          <a:ln/>
-        </p:spPr>
-        <p:txBody>
-          <a:bodyPr wrap="square" lIns="0" tIns="0" rIns="0" bIns="0" rtlCol="0" anchor="t"/>
-          <a:lstStyle/>
-          <a:p>
-            <a:pPr algn="l" indent="0" marL="0">
-              <a:buNone/>
-            </a:pPr>
-            <a:r>
-              <a:rPr lang="en-US" sz="1300" b="1" dirty="0">
+            <a:off x="8869680" y="1600200"/>
+            <a:ext cx="2697480" cy="896112"/>
+          </a:xfrm>
+          <a:prstGeom prst="rect">
+            <a:avLst/>
+          </a:prstGeom>
+          <a:noFill/>
+          <a:ln/>
+        </p:spPr>
+        <p:txBody>
+          <a:bodyPr wrap="square" lIns="0" tIns="0" rIns="0" bIns="0" rtlCol="0" anchor="ctr"/>
+          <a:lstStyle/>
+          <a:p>
+            <a:pPr algn="r" indent="0" marL="0">
+              <a:buNone/>
+            </a:pPr>
+            <a:r>
+              <a:rPr lang="en-US" sz="1250" dirty="0">
+                <a:solidFill>
+                  <a:srgbClr val="FBD8DF"/>
+                </a:solidFill>
+                <a:latin typeface="Calibri" pitchFamily="34" charset="0"/>
+                <a:ea typeface="Calibri" pitchFamily="34" charset="-122"/>
+                <a:cs typeface="Calibri" pitchFamily="34" charset="-120"/>
+              </a:rPr>
+              <a:t>Abnormal rhythm ECG · </a:t>
+            </a:r>
+            <a:pPr algn="r" indent="0" marL="0">
+              <a:buNone/>
+            </a:pPr>
+            <a:r>
+              <a:rPr lang="en-US" sz="1250" b="1" dirty="0">
                 <a:solidFill>
                   <a:srgbClr val="FF4D6D"/>
                 </a:solidFill>
@@ -6511,9 +6614,9 @@
                 <a:ea typeface="Calibri" pitchFamily="34" charset="-122"/>
                 <a:cs typeface="Calibri" pitchFamily="34" charset="-120"/>
               </a:rPr>
-              <a:t>Abnormal rhythm ECG · 06-Jul-2026</a:t>
-            </a:r>
-            <a:endParaRPr lang="en-US" sz="1300" dirty="0"/>
+              <a:t>06-Jul-2026</a:t>
+            </a:r>
+            <a:endParaRPr lang="en-US" sz="1250" dirty="0"/>
           </a:p>
         </p:txBody>
       </p:sp>
@@ -6525,12 +6628,70 @@
         </p:nvSpPr>
         <p:spPr>
           <a:xfrm>
-            <a:off x="502920" y="2889504"/>
-            <a:ext cx="3246120" cy="2615184"/>
+            <a:off x="502920" y="2651760"/>
+            <a:ext cx="7973568" cy="3355848"/>
           </a:xfrm>
           <a:prstGeom prst="roundRect">
             <a:avLst>
-              <a:gd name="adj" fmla="val 4196"/>
+              <a:gd name="adj" fmla="val 3270"/>
+            </a:avLst>
+          </a:prstGeom>
+          <a:solidFill>
+            <a:srgbClr val="FFFFFF"/>
+          </a:solidFill>
+          <a:ln w="12700">
+            <a:solidFill>
+              <a:srgbClr val="FBD8DF"/>
+            </a:solidFill>
+            <a:prstDash val="solid"/>
+          </a:ln>
+          <a:effectLst>
+            <a:outerShdw sx="100000" sy="100000" kx="0" ky="0" algn="bl" rotWithShape="0" blurRad="127000" dist="50800" dir="5400000">
+              <a:srgbClr val="C9A3AC">
+                <a:alpha val="45000"/>
+              </a:srgbClr>
+            </a:outerShdw>
+          </a:effectLst>
+        </p:spPr>
+      </p:sp>
+      <p:pic>
+        <p:nvPicPr>
+          <p:cNvPr id="12" name="Image 2" descr="preencoded.png">    </p:cNvPr>
+          <p:cNvPicPr>
+            <a:picLocks noChangeAspect="1"/>
+          </p:cNvPicPr>
+          <p:nvPr/>
+        </p:nvPicPr>
+        <p:blipFill>
+          <a:blip r:embed="rId3"/>
+          <a:stretch>
+            <a:fillRect/>
+          </a:stretch>
+        </p:blipFill>
+        <p:spPr>
+          <a:xfrm>
+            <a:off x="621792" y="2724912"/>
+            <a:ext cx="7735824" cy="3227832"/>
+          </a:xfrm>
+          <a:prstGeom prst="rect">
+            <a:avLst/>
+          </a:prstGeom>
+        </p:spPr>
+      </p:pic>
+      <p:sp>
+        <p:nvSpPr>
+          <p:cNvPr id="13" name="Shape 8"/>
+          <p:cNvSpPr/>
+          <p:nvPr/>
+        </p:nvSpPr>
+        <p:spPr>
+          <a:xfrm>
+            <a:off x="8613648" y="2651760"/>
+            <a:ext cx="3072384" cy="1078992"/>
+          </a:xfrm>
+          <a:prstGeom prst="roundRect">
+            <a:avLst>
+              <a:gd name="adj" fmla="val 10169"/>
             </a:avLst>
           </a:prstGeom>
           <a:solidFill>
@@ -6553,14 +6714,14 @@
       </p:sp>
       <p:sp>
         <p:nvSpPr>
-          <p:cNvPr id="12" name="Text 8"/>
-          <p:cNvSpPr/>
-          <p:nvPr/>
-        </p:nvSpPr>
-        <p:spPr>
-          <a:xfrm>
-            <a:off x="777240" y="3145536"/>
-            <a:ext cx="2743200" cy="274320"/>
+          <p:cNvPr id="14" name="Text 9"/>
+          <p:cNvSpPr/>
+          <p:nvPr/>
+        </p:nvSpPr>
+        <p:spPr>
+          <a:xfrm>
+            <a:off x="8833104" y="2779776"/>
+            <a:ext cx="2194560" cy="256032"/>
           </a:xfrm>
           <a:prstGeom prst="rect">
             <a:avLst/>
@@ -6576,7 +6737,7 @@
               <a:buNone/>
             </a:pPr>
             <a:r>
-              <a:rPr lang="en-US" sz="1250" b="1" spc="200" kern="0" dirty="0">
+              <a:rPr lang="en-US" sz="1100" b="1" spc="150" kern="0" dirty="0">
                 <a:solidFill>
                   <a:srgbClr val="A4133C"/>
                 </a:solidFill>
@@ -6586,28 +6747,28 @@
               </a:rPr>
               <a:t>VENTRICULAR RATE</a:t>
             </a:r>
-            <a:endParaRPr lang="en-US" sz="1250" dirty="0"/>
+            <a:endParaRPr lang="en-US" sz="1100" dirty="0"/>
           </a:p>
         </p:txBody>
       </p:sp>
       <p:pic>
         <p:nvPicPr>
-          <p:cNvPr id="13" name="Image 2" descr="preencoded.png">    </p:cNvPr>
+          <p:cNvPr id="15" name="Image 3" descr="preencoded.png">    </p:cNvPr>
           <p:cNvPicPr>
             <a:picLocks noChangeAspect="1"/>
           </p:cNvPicPr>
           <p:nvPr/>
         </p:nvPicPr>
         <p:blipFill>
-          <a:blip r:embed="rId3"/>
+          <a:blip r:embed="rId4"/>
           <a:stretch>
             <a:fillRect/>
           </a:stretch>
         </p:blipFill>
         <p:spPr>
           <a:xfrm>
-            <a:off x="3246120" y="3127248"/>
-            <a:ext cx="292608" cy="292608"/>
+            <a:off x="11228832" y="2761488"/>
+            <a:ext cx="274320" cy="274320"/>
           </a:xfrm>
           <a:prstGeom prst="rect">
             <a:avLst/>
@@ -6616,14 +6777,14 @@
       </p:pic>
       <p:sp>
         <p:nvSpPr>
-          <p:cNvPr id="14" name="Text 9"/>
-          <p:cNvSpPr/>
-          <p:nvPr/>
-        </p:nvSpPr>
-        <p:spPr>
-          <a:xfrm>
-            <a:off x="777240" y="3511296"/>
-            <a:ext cx="2743200" cy="868680"/>
+          <p:cNvPr id="16" name="Text 10"/>
+          <p:cNvSpPr/>
+          <p:nvPr/>
+        </p:nvSpPr>
+        <p:spPr>
+          <a:xfrm>
+            <a:off x="8833104" y="3072384"/>
+            <a:ext cx="1828800" cy="548640"/>
           </a:xfrm>
           <a:prstGeom prst="rect">
             <a:avLst/>
@@ -6639,7 +6800,7 @@
               <a:buNone/>
             </a:pPr>
             <a:r>
-              <a:rPr lang="en-US" sz="4400" b="1" dirty="0">
+              <a:rPr lang="en-US" sz="3600" b="1" dirty="0">
                 <a:solidFill>
                   <a:srgbClr val="FF4D6D"/>
                 </a:solidFill>
@@ -6653,7 +6814,7 @@
               <a:buNone/>
             </a:pPr>
             <a:r>
-              <a:rPr lang="en-US" sz="1800" b="1" dirty="0">
+              <a:rPr lang="en-US" sz="1500" b="1" dirty="0">
                 <a:solidFill>
                   <a:srgbClr val="6B6B76"/>
                 </a:solidFill>
@@ -6661,22 +6822,22 @@
                 <a:ea typeface="Calibri" pitchFamily="34" charset="-122"/>
                 <a:cs typeface="Calibri" pitchFamily="34" charset="-120"/>
               </a:rPr>
-              <a:t>  bpm</a:t>
-            </a:r>
-            <a:endParaRPr lang="en-US" sz="4400" dirty="0"/>
-          </a:p>
-        </p:txBody>
-      </p:sp>
-      <p:sp>
-        <p:nvSpPr>
-          <p:cNvPr id="15" name="Shape 10"/>
-          <p:cNvSpPr/>
-          <p:nvPr/>
-        </p:nvSpPr>
-        <p:spPr>
-          <a:xfrm>
-            <a:off x="777240" y="4526280"/>
-            <a:ext cx="1463040" cy="457200"/>
+              <a:t> bpm</a:t>
+            </a:r>
+            <a:endParaRPr lang="en-US" sz="3600" dirty="0"/>
+          </a:p>
+        </p:txBody>
+      </p:sp>
+      <p:sp>
+        <p:nvSpPr>
+          <p:cNvPr id="17" name="Shape 11"/>
+          <p:cNvSpPr/>
+          <p:nvPr/>
+        </p:nvSpPr>
+        <p:spPr>
+          <a:xfrm>
+            <a:off x="10543032" y="3163824"/>
+            <a:ext cx="960120" cy="402336"/>
           </a:xfrm>
           <a:prstGeom prst="roundRect">
             <a:avLst>
@@ -6691,14 +6852,14 @@
       </p:sp>
       <p:sp>
         <p:nvSpPr>
-          <p:cNvPr id="16" name="Text 11"/>
-          <p:cNvSpPr/>
-          <p:nvPr/>
-        </p:nvSpPr>
-        <p:spPr>
-          <a:xfrm>
-            <a:off x="777240" y="4526280"/>
-            <a:ext cx="1463040" cy="457200"/>
+          <p:cNvPr id="18" name="Text 12"/>
+          <p:cNvSpPr/>
+          <p:nvPr/>
+        </p:nvSpPr>
+        <p:spPr>
+          <a:xfrm>
+            <a:off x="10543032" y="3163824"/>
+            <a:ext cx="960120" cy="402336"/>
           </a:xfrm>
           <a:prstGeom prst="rect">
             <a:avLst/>
@@ -6714,7 +6875,7 @@
               <a:buNone/>
             </a:pPr>
             <a:r>
-              <a:rPr lang="en-US" sz="1300" b="1" spc="150" kern="0" dirty="0">
+              <a:rPr lang="en-US" sz="1200" b="1" spc="100" kern="0" dirty="0">
                 <a:solidFill>
                   <a:srgbClr val="FFFFFF"/>
                 </a:solidFill>
@@ -6724,199 +6885,24 @@
               </a:rPr>
               <a:t>RAPID</a:t>
             </a:r>
-            <a:endParaRPr lang="en-US" sz="1300" dirty="0"/>
-          </a:p>
-        </p:txBody>
-      </p:sp>
-      <p:sp>
-        <p:nvSpPr>
-          <p:cNvPr id="17" name="Shape 12"/>
-          <p:cNvSpPr/>
-          <p:nvPr/>
-        </p:nvSpPr>
-        <p:spPr>
-          <a:xfrm>
-            <a:off x="868680" y="5193792"/>
-            <a:ext cx="854964" cy="0"/>
-          </a:xfrm>
-          <a:prstGeom prst="line">
-            <a:avLst/>
-          </a:prstGeom>
-          <a:noFill/>
-          <a:ln w="28575">
-            <a:solidFill>
-              <a:srgbClr val="FF4D6D">
-                <a:alpha val="75000"/>
-              </a:srgbClr>
-            </a:solidFill>
-            <a:prstDash val="solid"/>
-          </a:ln>
-        </p:spPr>
-      </p:sp>
-      <p:sp>
-        <p:nvSpPr>
-          <p:cNvPr id="18" name="Shape 13"/>
-          <p:cNvSpPr/>
-          <p:nvPr/>
-        </p:nvSpPr>
-        <p:spPr>
-          <a:xfrm flipV="1">
-            <a:off x="1723644" y="5047488"/>
-            <a:ext cx="150876" cy="146304"/>
-          </a:xfrm>
-          <a:prstGeom prst="line">
-            <a:avLst/>
-          </a:prstGeom>
-          <a:noFill/>
-          <a:ln w="28575">
-            <a:solidFill>
-              <a:srgbClr val="FF4D6D">
-                <a:alpha val="75000"/>
-              </a:srgbClr>
-            </a:solidFill>
-            <a:prstDash val="solid"/>
-          </a:ln>
-        </p:spPr>
-      </p:sp>
-      <p:sp>
-        <p:nvSpPr>
-          <p:cNvPr id="19" name="Shape 14"/>
-          <p:cNvSpPr/>
-          <p:nvPr/>
-        </p:nvSpPr>
-        <p:spPr>
-          <a:xfrm>
-            <a:off x="1874520" y="5047488"/>
-            <a:ext cx="150876" cy="457200"/>
-          </a:xfrm>
-          <a:prstGeom prst="line">
-            <a:avLst/>
-          </a:prstGeom>
-          <a:noFill/>
-          <a:ln w="28575">
-            <a:solidFill>
-              <a:srgbClr val="FF4D6D">
-                <a:alpha val="75000"/>
-              </a:srgbClr>
-            </a:solidFill>
-            <a:prstDash val="solid"/>
-          </a:ln>
-        </p:spPr>
-      </p:sp>
-      <p:sp>
-        <p:nvSpPr>
-          <p:cNvPr id="20" name="Shape 15"/>
-          <p:cNvSpPr/>
-          <p:nvPr/>
-        </p:nvSpPr>
-        <p:spPr>
-          <a:xfrm flipV="1">
-            <a:off x="2025396" y="4690872"/>
-            <a:ext cx="150876" cy="813816"/>
-          </a:xfrm>
-          <a:prstGeom prst="line">
-            <a:avLst/>
-          </a:prstGeom>
-          <a:noFill/>
-          <a:ln w="28575">
-            <a:solidFill>
-              <a:srgbClr val="FF4D6D">
-                <a:alpha val="75000"/>
-              </a:srgbClr>
-            </a:solidFill>
-            <a:prstDash val="solid"/>
-          </a:ln>
-        </p:spPr>
-      </p:sp>
-      <p:sp>
-        <p:nvSpPr>
-          <p:cNvPr id="21" name="Shape 16"/>
-          <p:cNvSpPr/>
-          <p:nvPr/>
-        </p:nvSpPr>
-        <p:spPr>
-          <a:xfrm>
-            <a:off x="2176272" y="4690872"/>
-            <a:ext cx="150876" cy="685800"/>
-          </a:xfrm>
-          <a:prstGeom prst="line">
-            <a:avLst/>
-          </a:prstGeom>
-          <a:noFill/>
-          <a:ln w="28575">
-            <a:solidFill>
-              <a:srgbClr val="FF4D6D">
-                <a:alpha val="75000"/>
-              </a:srgbClr>
-            </a:solidFill>
-            <a:prstDash val="solid"/>
-          </a:ln>
-        </p:spPr>
-      </p:sp>
-      <p:sp>
-        <p:nvSpPr>
-          <p:cNvPr id="22" name="Shape 17"/>
-          <p:cNvSpPr/>
-          <p:nvPr/>
-        </p:nvSpPr>
-        <p:spPr>
-          <a:xfrm flipV="1">
-            <a:off x="2327148" y="5193792"/>
-            <a:ext cx="150876" cy="182880"/>
-          </a:xfrm>
-          <a:prstGeom prst="line">
-            <a:avLst/>
-          </a:prstGeom>
-          <a:noFill/>
-          <a:ln w="28575">
-            <a:solidFill>
-              <a:srgbClr val="FF4D6D">
-                <a:alpha val="75000"/>
-              </a:srgbClr>
-            </a:solidFill>
-            <a:prstDash val="solid"/>
-          </a:ln>
-        </p:spPr>
-      </p:sp>
-      <p:sp>
-        <p:nvSpPr>
-          <p:cNvPr id="23" name="Shape 18"/>
-          <p:cNvSpPr/>
-          <p:nvPr/>
-        </p:nvSpPr>
-        <p:spPr>
-          <a:xfrm>
-            <a:off x="2478024" y="5193792"/>
-            <a:ext cx="905256" cy="0"/>
-          </a:xfrm>
-          <a:prstGeom prst="line">
-            <a:avLst/>
-          </a:prstGeom>
-          <a:noFill/>
-          <a:ln w="28575">
-            <a:solidFill>
-              <a:srgbClr val="FF4D6D">
-                <a:alpha val="75000"/>
-              </a:srgbClr>
-            </a:solidFill>
-            <a:prstDash val="solid"/>
-          </a:ln>
-        </p:spPr>
-      </p:sp>
-      <p:sp>
-        <p:nvSpPr>
-          <p:cNvPr id="24" name="Shape 19"/>
-          <p:cNvSpPr/>
-          <p:nvPr/>
-        </p:nvSpPr>
-        <p:spPr>
-          <a:xfrm>
-            <a:off x="3977640" y="2889504"/>
-            <a:ext cx="3739896" cy="777240"/>
+            <a:endParaRPr lang="en-US" sz="1200" dirty="0"/>
+          </a:p>
+        </p:txBody>
+      </p:sp>
+      <p:sp>
+        <p:nvSpPr>
+          <p:cNvPr id="19" name="Shape 13"/>
+          <p:cNvSpPr/>
+          <p:nvPr/>
+        </p:nvSpPr>
+        <p:spPr>
+          <a:xfrm>
+            <a:off x="8613648" y="3840480"/>
+            <a:ext cx="3072384" cy="493776"/>
           </a:xfrm>
           <a:prstGeom prst="roundRect">
             <a:avLst>
-              <a:gd name="adj" fmla="val 11765"/>
+              <a:gd name="adj" fmla="val 16667"/>
             </a:avLst>
           </a:prstGeom>
           <a:solidFill>
@@ -6932,14 +6918,14 @@
       </p:sp>
       <p:sp>
         <p:nvSpPr>
-          <p:cNvPr id="25" name="Text 20"/>
-          <p:cNvSpPr/>
-          <p:nvPr/>
-        </p:nvSpPr>
-        <p:spPr>
-          <a:xfrm>
-            <a:off x="4206240" y="3008376"/>
-            <a:ext cx="3328416" cy="219456"/>
+          <p:cNvPr id="20" name="Text 14"/>
+          <p:cNvSpPr/>
+          <p:nvPr/>
+        </p:nvSpPr>
+        <p:spPr>
+          <a:xfrm>
+            <a:off x="8814816" y="3904488"/>
+            <a:ext cx="2706624" cy="182880"/>
           </a:xfrm>
           <a:prstGeom prst="rect">
             <a:avLst/>
@@ -6955,7 +6941,7 @@
               <a:buNone/>
             </a:pPr>
             <a:r>
-              <a:rPr lang="en-US" sz="1100" b="1" spc="120" kern="0" dirty="0">
+              <a:rPr lang="en-US" sz="950" b="1" spc="100" kern="0" dirty="0">
                 <a:solidFill>
                   <a:srgbClr val="A4133C"/>
                 </a:solidFill>
@@ -6965,20 +6951,20 @@
               </a:rPr>
               <a:t>RHYTHM</a:t>
             </a:r>
-            <a:endParaRPr lang="en-US" sz="1100" dirty="0"/>
-          </a:p>
-        </p:txBody>
-      </p:sp>
-      <p:sp>
-        <p:nvSpPr>
-          <p:cNvPr id="26" name="Text 21"/>
-          <p:cNvSpPr/>
-          <p:nvPr/>
-        </p:nvSpPr>
-        <p:spPr>
-          <a:xfrm>
-            <a:off x="4206240" y="3236976"/>
-            <a:ext cx="3328416" cy="384048"/>
+            <a:endParaRPr lang="en-US" sz="950" dirty="0"/>
+          </a:p>
+        </p:txBody>
+      </p:sp>
+      <p:sp>
+        <p:nvSpPr>
+          <p:cNvPr id="21" name="Text 15"/>
+          <p:cNvSpPr/>
+          <p:nvPr/>
+        </p:nvSpPr>
+        <p:spPr>
+          <a:xfrm>
+            <a:off x="8814816" y="4078224"/>
+            <a:ext cx="2706624" cy="237744"/>
           </a:xfrm>
           <a:prstGeom prst="rect">
             <a:avLst/>
@@ -6991,13 +6977,10 @@
           <a:lstStyle/>
           <a:p>
             <a:pPr algn="l" indent="0" marL="0">
-              <a:lnSpc>
-                <a:spcPct val="100000"/>
-              </a:lnSpc>
-              <a:buNone/>
-            </a:pPr>
-            <a:r>
-              <a:rPr lang="en-US" sz="1300" b="1" dirty="0">
+              <a:buNone/>
+            </a:pPr>
+            <a:r>
+              <a:rPr lang="en-US" sz="1250" b="1" dirty="0">
                 <a:solidFill>
                   <a:srgbClr val="2B2B33"/>
                 </a:solidFill>
@@ -7005,26 +6988,26 @@
                 <a:ea typeface="Calibri" pitchFamily="34" charset="-122"/>
                 <a:cs typeface="Calibri" pitchFamily="34" charset="-120"/>
               </a:rPr>
-              <a:t>Atrial fibrillation (irregularly irregular)</a:t>
-            </a:r>
-            <a:endParaRPr lang="en-US" sz="1300" dirty="0"/>
-          </a:p>
-        </p:txBody>
-      </p:sp>
-      <p:sp>
-        <p:nvSpPr>
-          <p:cNvPr id="27" name="Shape 22"/>
-          <p:cNvSpPr/>
-          <p:nvPr/>
-        </p:nvSpPr>
-        <p:spPr>
-          <a:xfrm>
-            <a:off x="7946136" y="2889504"/>
-            <a:ext cx="3739896" cy="777240"/>
+              <a:t>Atrial fibrillation (irregular)</a:t>
+            </a:r>
+            <a:endParaRPr lang="en-US" sz="1250" dirty="0"/>
+          </a:p>
+        </p:txBody>
+      </p:sp>
+      <p:sp>
+        <p:nvSpPr>
+          <p:cNvPr id="22" name="Shape 16"/>
+          <p:cNvSpPr/>
+          <p:nvPr/>
+        </p:nvSpPr>
+        <p:spPr>
+          <a:xfrm>
+            <a:off x="8613648" y="4389120"/>
+            <a:ext cx="3072384" cy="493776"/>
           </a:xfrm>
           <a:prstGeom prst="roundRect">
             <a:avLst>
-              <a:gd name="adj" fmla="val 11765"/>
+              <a:gd name="adj" fmla="val 16667"/>
             </a:avLst>
           </a:prstGeom>
           <a:solidFill>
@@ -7040,14 +7023,14 @@
       </p:sp>
       <p:sp>
         <p:nvSpPr>
-          <p:cNvPr id="28" name="Text 23"/>
-          <p:cNvSpPr/>
-          <p:nvPr/>
-        </p:nvSpPr>
-        <p:spPr>
-          <a:xfrm>
-            <a:off x="8174736" y="3008376"/>
-            <a:ext cx="3328416" cy="219456"/>
+          <p:cNvPr id="23" name="Text 17"/>
+          <p:cNvSpPr/>
+          <p:nvPr/>
+        </p:nvSpPr>
+        <p:spPr>
+          <a:xfrm>
+            <a:off x="8814816" y="4453128"/>
+            <a:ext cx="2706624" cy="182880"/>
           </a:xfrm>
           <a:prstGeom prst="rect">
             <a:avLst/>
@@ -7063,7 +7046,7 @@
               <a:buNone/>
             </a:pPr>
             <a:r>
-              <a:rPr lang="en-US" sz="1100" b="1" spc="120" kern="0" dirty="0">
+              <a:rPr lang="en-US" sz="950" b="1" spc="100" kern="0" dirty="0">
                 <a:solidFill>
                   <a:srgbClr val="A4133C"/>
                 </a:solidFill>
@@ -7073,20 +7056,20 @@
               </a:rPr>
               <a:t>P WAVES</a:t>
             </a:r>
-            <a:endParaRPr lang="en-US" sz="1100" dirty="0"/>
-          </a:p>
-        </p:txBody>
-      </p:sp>
-      <p:sp>
-        <p:nvSpPr>
-          <p:cNvPr id="29" name="Text 24"/>
-          <p:cNvSpPr/>
-          <p:nvPr/>
-        </p:nvSpPr>
-        <p:spPr>
-          <a:xfrm>
-            <a:off x="8174736" y="3236976"/>
-            <a:ext cx="3328416" cy="384048"/>
+            <a:endParaRPr lang="en-US" sz="950" dirty="0"/>
+          </a:p>
+        </p:txBody>
+      </p:sp>
+      <p:sp>
+        <p:nvSpPr>
+          <p:cNvPr id="24" name="Text 18"/>
+          <p:cNvSpPr/>
+          <p:nvPr/>
+        </p:nvSpPr>
+        <p:spPr>
+          <a:xfrm>
+            <a:off x="8814816" y="4626864"/>
+            <a:ext cx="2706624" cy="237744"/>
           </a:xfrm>
           <a:prstGeom prst="rect">
             <a:avLst/>
@@ -7099,13 +7082,10 @@
           <a:lstStyle/>
           <a:p>
             <a:pPr algn="l" indent="0" marL="0">
-              <a:lnSpc>
-                <a:spcPct val="100000"/>
-              </a:lnSpc>
-              <a:buNone/>
-            </a:pPr>
-            <a:r>
-              <a:rPr lang="en-US" sz="1300" b="1" dirty="0">
+              <a:buNone/>
+            </a:pPr>
+            <a:r>
+              <a:rPr lang="en-US" sz="1250" b="1" dirty="0">
                 <a:solidFill>
                   <a:srgbClr val="2B2B33"/>
                 </a:solidFill>
@@ -7113,26 +7093,26 @@
                 <a:ea typeface="Calibri" pitchFamily="34" charset="-122"/>
                 <a:cs typeface="Calibri" pitchFamily="34" charset="-120"/>
               </a:rPr>
-              <a:t>Absent (no organised atrial activity)</a:t>
-            </a:r>
-            <a:endParaRPr lang="en-US" sz="1300" dirty="0"/>
-          </a:p>
-        </p:txBody>
-      </p:sp>
-      <p:sp>
-        <p:nvSpPr>
-          <p:cNvPr id="30" name="Shape 25"/>
-          <p:cNvSpPr/>
-          <p:nvPr/>
-        </p:nvSpPr>
-        <p:spPr>
-          <a:xfrm>
-            <a:off x="3977640" y="3808476"/>
-            <a:ext cx="3739896" cy="777240"/>
+              <a:t>Absent</a:t>
+            </a:r>
+            <a:endParaRPr lang="en-US" sz="1250" dirty="0"/>
+          </a:p>
+        </p:txBody>
+      </p:sp>
+      <p:sp>
+        <p:nvSpPr>
+          <p:cNvPr id="25" name="Shape 19"/>
+          <p:cNvSpPr/>
+          <p:nvPr/>
+        </p:nvSpPr>
+        <p:spPr>
+          <a:xfrm>
+            <a:off x="8613648" y="4937760"/>
+            <a:ext cx="3072384" cy="493776"/>
           </a:xfrm>
           <a:prstGeom prst="roundRect">
             <a:avLst>
-              <a:gd name="adj" fmla="val 11765"/>
+              <a:gd name="adj" fmla="val 16667"/>
             </a:avLst>
           </a:prstGeom>
           <a:solidFill>
@@ -7148,14 +7128,14 @@
       </p:sp>
       <p:sp>
         <p:nvSpPr>
-          <p:cNvPr id="31" name="Text 26"/>
-          <p:cNvSpPr/>
-          <p:nvPr/>
-        </p:nvSpPr>
-        <p:spPr>
-          <a:xfrm>
-            <a:off x="4206240" y="3927348"/>
-            <a:ext cx="3328416" cy="219456"/>
+          <p:cNvPr id="26" name="Text 20"/>
+          <p:cNvSpPr/>
+          <p:nvPr/>
+        </p:nvSpPr>
+        <p:spPr>
+          <a:xfrm>
+            <a:off x="8814816" y="5001768"/>
+            <a:ext cx="2706624" cy="182880"/>
           </a:xfrm>
           <a:prstGeom prst="rect">
             <a:avLst/>
@@ -7171,7 +7151,7 @@
               <a:buNone/>
             </a:pPr>
             <a:r>
-              <a:rPr lang="en-US" sz="1100" b="1" spc="120" kern="0" dirty="0">
+              <a:rPr lang="en-US" sz="950" b="1" spc="100" kern="0" dirty="0">
                 <a:solidFill>
                   <a:srgbClr val="A4133C"/>
                 </a:solidFill>
@@ -7179,22 +7159,22 @@
                 <a:ea typeface="Calibri" pitchFamily="34" charset="-122"/>
                 <a:cs typeface="Calibri" pitchFamily="34" charset="-120"/>
               </a:rPr>
-              <a:t>PR INTERVAL</a:t>
-            </a:r>
-            <a:endParaRPr lang="en-US" sz="1100" dirty="0"/>
-          </a:p>
-        </p:txBody>
-      </p:sp>
-      <p:sp>
-        <p:nvSpPr>
-          <p:cNvPr id="32" name="Text 27"/>
-          <p:cNvSpPr/>
-          <p:nvPr/>
-        </p:nvSpPr>
-        <p:spPr>
-          <a:xfrm>
-            <a:off x="4206240" y="4155948"/>
-            <a:ext cx="3328416" cy="384048"/>
+              <a:t>PR · QRS</a:t>
+            </a:r>
+            <a:endParaRPr lang="en-US" sz="950" dirty="0"/>
+          </a:p>
+        </p:txBody>
+      </p:sp>
+      <p:sp>
+        <p:nvSpPr>
+          <p:cNvPr id="27" name="Text 21"/>
+          <p:cNvSpPr/>
+          <p:nvPr/>
+        </p:nvSpPr>
+        <p:spPr>
+          <a:xfrm>
+            <a:off x="8814816" y="5175504"/>
+            <a:ext cx="2706624" cy="237744"/>
           </a:xfrm>
           <a:prstGeom prst="rect">
             <a:avLst/>
@@ -7207,13 +7187,10 @@
           <a:lstStyle/>
           <a:p>
             <a:pPr algn="l" indent="0" marL="0">
-              <a:lnSpc>
-                <a:spcPct val="100000"/>
-              </a:lnSpc>
-              <a:buNone/>
-            </a:pPr>
-            <a:r>
-              <a:rPr lang="en-US" sz="1300" b="1" dirty="0">
+              <a:buNone/>
+            </a:pPr>
+            <a:r>
+              <a:rPr lang="en-US" sz="1250" b="1" dirty="0">
                 <a:solidFill>
                   <a:srgbClr val="2B2B33"/>
                 </a:solidFill>
@@ -7221,26 +7198,26 @@
                 <a:ea typeface="Calibri" pitchFamily="34" charset="-122"/>
                 <a:cs typeface="Calibri" pitchFamily="34" charset="-120"/>
               </a:rPr>
-              <a:t>Not measurable</a:t>
-            </a:r>
-            <a:endParaRPr lang="en-US" sz="1300" dirty="0"/>
-          </a:p>
-        </p:txBody>
-      </p:sp>
-      <p:sp>
-        <p:nvSpPr>
-          <p:cNvPr id="33" name="Shape 28"/>
-          <p:cNvSpPr/>
-          <p:nvPr/>
-        </p:nvSpPr>
-        <p:spPr>
-          <a:xfrm>
-            <a:off x="7946136" y="3808476"/>
-            <a:ext cx="3739896" cy="777240"/>
+              <a:t>Not measurable · 80 ms</a:t>
+            </a:r>
+            <a:endParaRPr lang="en-US" sz="1250" dirty="0"/>
+          </a:p>
+        </p:txBody>
+      </p:sp>
+      <p:sp>
+        <p:nvSpPr>
+          <p:cNvPr id="28" name="Shape 22"/>
+          <p:cNvSpPr/>
+          <p:nvPr/>
+        </p:nvSpPr>
+        <p:spPr>
+          <a:xfrm>
+            <a:off x="8613648" y="5486400"/>
+            <a:ext cx="3072384" cy="493776"/>
           </a:xfrm>
           <a:prstGeom prst="roundRect">
             <a:avLst>
-              <a:gd name="adj" fmla="val 11765"/>
+              <a:gd name="adj" fmla="val 16667"/>
             </a:avLst>
           </a:prstGeom>
           <a:solidFill>
@@ -7256,14 +7233,14 @@
       </p:sp>
       <p:sp>
         <p:nvSpPr>
-          <p:cNvPr id="34" name="Text 29"/>
-          <p:cNvSpPr/>
-          <p:nvPr/>
-        </p:nvSpPr>
-        <p:spPr>
-          <a:xfrm>
-            <a:off x="8174736" y="3927348"/>
-            <a:ext cx="3328416" cy="219456"/>
+          <p:cNvPr id="29" name="Text 23"/>
+          <p:cNvSpPr/>
+          <p:nvPr/>
+        </p:nvSpPr>
+        <p:spPr>
+          <a:xfrm>
+            <a:off x="8814816" y="5550408"/>
+            <a:ext cx="2706624" cy="182880"/>
           </a:xfrm>
           <a:prstGeom prst="rect">
             <a:avLst/>
@@ -7279,7 +7256,7 @@
               <a:buNone/>
             </a:pPr>
             <a:r>
-              <a:rPr lang="en-US" sz="1100" b="1" spc="120" kern="0" dirty="0">
+              <a:rPr lang="en-US" sz="950" b="1" spc="100" kern="0" dirty="0">
                 <a:solidFill>
                   <a:srgbClr val="A4133C"/>
                 </a:solidFill>
@@ -7287,22 +7264,22 @@
                 <a:ea typeface="Calibri" pitchFamily="34" charset="-122"/>
                 <a:cs typeface="Calibri" pitchFamily="34" charset="-120"/>
               </a:rPr>
-              <a:t>QRS DURATION</a:t>
-            </a:r>
-            <a:endParaRPr lang="en-US" sz="1100" dirty="0"/>
-          </a:p>
-        </p:txBody>
-      </p:sp>
-      <p:sp>
-        <p:nvSpPr>
-          <p:cNvPr id="35" name="Text 30"/>
-          <p:cNvSpPr/>
-          <p:nvPr/>
-        </p:nvSpPr>
-        <p:spPr>
-          <a:xfrm>
-            <a:off x="8174736" y="4155948"/>
-            <a:ext cx="3328416" cy="384048"/>
+              <a:t>QTC · AXIS</a:t>
+            </a:r>
+            <a:endParaRPr lang="en-US" sz="950" dirty="0"/>
+          </a:p>
+        </p:txBody>
+      </p:sp>
+      <p:sp>
+        <p:nvSpPr>
+          <p:cNvPr id="30" name="Text 24"/>
+          <p:cNvSpPr/>
+          <p:nvPr/>
+        </p:nvSpPr>
+        <p:spPr>
+          <a:xfrm>
+            <a:off x="8814816" y="5724144"/>
+            <a:ext cx="2706624" cy="237744"/>
           </a:xfrm>
           <a:prstGeom prst="rect">
             <a:avLst/>
@@ -7315,13 +7292,10 @@
           <a:lstStyle/>
           <a:p>
             <a:pPr algn="l" indent="0" marL="0">
-              <a:lnSpc>
-                <a:spcPct val="100000"/>
-              </a:lnSpc>
-              <a:buNone/>
-            </a:pPr>
-            <a:r>
-              <a:rPr lang="en-US" sz="1300" b="1" dirty="0">
+              <a:buNone/>
+            </a:pPr>
+            <a:r>
+              <a:rPr lang="en-US" sz="1250" b="1" dirty="0">
                 <a:solidFill>
                   <a:srgbClr val="2B2B33"/>
                 </a:solidFill>
@@ -7329,338 +7303,15 @@
                 <a:ea typeface="Calibri" pitchFamily="34" charset="-122"/>
                 <a:cs typeface="Calibri" pitchFamily="34" charset="-120"/>
               </a:rPr>
-              <a:t>80 ms</a:t>
-            </a:r>
-            <a:pPr algn="l" indent="0" marL="0">
-              <a:lnSpc>
-                <a:spcPct val="100000"/>
-              </a:lnSpc>
-              <a:buNone/>
-            </a:pPr>
-            <a:r>
-              <a:rPr lang="en-US" sz="1100" b="1" dirty="0">
-                <a:solidFill>
-                  <a:srgbClr val="2E7D32"/>
-                </a:solidFill>
-                <a:latin typeface="Calibri" pitchFamily="34" charset="0"/>
-                <a:ea typeface="Calibri" pitchFamily="34" charset="-122"/>
-                <a:cs typeface="Calibri" pitchFamily="34" charset="-120"/>
-              </a:rPr>
-              <a:t>   normal</a:t>
-            </a:r>
-            <a:endParaRPr lang="en-US" sz="1300" dirty="0"/>
-          </a:p>
-        </p:txBody>
-      </p:sp>
-      <p:sp>
-        <p:nvSpPr>
-          <p:cNvPr id="36" name="Shape 31"/>
-          <p:cNvSpPr/>
-          <p:nvPr/>
-        </p:nvSpPr>
-        <p:spPr>
-          <a:xfrm>
-            <a:off x="3977640" y="4727448"/>
-            <a:ext cx="3739896" cy="777240"/>
-          </a:xfrm>
-          <a:prstGeom prst="roundRect">
-            <a:avLst>
-              <a:gd name="adj" fmla="val 11765"/>
-            </a:avLst>
-          </a:prstGeom>
-          <a:solidFill>
-            <a:srgbClr val="FFF0F3"/>
-          </a:solidFill>
-          <a:ln w="12700">
-            <a:solidFill>
-              <a:srgbClr val="FBD8DF"/>
-            </a:solidFill>
-            <a:prstDash val="solid"/>
-          </a:ln>
-        </p:spPr>
-      </p:sp>
-      <p:sp>
-        <p:nvSpPr>
-          <p:cNvPr id="37" name="Text 32"/>
-          <p:cNvSpPr/>
-          <p:nvPr/>
-        </p:nvSpPr>
-        <p:spPr>
-          <a:xfrm>
-            <a:off x="4206240" y="4846320"/>
-            <a:ext cx="3328416" cy="219456"/>
-          </a:xfrm>
-          <a:prstGeom prst="rect">
-            <a:avLst/>
-          </a:prstGeom>
-          <a:noFill/>
-          <a:ln/>
-        </p:spPr>
-        <p:txBody>
-          <a:bodyPr wrap="square" lIns="0" tIns="0" rIns="0" bIns="0" rtlCol="0" anchor="t"/>
-          <a:lstStyle/>
-          <a:p>
-            <a:pPr algn="l" indent="0" marL="0">
-              <a:buNone/>
-            </a:pPr>
-            <a:r>
-              <a:rPr lang="en-US" sz="1100" b="1" spc="120" kern="0" dirty="0">
-                <a:solidFill>
-                  <a:srgbClr val="A4133C"/>
-                </a:solidFill>
-                <a:latin typeface="Calibri" pitchFamily="34" charset="0"/>
-                <a:ea typeface="Calibri" pitchFamily="34" charset="-122"/>
-                <a:cs typeface="Calibri" pitchFamily="34" charset="-120"/>
-              </a:rPr>
-              <a:t>QT / QTC</a:t>
-            </a:r>
-            <a:endParaRPr lang="en-US" sz="1100" dirty="0"/>
-          </a:p>
-        </p:txBody>
-      </p:sp>
-      <p:sp>
-        <p:nvSpPr>
-          <p:cNvPr id="38" name="Text 33"/>
-          <p:cNvSpPr/>
-          <p:nvPr/>
-        </p:nvSpPr>
-        <p:spPr>
-          <a:xfrm>
-            <a:off x="4206240" y="5074920"/>
-            <a:ext cx="3328416" cy="384048"/>
-          </a:xfrm>
-          <a:prstGeom prst="rect">
-            <a:avLst/>
-          </a:prstGeom>
-          <a:noFill/>
-          <a:ln/>
-        </p:spPr>
-        <p:txBody>
-          <a:bodyPr wrap="square" lIns="0" tIns="0" rIns="0" bIns="0" rtlCol="0" anchor="t"/>
-          <a:lstStyle/>
-          <a:p>
-            <a:pPr algn="l" indent="0" marL="0">
-              <a:lnSpc>
-                <a:spcPct val="100000"/>
-              </a:lnSpc>
-              <a:buNone/>
-            </a:pPr>
-            <a:r>
-              <a:rPr lang="en-US" sz="1300" b="1" dirty="0">
-                <a:solidFill>
-                  <a:srgbClr val="2B2B33"/>
-                </a:solidFill>
-                <a:latin typeface="Calibri" pitchFamily="34" charset="0"/>
-                <a:ea typeface="Calibri" pitchFamily="34" charset="-122"/>
-                <a:cs typeface="Calibri" pitchFamily="34" charset="-120"/>
-              </a:rPr>
-              <a:t>298 / 382 ms</a:t>
-            </a:r>
-            <a:endParaRPr lang="en-US" sz="1300" dirty="0"/>
-          </a:p>
-        </p:txBody>
-      </p:sp>
-      <p:sp>
-        <p:nvSpPr>
-          <p:cNvPr id="39" name="Shape 34"/>
-          <p:cNvSpPr/>
-          <p:nvPr/>
-        </p:nvSpPr>
-        <p:spPr>
-          <a:xfrm>
-            <a:off x="7946136" y="4727448"/>
-            <a:ext cx="3739896" cy="777240"/>
-          </a:xfrm>
-          <a:prstGeom prst="roundRect">
-            <a:avLst>
-              <a:gd name="adj" fmla="val 11765"/>
-            </a:avLst>
-          </a:prstGeom>
-          <a:solidFill>
-            <a:srgbClr val="FFF0F3"/>
-          </a:solidFill>
-          <a:ln w="12700">
-            <a:solidFill>
-              <a:srgbClr val="FBD8DF"/>
-            </a:solidFill>
-            <a:prstDash val="solid"/>
-          </a:ln>
-        </p:spPr>
-      </p:sp>
-      <p:sp>
-        <p:nvSpPr>
-          <p:cNvPr id="40" name="Text 35"/>
-          <p:cNvSpPr/>
-          <p:nvPr/>
-        </p:nvSpPr>
-        <p:spPr>
-          <a:xfrm>
-            <a:off x="8174736" y="4846320"/>
-            <a:ext cx="3328416" cy="219456"/>
-          </a:xfrm>
-          <a:prstGeom prst="rect">
-            <a:avLst/>
-          </a:prstGeom>
-          <a:noFill/>
-          <a:ln/>
-        </p:spPr>
-        <p:txBody>
-          <a:bodyPr wrap="square" lIns="0" tIns="0" rIns="0" bIns="0" rtlCol="0" anchor="t"/>
-          <a:lstStyle/>
-          <a:p>
-            <a:pPr algn="l" indent="0" marL="0">
-              <a:buNone/>
-            </a:pPr>
-            <a:r>
-              <a:rPr lang="en-US" sz="1100" b="1" spc="120" kern="0" dirty="0">
-                <a:solidFill>
-                  <a:srgbClr val="A4133C"/>
-                </a:solidFill>
-                <a:latin typeface="Calibri" pitchFamily="34" charset="0"/>
-                <a:ea typeface="Calibri" pitchFamily="34" charset="-122"/>
-                <a:cs typeface="Calibri" pitchFamily="34" charset="-120"/>
-              </a:rPr>
-              <a:t>QRS AXIS</a:t>
-            </a:r>
-            <a:endParaRPr lang="en-US" sz="1100" dirty="0"/>
-          </a:p>
-        </p:txBody>
-      </p:sp>
-      <p:sp>
-        <p:nvSpPr>
-          <p:cNvPr id="41" name="Text 36"/>
-          <p:cNvSpPr/>
-          <p:nvPr/>
-        </p:nvSpPr>
-        <p:spPr>
-          <a:xfrm>
-            <a:off x="8174736" y="5074920"/>
-            <a:ext cx="3328416" cy="384048"/>
-          </a:xfrm>
-          <a:prstGeom prst="rect">
-            <a:avLst/>
-          </a:prstGeom>
-          <a:noFill/>
-          <a:ln/>
-        </p:spPr>
-        <p:txBody>
-          <a:bodyPr wrap="square" lIns="0" tIns="0" rIns="0" bIns="0" rtlCol="0" anchor="t"/>
-          <a:lstStyle/>
-          <a:p>
-            <a:pPr algn="l" indent="0" marL="0">
-              <a:lnSpc>
-                <a:spcPct val="100000"/>
-              </a:lnSpc>
-              <a:buNone/>
-            </a:pPr>
-            <a:r>
-              <a:rPr lang="en-US" sz="1300" b="1" dirty="0">
-                <a:solidFill>
-                  <a:srgbClr val="2B2B33"/>
-                </a:solidFill>
-                <a:latin typeface="Calibri" pitchFamily="34" charset="0"/>
-                <a:ea typeface="Calibri" pitchFamily="34" charset="-122"/>
-                <a:cs typeface="Calibri" pitchFamily="34" charset="-120"/>
-              </a:rPr>
-              <a:t>38°</a:t>
-            </a:r>
-            <a:endParaRPr lang="en-US" sz="1300" dirty="0"/>
-          </a:p>
-        </p:txBody>
-      </p:sp>
-      <p:sp>
-        <p:nvSpPr>
-          <p:cNvPr id="42" name="Shape 37"/>
-          <p:cNvSpPr/>
-          <p:nvPr/>
-        </p:nvSpPr>
-        <p:spPr>
-          <a:xfrm>
-            <a:off x="502920" y="5687568"/>
-            <a:ext cx="11183112" cy="457200"/>
-          </a:xfrm>
-          <a:prstGeom prst="roundRect">
-            <a:avLst>
-              <a:gd name="adj" fmla="val 20000"/>
-            </a:avLst>
-          </a:prstGeom>
-          <a:solidFill>
-            <a:srgbClr val="FFFFFF"/>
-          </a:solidFill>
-          <a:ln w="12700">
-            <a:solidFill>
-              <a:srgbClr val="FBD8DF"/>
-            </a:solidFill>
-            <a:prstDash val="solid"/>
-          </a:ln>
-        </p:spPr>
-      </p:sp>
-      <p:pic>
-        <p:nvPicPr>
-          <p:cNvPr id="43" name="Image 3" descr="preencoded.png">    </p:cNvPr>
-          <p:cNvPicPr>
-            <a:picLocks noChangeAspect="1"/>
-          </p:cNvPicPr>
-          <p:nvPr/>
-        </p:nvPicPr>
-        <p:blipFill>
-          <a:blip r:embed="rId4"/>
-          <a:stretch>
-            <a:fillRect/>
-          </a:stretch>
-        </p:blipFill>
-        <p:spPr>
-          <a:xfrm>
-            <a:off x="749808" y="5797296"/>
-            <a:ext cx="237744" cy="237744"/>
-          </a:xfrm>
-          <a:prstGeom prst="rect">
-            <a:avLst/>
-          </a:prstGeom>
-        </p:spPr>
-      </p:pic>
-      <p:sp>
-        <p:nvSpPr>
-          <p:cNvPr id="44" name="Text 38"/>
-          <p:cNvSpPr/>
-          <p:nvPr/>
-        </p:nvSpPr>
-        <p:spPr>
-          <a:xfrm>
-            <a:off x="1097280" y="5687568"/>
-            <a:ext cx="10332720" cy="457200"/>
-          </a:xfrm>
-          <a:prstGeom prst="rect">
-            <a:avLst/>
-          </a:prstGeom>
-          <a:noFill/>
-          <a:ln/>
-        </p:spPr>
-        <p:txBody>
-          <a:bodyPr wrap="square" lIns="0" tIns="0" rIns="0" bIns="0" rtlCol="0" anchor="ctr"/>
-          <a:lstStyle/>
-          <a:p>
-            <a:pPr algn="l" indent="0" marL="0">
-              <a:buNone/>
-            </a:pPr>
-            <a:r>
-              <a:rPr lang="en-US" sz="1350" i="1" dirty="0">
-                <a:solidFill>
-                  <a:srgbClr val="2B2B33"/>
-                </a:solidFill>
-                <a:latin typeface="Calibri" pitchFamily="34" charset="0"/>
-                <a:ea typeface="Calibri" pitchFamily="34" charset="-122"/>
-                <a:cs typeface="Calibri" pitchFamily="34" charset="-120"/>
-              </a:rPr>
-              <a:t>Confirms atrial fibrillation with a fast ventricular rate.</a:t>
-            </a:r>
-            <a:endParaRPr lang="en-US" sz="1350" dirty="0"/>
-          </a:p>
-        </p:txBody>
-      </p:sp>
-      <p:sp>
-        <p:nvSpPr>
-          <p:cNvPr id="45" name="Text 39"/>
+              <a:t>382 ms · 38°</a:t>
+            </a:r>
+            <a:endParaRPr lang="en-US" sz="1250" dirty="0"/>
+          </a:p>
+        </p:txBody>
+      </p:sp>
+      <p:sp>
+        <p:nvSpPr>
+          <p:cNvPr id="31" name="Text 25"/>
           <p:cNvSpPr/>
           <p:nvPr/>
         </p:nvSpPr>
@@ -7699,7 +7350,7 @@
       </p:sp>
       <p:sp>
         <p:nvSpPr>
-          <p:cNvPr id="46" name="Text 40"/>
+          <p:cNvPr id="32" name="Text 26"/>
           <p:cNvSpPr/>
           <p:nvPr/>
         </p:nvSpPr>
@@ -14826,6 +14477,1387 @@
     <p:bg>
       <p:bgPr>
         <a:solidFill>
+          <a:srgbClr val="FFFFFF"/>
+        </a:solidFill>
+      </p:bgPr>
+    </p:bg>
+    <p:spTree>
+      <p:nvGrpSpPr>
+        <p:cNvPr id="1" name=""/>
+        <p:cNvGrpSpPr/>
+        <p:nvPr/>
+      </p:nvGrpSpPr>
+      <p:grpSpPr>
+        <a:xfrm>
+          <a:off x="0" y="0"/>
+          <a:ext cx="0" cy="0"/>
+          <a:chOff x="0" y="0"/>
+          <a:chExt cx="0" cy="0"/>
+        </a:xfrm>
+      </p:grpSpPr>
+      <p:sp>
+        <p:nvSpPr>
+          <p:cNvPr id="2" name="Shape 0"/>
+          <p:cNvSpPr/>
+          <p:nvPr/>
+        </p:nvSpPr>
+        <p:spPr>
+          <a:xfrm>
+            <a:off x="502920" y="457200"/>
+            <a:ext cx="868680" cy="868680"/>
+          </a:xfrm>
+          <a:prstGeom prst="ellipse">
+            <a:avLst/>
+          </a:prstGeom>
+          <a:solidFill>
+            <a:srgbClr val="FFF0F3"/>
+          </a:solidFill>
+          <a:ln w="12700">
+            <a:solidFill>
+              <a:srgbClr val="FBD8DF"/>
+            </a:solidFill>
+            <a:prstDash val="solid"/>
+          </a:ln>
+        </p:spPr>
+      </p:sp>
+      <p:pic>
+        <p:nvPicPr>
+          <p:cNvPr id="3" name="Image 0" descr="preencoded.png">    </p:cNvPr>
+          <p:cNvPicPr>
+            <a:picLocks noChangeAspect="1"/>
+          </p:cNvPicPr>
+          <p:nvPr/>
+        </p:nvPicPr>
+        <p:blipFill>
+          <a:blip r:embed="rId1"/>
+          <a:stretch>
+            <a:fillRect/>
+          </a:stretch>
+        </p:blipFill>
+        <p:spPr>
+          <a:xfrm>
+            <a:off x="694944" y="649224"/>
+            <a:ext cx="484632" cy="484632"/>
+          </a:xfrm>
+          <a:prstGeom prst="rect">
+            <a:avLst/>
+          </a:prstGeom>
+        </p:spPr>
+      </p:pic>
+      <p:sp>
+        <p:nvSpPr>
+          <p:cNvPr id="4" name="Text 1"/>
+          <p:cNvSpPr/>
+          <p:nvPr/>
+        </p:nvSpPr>
+        <p:spPr>
+          <a:xfrm>
+            <a:off x="1572768" y="502920"/>
+            <a:ext cx="9601200" cy="274320"/>
+          </a:xfrm>
+          <a:prstGeom prst="rect">
+            <a:avLst/>
+          </a:prstGeom>
+          <a:noFill/>
+          <a:ln/>
+        </p:spPr>
+        <p:txBody>
+          <a:bodyPr wrap="square" rtlCol="0" anchor="t"/>
+          <a:lstStyle/>
+          <a:p>
+            <a:pPr algn="l" indent="0" marL="0">
+              <a:buNone/>
+            </a:pPr>
+            <a:r>
+              <a:rPr lang="en-US" sz="1250" b="1" spc="200" kern="0" dirty="0">
+                <a:solidFill>
+                  <a:srgbClr val="A4133C"/>
+                </a:solidFill>
+                <a:latin typeface="Calibri" pitchFamily="34" charset="0"/>
+                <a:ea typeface="Calibri" pitchFamily="34" charset="-122"/>
+                <a:cs typeface="Calibri" pitchFamily="34" charset="-120"/>
+              </a:rPr>
+              <a:t>CASE DISCUSSION</a:t>
+            </a:r>
+            <a:endParaRPr lang="en-US" sz="1250" dirty="0"/>
+          </a:p>
+        </p:txBody>
+      </p:sp>
+      <p:sp>
+        <p:nvSpPr>
+          <p:cNvPr id="5" name="Text 2"/>
+          <p:cNvSpPr/>
+          <p:nvPr/>
+        </p:nvSpPr>
+        <p:spPr>
+          <a:xfrm>
+            <a:off x="1554480" y="749808"/>
+            <a:ext cx="10058400" cy="640080"/>
+          </a:xfrm>
+          <a:prstGeom prst="rect">
+            <a:avLst/>
+          </a:prstGeom>
+          <a:noFill/>
+          <a:ln/>
+        </p:spPr>
+        <p:txBody>
+          <a:bodyPr wrap="square" rtlCol="0" anchor="t"/>
+          <a:lstStyle/>
+          <a:p>
+            <a:pPr algn="l" indent="0" marL="0">
+              <a:buNone/>
+            </a:pPr>
+            <a:r>
+              <a:rPr lang="en-US" sz="3000" b="1" dirty="0">
+                <a:solidFill>
+                  <a:srgbClr val="2B2B33"/>
+                </a:solidFill>
+                <a:latin typeface="Cambria" pitchFamily="34" charset="0"/>
+                <a:ea typeface="Cambria" pitchFamily="34" charset="-122"/>
+                <a:cs typeface="Cambria" pitchFamily="34" charset="-120"/>
+              </a:rPr>
+              <a:t>Differential &amp; Final Diagnosis</a:t>
+            </a:r>
+            <a:endParaRPr lang="en-US" sz="3000" dirty="0"/>
+          </a:p>
+        </p:txBody>
+      </p:sp>
+      <p:sp>
+        <p:nvSpPr>
+          <p:cNvPr id="6" name="Shape 3"/>
+          <p:cNvSpPr/>
+          <p:nvPr/>
+        </p:nvSpPr>
+        <p:spPr>
+          <a:xfrm>
+            <a:off x="502920" y="1783080"/>
+            <a:ext cx="6355080" cy="4206240"/>
+          </a:xfrm>
+          <a:prstGeom prst="roundRect">
+            <a:avLst>
+              <a:gd name="adj" fmla="val 2609"/>
+            </a:avLst>
+          </a:prstGeom>
+          <a:solidFill>
+            <a:srgbClr val="FFF0F3"/>
+          </a:solidFill>
+          <a:ln w="12700">
+            <a:solidFill>
+              <a:srgbClr val="FBD8DF"/>
+            </a:solidFill>
+            <a:prstDash val="solid"/>
+          </a:ln>
+          <a:effectLst>
+            <a:outerShdw sx="100000" sy="100000" kx="0" ky="0" algn="bl" rotWithShape="0" blurRad="127000" dist="50800" dir="5400000">
+              <a:srgbClr val="C9A3AC">
+                <a:alpha val="45000"/>
+              </a:srgbClr>
+            </a:outerShdw>
+          </a:effectLst>
+        </p:spPr>
+      </p:sp>
+      <p:sp>
+        <p:nvSpPr>
+          <p:cNvPr id="7" name="Text 4"/>
+          <p:cNvSpPr/>
+          <p:nvPr/>
+        </p:nvSpPr>
+        <p:spPr>
+          <a:xfrm>
+            <a:off x="822960" y="2029968"/>
+            <a:ext cx="5669280" cy="274320"/>
+          </a:xfrm>
+          <a:prstGeom prst="rect">
+            <a:avLst/>
+          </a:prstGeom>
+          <a:noFill/>
+          <a:ln/>
+        </p:spPr>
+        <p:txBody>
+          <a:bodyPr wrap="square" rtlCol="0" anchor="t"/>
+          <a:lstStyle/>
+          <a:p>
+            <a:pPr algn="l" indent="0" marL="0">
+              <a:buNone/>
+            </a:pPr>
+            <a:r>
+              <a:rPr lang="en-US" sz="1250" b="1" spc="150" kern="0" dirty="0">
+                <a:solidFill>
+                  <a:srgbClr val="A4133C"/>
+                </a:solidFill>
+                <a:latin typeface="Calibri" pitchFamily="34" charset="0"/>
+                <a:ea typeface="Calibri" pitchFamily="34" charset="-122"/>
+                <a:cs typeface="Calibri" pitchFamily="34" charset="-120"/>
+              </a:rPr>
+              <a:t>DIFFERENTIALS CONSIDERED</a:t>
+            </a:r>
+            <a:endParaRPr lang="en-US" sz="1250" dirty="0"/>
+          </a:p>
+        </p:txBody>
+      </p:sp>
+      <p:sp>
+        <p:nvSpPr>
+          <p:cNvPr id="8" name="Text 5"/>
+          <p:cNvSpPr/>
+          <p:nvPr/>
+        </p:nvSpPr>
+        <p:spPr>
+          <a:xfrm>
+            <a:off x="822960" y="2304288"/>
+            <a:ext cx="5669280" cy="274320"/>
+          </a:xfrm>
+          <a:prstGeom prst="rect">
+            <a:avLst/>
+          </a:prstGeom>
+          <a:noFill/>
+          <a:ln/>
+        </p:spPr>
+        <p:txBody>
+          <a:bodyPr wrap="square" rtlCol="0" anchor="t"/>
+          <a:lstStyle/>
+          <a:p>
+            <a:pPr algn="l" indent="0" marL="0">
+              <a:buNone/>
+            </a:pPr>
+            <a:r>
+              <a:rPr lang="en-US" sz="1250" i="1" dirty="0">
+                <a:solidFill>
+                  <a:srgbClr val="6B6B76"/>
+                </a:solidFill>
+                <a:latin typeface="Calibri" pitchFamily="34" charset="0"/>
+                <a:ea typeface="Calibri" pitchFamily="34" charset="-122"/>
+                <a:cs typeface="Calibri" pitchFamily="34" charset="-120"/>
+              </a:rPr>
+              <a:t>Causes of an irregular tachycardia</a:t>
+            </a:r>
+            <a:endParaRPr lang="en-US" sz="1250" dirty="0"/>
+          </a:p>
+        </p:txBody>
+      </p:sp>
+      <p:sp>
+        <p:nvSpPr>
+          <p:cNvPr id="9" name="Shape 6"/>
+          <p:cNvSpPr/>
+          <p:nvPr/>
+        </p:nvSpPr>
+        <p:spPr>
+          <a:xfrm>
+            <a:off x="868680" y="2779776"/>
+            <a:ext cx="384048" cy="384048"/>
+          </a:xfrm>
+          <a:prstGeom prst="ellipse">
+            <a:avLst/>
+          </a:prstGeom>
+          <a:solidFill>
+            <a:srgbClr val="FFFFFF"/>
+          </a:solidFill>
+          <a:ln w="12700">
+            <a:solidFill>
+              <a:srgbClr val="FBD8DF"/>
+            </a:solidFill>
+            <a:prstDash val="solid"/>
+          </a:ln>
+        </p:spPr>
+      </p:sp>
+      <p:pic>
+        <p:nvPicPr>
+          <p:cNvPr id="10" name="Image 1" descr="preencoded.png">    </p:cNvPr>
+          <p:cNvPicPr>
+            <a:picLocks noChangeAspect="1"/>
+          </p:cNvPicPr>
+          <p:nvPr/>
+        </p:nvPicPr>
+        <p:blipFill>
+          <a:blip r:embed="rId2"/>
+          <a:stretch>
+            <a:fillRect/>
+          </a:stretch>
+        </p:blipFill>
+        <p:spPr>
+          <a:xfrm>
+            <a:off x="941832" y="2852928"/>
+            <a:ext cx="237744" cy="237744"/>
+          </a:xfrm>
+          <a:prstGeom prst="rect">
+            <a:avLst/>
+          </a:prstGeom>
+        </p:spPr>
+      </p:pic>
+      <p:sp>
+        <p:nvSpPr>
+          <p:cNvPr id="11" name="Text 7"/>
+          <p:cNvSpPr/>
+          <p:nvPr/>
+        </p:nvSpPr>
+        <p:spPr>
+          <a:xfrm>
+            <a:off x="1417320" y="2706624"/>
+            <a:ext cx="5212080" cy="292608"/>
+          </a:xfrm>
+          <a:prstGeom prst="rect">
+            <a:avLst/>
+          </a:prstGeom>
+          <a:noFill/>
+          <a:ln/>
+        </p:spPr>
+        <p:txBody>
+          <a:bodyPr wrap="square" lIns="0" tIns="0" rIns="0" bIns="0" rtlCol="0" anchor="t"/>
+          <a:lstStyle/>
+          <a:p>
+            <a:pPr algn="l" indent="0" marL="0">
+              <a:buNone/>
+            </a:pPr>
+            <a:r>
+              <a:rPr lang="en-US" sz="1550" b="1" dirty="0">
+                <a:solidFill>
+                  <a:srgbClr val="2B2B33"/>
+                </a:solidFill>
+                <a:latin typeface="Cambria" pitchFamily="34" charset="0"/>
+                <a:ea typeface="Cambria" pitchFamily="34" charset="-122"/>
+                <a:cs typeface="Cambria" pitchFamily="34" charset="-120"/>
+              </a:rPr>
+              <a:t>Atrial flutter</a:t>
+            </a:r>
+            <a:endParaRPr lang="en-US" sz="1550" dirty="0"/>
+          </a:p>
+        </p:txBody>
+      </p:sp>
+      <p:sp>
+        <p:nvSpPr>
+          <p:cNvPr id="12" name="Text 8"/>
+          <p:cNvSpPr/>
+          <p:nvPr/>
+        </p:nvSpPr>
+        <p:spPr>
+          <a:xfrm>
+            <a:off x="1417320" y="2999232"/>
+            <a:ext cx="5257800" cy="274320"/>
+          </a:xfrm>
+          <a:prstGeom prst="rect">
+            <a:avLst/>
+          </a:prstGeom>
+          <a:noFill/>
+          <a:ln/>
+        </p:spPr>
+        <p:txBody>
+          <a:bodyPr wrap="square" lIns="0" tIns="0" rIns="0" bIns="0" rtlCol="0" anchor="t"/>
+          <a:lstStyle/>
+          <a:p>
+            <a:pPr algn="l" indent="0" marL="0">
+              <a:buNone/>
+            </a:pPr>
+            <a:r>
+              <a:rPr lang="en-US" sz="1200" dirty="0">
+                <a:solidFill>
+                  <a:srgbClr val="6B6B76"/>
+                </a:solidFill>
+                <a:latin typeface="Calibri" pitchFamily="34" charset="0"/>
+                <a:ea typeface="Calibri" pitchFamily="34" charset="-122"/>
+                <a:cs typeface="Calibri" pitchFamily="34" charset="-120"/>
+              </a:rPr>
+              <a:t>No sawtooth flutter waves; R–R irregular</a:t>
+            </a:r>
+            <a:endParaRPr lang="en-US" sz="1200" dirty="0"/>
+          </a:p>
+        </p:txBody>
+      </p:sp>
+      <p:sp>
+        <p:nvSpPr>
+          <p:cNvPr id="13" name="Shape 9"/>
+          <p:cNvSpPr/>
+          <p:nvPr/>
+        </p:nvSpPr>
+        <p:spPr>
+          <a:xfrm>
+            <a:off x="868680" y="3401568"/>
+            <a:ext cx="384048" cy="384048"/>
+          </a:xfrm>
+          <a:prstGeom prst="ellipse">
+            <a:avLst/>
+          </a:prstGeom>
+          <a:solidFill>
+            <a:srgbClr val="FFFFFF"/>
+          </a:solidFill>
+          <a:ln w="12700">
+            <a:solidFill>
+              <a:srgbClr val="FBD8DF"/>
+            </a:solidFill>
+            <a:prstDash val="solid"/>
+          </a:ln>
+        </p:spPr>
+      </p:sp>
+      <p:pic>
+        <p:nvPicPr>
+          <p:cNvPr id="14" name="Image 2" descr="preencoded.png">    </p:cNvPr>
+          <p:cNvPicPr>
+            <a:picLocks noChangeAspect="1"/>
+          </p:cNvPicPr>
+          <p:nvPr/>
+        </p:nvPicPr>
+        <p:blipFill>
+          <a:blip r:embed="rId3"/>
+          <a:stretch>
+            <a:fillRect/>
+          </a:stretch>
+        </p:blipFill>
+        <p:spPr>
+          <a:xfrm>
+            <a:off x="941832" y="3474720"/>
+            <a:ext cx="237744" cy="237744"/>
+          </a:xfrm>
+          <a:prstGeom prst="rect">
+            <a:avLst/>
+          </a:prstGeom>
+        </p:spPr>
+      </p:pic>
+      <p:sp>
+        <p:nvSpPr>
+          <p:cNvPr id="15" name="Text 10"/>
+          <p:cNvSpPr/>
+          <p:nvPr/>
+        </p:nvSpPr>
+        <p:spPr>
+          <a:xfrm>
+            <a:off x="1417320" y="3328416"/>
+            <a:ext cx="5212080" cy="292608"/>
+          </a:xfrm>
+          <a:prstGeom prst="rect">
+            <a:avLst/>
+          </a:prstGeom>
+          <a:noFill/>
+          <a:ln/>
+        </p:spPr>
+        <p:txBody>
+          <a:bodyPr wrap="square" lIns="0" tIns="0" rIns="0" bIns="0" rtlCol="0" anchor="t"/>
+          <a:lstStyle/>
+          <a:p>
+            <a:pPr algn="l" indent="0" marL="0">
+              <a:buNone/>
+            </a:pPr>
+            <a:r>
+              <a:rPr lang="en-US" sz="1550" b="1" dirty="0">
+                <a:solidFill>
+                  <a:srgbClr val="2B2B33"/>
+                </a:solidFill>
+                <a:latin typeface="Cambria" pitchFamily="34" charset="0"/>
+                <a:ea typeface="Cambria" pitchFamily="34" charset="-122"/>
+                <a:cs typeface="Cambria" pitchFamily="34" charset="-120"/>
+              </a:rPr>
+              <a:t>Multifocal atrial tachycardia</a:t>
+            </a:r>
+            <a:endParaRPr lang="en-US" sz="1550" dirty="0"/>
+          </a:p>
+        </p:txBody>
+      </p:sp>
+      <p:sp>
+        <p:nvSpPr>
+          <p:cNvPr id="16" name="Text 11"/>
+          <p:cNvSpPr/>
+          <p:nvPr/>
+        </p:nvSpPr>
+        <p:spPr>
+          <a:xfrm>
+            <a:off x="1417320" y="3621024"/>
+            <a:ext cx="5257800" cy="274320"/>
+          </a:xfrm>
+          <a:prstGeom prst="rect">
+            <a:avLst/>
+          </a:prstGeom>
+          <a:noFill/>
+          <a:ln/>
+        </p:spPr>
+        <p:txBody>
+          <a:bodyPr wrap="square" lIns="0" tIns="0" rIns="0" bIns="0" rtlCol="0" anchor="t"/>
+          <a:lstStyle/>
+          <a:p>
+            <a:pPr algn="l" indent="0" marL="0">
+              <a:buNone/>
+            </a:pPr>
+            <a:r>
+              <a:rPr lang="en-US" sz="1200" dirty="0">
+                <a:solidFill>
+                  <a:srgbClr val="6B6B76"/>
+                </a:solidFill>
+                <a:latin typeface="Calibri" pitchFamily="34" charset="0"/>
+                <a:ea typeface="Calibri" pitchFamily="34" charset="-122"/>
+                <a:cs typeface="Calibri" pitchFamily="34" charset="-120"/>
+              </a:rPr>
+              <a:t>No ≥ 3 differing P-wave morphologies</a:t>
+            </a:r>
+            <a:endParaRPr lang="en-US" sz="1200" dirty="0"/>
+          </a:p>
+        </p:txBody>
+      </p:sp>
+      <p:sp>
+        <p:nvSpPr>
+          <p:cNvPr id="17" name="Shape 12"/>
+          <p:cNvSpPr/>
+          <p:nvPr/>
+        </p:nvSpPr>
+        <p:spPr>
+          <a:xfrm>
+            <a:off x="868680" y="4023360"/>
+            <a:ext cx="384048" cy="384048"/>
+          </a:xfrm>
+          <a:prstGeom prst="ellipse">
+            <a:avLst/>
+          </a:prstGeom>
+          <a:solidFill>
+            <a:srgbClr val="FFFFFF"/>
+          </a:solidFill>
+          <a:ln w="12700">
+            <a:solidFill>
+              <a:srgbClr val="FBD8DF"/>
+            </a:solidFill>
+            <a:prstDash val="solid"/>
+          </a:ln>
+        </p:spPr>
+      </p:sp>
+      <p:pic>
+        <p:nvPicPr>
+          <p:cNvPr id="18" name="Image 3" descr="preencoded.png">    </p:cNvPr>
+          <p:cNvPicPr>
+            <a:picLocks noChangeAspect="1"/>
+          </p:cNvPicPr>
+          <p:nvPr/>
+        </p:nvPicPr>
+        <p:blipFill>
+          <a:blip r:embed="rId4"/>
+          <a:stretch>
+            <a:fillRect/>
+          </a:stretch>
+        </p:blipFill>
+        <p:spPr>
+          <a:xfrm>
+            <a:off x="941832" y="4096512"/>
+            <a:ext cx="237744" cy="237744"/>
+          </a:xfrm>
+          <a:prstGeom prst="rect">
+            <a:avLst/>
+          </a:prstGeom>
+        </p:spPr>
+      </p:pic>
+      <p:sp>
+        <p:nvSpPr>
+          <p:cNvPr id="19" name="Text 13"/>
+          <p:cNvSpPr/>
+          <p:nvPr/>
+        </p:nvSpPr>
+        <p:spPr>
+          <a:xfrm>
+            <a:off x="1417320" y="3950208"/>
+            <a:ext cx="5212080" cy="292608"/>
+          </a:xfrm>
+          <a:prstGeom prst="rect">
+            <a:avLst/>
+          </a:prstGeom>
+          <a:noFill/>
+          <a:ln/>
+        </p:spPr>
+        <p:txBody>
+          <a:bodyPr wrap="square" lIns="0" tIns="0" rIns="0" bIns="0" rtlCol="0" anchor="t"/>
+          <a:lstStyle/>
+          <a:p>
+            <a:pPr algn="l" indent="0" marL="0">
+              <a:buNone/>
+            </a:pPr>
+            <a:r>
+              <a:rPr lang="en-US" sz="1550" b="1" dirty="0">
+                <a:solidFill>
+                  <a:srgbClr val="2B2B33"/>
+                </a:solidFill>
+                <a:latin typeface="Cambria" pitchFamily="34" charset="0"/>
+                <a:ea typeface="Cambria" pitchFamily="34" charset="-122"/>
+                <a:cs typeface="Cambria" pitchFamily="34" charset="-120"/>
+              </a:rPr>
+              <a:t>Frequent atrial ectopics</a:t>
+            </a:r>
+            <a:endParaRPr lang="en-US" sz="1550" dirty="0"/>
+          </a:p>
+        </p:txBody>
+      </p:sp>
+      <p:sp>
+        <p:nvSpPr>
+          <p:cNvPr id="20" name="Text 14"/>
+          <p:cNvSpPr/>
+          <p:nvPr/>
+        </p:nvSpPr>
+        <p:spPr>
+          <a:xfrm>
+            <a:off x="1417320" y="4242816"/>
+            <a:ext cx="5257800" cy="274320"/>
+          </a:xfrm>
+          <a:prstGeom prst="rect">
+            <a:avLst/>
+          </a:prstGeom>
+          <a:noFill/>
+          <a:ln/>
+        </p:spPr>
+        <p:txBody>
+          <a:bodyPr wrap="square" lIns="0" tIns="0" rIns="0" bIns="0" rtlCol="0" anchor="t"/>
+          <a:lstStyle/>
+          <a:p>
+            <a:pPr algn="l" indent="0" marL="0">
+              <a:buNone/>
+            </a:pPr>
+            <a:r>
+              <a:rPr lang="en-US" sz="1200" dirty="0">
+                <a:solidFill>
+                  <a:srgbClr val="6B6B76"/>
+                </a:solidFill>
+                <a:latin typeface="Calibri" pitchFamily="34" charset="0"/>
+                <a:ea typeface="Calibri" pitchFamily="34" charset="-122"/>
+                <a:cs typeface="Calibri" pitchFamily="34" charset="-120"/>
+              </a:rPr>
+              <a:t>No discrete P waves before each QRS</a:t>
+            </a:r>
+            <a:endParaRPr lang="en-US" sz="1200" dirty="0"/>
+          </a:p>
+        </p:txBody>
+      </p:sp>
+      <p:sp>
+        <p:nvSpPr>
+          <p:cNvPr id="21" name="Shape 15"/>
+          <p:cNvSpPr/>
+          <p:nvPr/>
+        </p:nvSpPr>
+        <p:spPr>
+          <a:xfrm>
+            <a:off x="868680" y="4645152"/>
+            <a:ext cx="384048" cy="384048"/>
+          </a:xfrm>
+          <a:prstGeom prst="ellipse">
+            <a:avLst/>
+          </a:prstGeom>
+          <a:solidFill>
+            <a:srgbClr val="FFFFFF"/>
+          </a:solidFill>
+          <a:ln w="12700">
+            <a:solidFill>
+              <a:srgbClr val="FBD8DF"/>
+            </a:solidFill>
+            <a:prstDash val="solid"/>
+          </a:ln>
+        </p:spPr>
+      </p:sp>
+      <p:pic>
+        <p:nvPicPr>
+          <p:cNvPr id="22" name="Image 4" descr="preencoded.png">    </p:cNvPr>
+          <p:cNvPicPr>
+            <a:picLocks noChangeAspect="1"/>
+          </p:cNvPicPr>
+          <p:nvPr/>
+        </p:nvPicPr>
+        <p:blipFill>
+          <a:blip r:embed="rId5"/>
+          <a:stretch>
+            <a:fillRect/>
+          </a:stretch>
+        </p:blipFill>
+        <p:spPr>
+          <a:xfrm>
+            <a:off x="941832" y="4718304"/>
+            <a:ext cx="237744" cy="237744"/>
+          </a:xfrm>
+          <a:prstGeom prst="rect">
+            <a:avLst/>
+          </a:prstGeom>
+        </p:spPr>
+      </p:pic>
+      <p:sp>
+        <p:nvSpPr>
+          <p:cNvPr id="23" name="Text 16"/>
+          <p:cNvSpPr/>
+          <p:nvPr/>
+        </p:nvSpPr>
+        <p:spPr>
+          <a:xfrm>
+            <a:off x="1417320" y="4572000"/>
+            <a:ext cx="5212080" cy="292608"/>
+          </a:xfrm>
+          <a:prstGeom prst="rect">
+            <a:avLst/>
+          </a:prstGeom>
+          <a:noFill/>
+          <a:ln/>
+        </p:spPr>
+        <p:txBody>
+          <a:bodyPr wrap="square" lIns="0" tIns="0" rIns="0" bIns="0" rtlCol="0" anchor="t"/>
+          <a:lstStyle/>
+          <a:p>
+            <a:pPr algn="l" indent="0" marL="0">
+              <a:buNone/>
+            </a:pPr>
+            <a:r>
+              <a:rPr lang="en-US" sz="1550" b="1" dirty="0">
+                <a:solidFill>
+                  <a:srgbClr val="2B2B33"/>
+                </a:solidFill>
+                <a:latin typeface="Cambria" pitchFamily="34" charset="0"/>
+                <a:ea typeface="Cambria" pitchFamily="34" charset="-122"/>
+                <a:cs typeface="Cambria" pitchFamily="34" charset="-120"/>
+              </a:rPr>
+              <a:t>AVNRT / AVRT (SVT)</a:t>
+            </a:r>
+            <a:endParaRPr lang="en-US" sz="1550" dirty="0"/>
+          </a:p>
+        </p:txBody>
+      </p:sp>
+      <p:sp>
+        <p:nvSpPr>
+          <p:cNvPr id="24" name="Text 17"/>
+          <p:cNvSpPr/>
+          <p:nvPr/>
+        </p:nvSpPr>
+        <p:spPr>
+          <a:xfrm>
+            <a:off x="1417320" y="4864608"/>
+            <a:ext cx="5257800" cy="274320"/>
+          </a:xfrm>
+          <a:prstGeom prst="rect">
+            <a:avLst/>
+          </a:prstGeom>
+          <a:noFill/>
+          <a:ln/>
+        </p:spPr>
+        <p:txBody>
+          <a:bodyPr wrap="square" lIns="0" tIns="0" rIns="0" bIns="0" rtlCol="0" anchor="t"/>
+          <a:lstStyle/>
+          <a:p>
+            <a:pPr algn="l" indent="0" marL="0">
+              <a:buNone/>
+            </a:pPr>
+            <a:r>
+              <a:rPr lang="en-US" sz="1200" dirty="0">
+                <a:solidFill>
+                  <a:srgbClr val="6B6B76"/>
+                </a:solidFill>
+                <a:latin typeface="Calibri" pitchFamily="34" charset="0"/>
+                <a:ea typeface="Calibri" pitchFamily="34" charset="-122"/>
+                <a:cs typeface="Calibri" pitchFamily="34" charset="-120"/>
+              </a:rPr>
+              <a:t>Regular in SVT — here rhythm is irregular</a:t>
+            </a:r>
+            <a:endParaRPr lang="en-US" sz="1200" dirty="0"/>
+          </a:p>
+        </p:txBody>
+      </p:sp>
+      <p:sp>
+        <p:nvSpPr>
+          <p:cNvPr id="25" name="Shape 18"/>
+          <p:cNvSpPr/>
+          <p:nvPr/>
+        </p:nvSpPr>
+        <p:spPr>
+          <a:xfrm>
+            <a:off x="868680" y="5266944"/>
+            <a:ext cx="384048" cy="384048"/>
+          </a:xfrm>
+          <a:prstGeom prst="ellipse">
+            <a:avLst/>
+          </a:prstGeom>
+          <a:solidFill>
+            <a:srgbClr val="FFFFFF"/>
+          </a:solidFill>
+          <a:ln w="12700">
+            <a:solidFill>
+              <a:srgbClr val="FBD8DF"/>
+            </a:solidFill>
+            <a:prstDash val="solid"/>
+          </a:ln>
+        </p:spPr>
+      </p:sp>
+      <p:pic>
+        <p:nvPicPr>
+          <p:cNvPr id="26" name="Image 5" descr="preencoded.png">    </p:cNvPr>
+          <p:cNvPicPr>
+            <a:picLocks noChangeAspect="1"/>
+          </p:cNvPicPr>
+          <p:nvPr/>
+        </p:nvPicPr>
+        <p:blipFill>
+          <a:blip r:embed="rId6"/>
+          <a:stretch>
+            <a:fillRect/>
+          </a:stretch>
+        </p:blipFill>
+        <p:spPr>
+          <a:xfrm>
+            <a:off x="941832" y="5340096"/>
+            <a:ext cx="237744" cy="237744"/>
+          </a:xfrm>
+          <a:prstGeom prst="rect">
+            <a:avLst/>
+          </a:prstGeom>
+        </p:spPr>
+      </p:pic>
+      <p:sp>
+        <p:nvSpPr>
+          <p:cNvPr id="27" name="Text 19"/>
+          <p:cNvSpPr/>
+          <p:nvPr/>
+        </p:nvSpPr>
+        <p:spPr>
+          <a:xfrm>
+            <a:off x="1417320" y="5193792"/>
+            <a:ext cx="5212080" cy="292608"/>
+          </a:xfrm>
+          <a:prstGeom prst="rect">
+            <a:avLst/>
+          </a:prstGeom>
+          <a:noFill/>
+          <a:ln/>
+        </p:spPr>
+        <p:txBody>
+          <a:bodyPr wrap="square" lIns="0" tIns="0" rIns="0" bIns="0" rtlCol="0" anchor="t"/>
+          <a:lstStyle/>
+          <a:p>
+            <a:pPr algn="l" indent="0" marL="0">
+              <a:buNone/>
+            </a:pPr>
+            <a:r>
+              <a:rPr lang="en-US" sz="1550" b="1" dirty="0">
+                <a:solidFill>
+                  <a:srgbClr val="2B2B33"/>
+                </a:solidFill>
+                <a:latin typeface="Cambria" pitchFamily="34" charset="0"/>
+                <a:ea typeface="Cambria" pitchFamily="34" charset="-122"/>
+                <a:cs typeface="Cambria" pitchFamily="34" charset="-120"/>
+              </a:rPr>
+              <a:t>Sinus tachycardia + ectopics</a:t>
+            </a:r>
+            <a:endParaRPr lang="en-US" sz="1550" dirty="0"/>
+          </a:p>
+        </p:txBody>
+      </p:sp>
+      <p:sp>
+        <p:nvSpPr>
+          <p:cNvPr id="28" name="Text 20"/>
+          <p:cNvSpPr/>
+          <p:nvPr/>
+        </p:nvSpPr>
+        <p:spPr>
+          <a:xfrm>
+            <a:off x="1417320" y="5486400"/>
+            <a:ext cx="5257800" cy="274320"/>
+          </a:xfrm>
+          <a:prstGeom prst="rect">
+            <a:avLst/>
+          </a:prstGeom>
+          <a:noFill/>
+          <a:ln/>
+        </p:spPr>
+        <p:txBody>
+          <a:bodyPr wrap="square" lIns="0" tIns="0" rIns="0" bIns="0" rtlCol="0" anchor="t"/>
+          <a:lstStyle/>
+          <a:p>
+            <a:pPr algn="l" indent="0" marL="0">
+              <a:buNone/>
+            </a:pPr>
+            <a:r>
+              <a:rPr lang="en-US" sz="1200" dirty="0">
+                <a:solidFill>
+                  <a:srgbClr val="6B6B76"/>
+                </a:solidFill>
+                <a:latin typeface="Calibri" pitchFamily="34" charset="0"/>
+                <a:ea typeface="Calibri" pitchFamily="34" charset="-122"/>
+                <a:cs typeface="Calibri" pitchFamily="34" charset="-120"/>
+              </a:rPr>
+              <a:t>P waves absent; irregularly irregular</a:t>
+            </a:r>
+            <a:endParaRPr lang="en-US" sz="1200" dirty="0"/>
+          </a:p>
+        </p:txBody>
+      </p:sp>
+      <p:sp>
+        <p:nvSpPr>
+          <p:cNvPr id="29" name="Shape 21"/>
+          <p:cNvSpPr/>
+          <p:nvPr/>
+        </p:nvSpPr>
+        <p:spPr>
+          <a:xfrm>
+            <a:off x="6995160" y="1783080"/>
+            <a:ext cx="4690872" cy="4206240"/>
+          </a:xfrm>
+          <a:prstGeom prst="roundRect">
+            <a:avLst>
+              <a:gd name="adj" fmla="val 2609"/>
+            </a:avLst>
+          </a:prstGeom>
+          <a:solidFill>
+            <a:srgbClr val="590D22"/>
+          </a:solidFill>
+          <a:ln/>
+          <a:effectLst>
+            <a:outerShdw sx="100000" sy="100000" kx="0" ky="0" algn="bl" rotWithShape="0" blurRad="127000" dist="50800" dir="5400000">
+              <a:srgbClr val="C9A3AC">
+                <a:alpha val="45000"/>
+              </a:srgbClr>
+            </a:outerShdw>
+          </a:effectLst>
+        </p:spPr>
+      </p:sp>
+      <p:sp>
+        <p:nvSpPr>
+          <p:cNvPr id="30" name="Text 22"/>
+          <p:cNvSpPr/>
+          <p:nvPr/>
+        </p:nvSpPr>
+        <p:spPr>
+          <a:xfrm>
+            <a:off x="7296912" y="2048256"/>
+            <a:ext cx="4114800" cy="274320"/>
+          </a:xfrm>
+          <a:prstGeom prst="rect">
+            <a:avLst/>
+          </a:prstGeom>
+          <a:noFill/>
+          <a:ln/>
+        </p:spPr>
+        <p:txBody>
+          <a:bodyPr wrap="square" rtlCol="0" anchor="t"/>
+          <a:lstStyle/>
+          <a:p>
+            <a:pPr algn="l" indent="0" marL="0">
+              <a:buNone/>
+            </a:pPr>
+            <a:r>
+              <a:rPr lang="en-US" sz="1250" b="1" spc="200" kern="0" dirty="0">
+                <a:solidFill>
+                  <a:srgbClr val="FF4D6D"/>
+                </a:solidFill>
+                <a:latin typeface="Calibri" pitchFamily="34" charset="0"/>
+                <a:ea typeface="Calibri" pitchFamily="34" charset="-122"/>
+                <a:cs typeface="Calibri" pitchFamily="34" charset="-120"/>
+              </a:rPr>
+              <a:t>FINAL DIAGNOSIS</a:t>
+            </a:r>
+            <a:endParaRPr lang="en-US" sz="1250" dirty="0"/>
+          </a:p>
+        </p:txBody>
+      </p:sp>
+      <p:sp>
+        <p:nvSpPr>
+          <p:cNvPr id="31" name="Text 23"/>
+          <p:cNvSpPr/>
+          <p:nvPr/>
+        </p:nvSpPr>
+        <p:spPr>
+          <a:xfrm>
+            <a:off x="7296912" y="2377440"/>
+            <a:ext cx="4160520" cy="1371600"/>
+          </a:xfrm>
+          <a:prstGeom prst="rect">
+            <a:avLst/>
+          </a:prstGeom>
+          <a:noFill/>
+          <a:ln/>
+        </p:spPr>
+        <p:txBody>
+          <a:bodyPr wrap="square" rtlCol="0" anchor="t"/>
+          <a:lstStyle/>
+          <a:p>
+            <a:pPr algn="l" indent="0" marL="0">
+              <a:lnSpc>
+                <a:spcPct val="100000"/>
+              </a:lnSpc>
+              <a:buNone/>
+            </a:pPr>
+            <a:r>
+              <a:rPr lang="en-US" sz="2400" b="1" dirty="0">
+                <a:solidFill>
+                  <a:srgbClr val="FFFFFF"/>
+                </a:solidFill>
+                <a:latin typeface="Cambria" pitchFamily="34" charset="0"/>
+                <a:ea typeface="Cambria" pitchFamily="34" charset="-122"/>
+                <a:cs typeface="Cambria" pitchFamily="34" charset="-120"/>
+              </a:rPr>
+              <a:t>Atrial Fibrillation with Rapid Ventricular Response</a:t>
+            </a:r>
+            <a:endParaRPr lang="en-US" sz="2400" dirty="0"/>
+          </a:p>
+        </p:txBody>
+      </p:sp>
+      <p:sp>
+        <p:nvSpPr>
+          <p:cNvPr id="32" name="Shape 24"/>
+          <p:cNvSpPr/>
+          <p:nvPr/>
+        </p:nvSpPr>
+        <p:spPr>
+          <a:xfrm>
+            <a:off x="7296912" y="3858768"/>
+            <a:ext cx="4114800" cy="0"/>
+          </a:xfrm>
+          <a:prstGeom prst="line">
+            <a:avLst/>
+          </a:prstGeom>
+          <a:noFill/>
+          <a:ln w="12700">
+            <a:solidFill>
+              <a:srgbClr val="7A2233"/>
+            </a:solidFill>
+            <a:prstDash val="solid"/>
+          </a:ln>
+        </p:spPr>
+      </p:sp>
+      <p:pic>
+        <p:nvPicPr>
+          <p:cNvPr id="33" name="Image 6" descr="preencoded.png">    </p:cNvPr>
+          <p:cNvPicPr>
+            <a:picLocks noChangeAspect="1"/>
+          </p:cNvPicPr>
+          <p:nvPr/>
+        </p:nvPicPr>
+        <p:blipFill>
+          <a:blip r:embed="rId7"/>
+          <a:stretch>
+            <a:fillRect/>
+          </a:stretch>
+        </p:blipFill>
+        <p:spPr>
+          <a:xfrm>
+            <a:off x="7296912" y="4050792"/>
+            <a:ext cx="274320" cy="274320"/>
+          </a:xfrm>
+          <a:prstGeom prst="rect">
+            <a:avLst/>
+          </a:prstGeom>
+        </p:spPr>
+      </p:pic>
+      <p:sp>
+        <p:nvSpPr>
+          <p:cNvPr id="34" name="Text 25"/>
+          <p:cNvSpPr/>
+          <p:nvPr/>
+        </p:nvSpPr>
+        <p:spPr>
+          <a:xfrm>
+            <a:off x="7680960" y="4041648"/>
+            <a:ext cx="3794760" cy="457200"/>
+          </a:xfrm>
+          <a:prstGeom prst="rect">
+            <a:avLst/>
+          </a:prstGeom>
+          <a:noFill/>
+          <a:ln/>
+        </p:spPr>
+        <p:txBody>
+          <a:bodyPr wrap="square" lIns="0" tIns="0" rIns="0" bIns="0" rtlCol="0" anchor="t"/>
+          <a:lstStyle/>
+          <a:p>
+            <a:pPr algn="l" indent="0" marL="0">
+              <a:lnSpc>
+                <a:spcPct val="102000"/>
+              </a:lnSpc>
+              <a:buNone/>
+            </a:pPr>
+            <a:r>
+              <a:rPr lang="en-US" sz="1200" dirty="0">
+                <a:solidFill>
+                  <a:srgbClr val="FBD8DF"/>
+                </a:solidFill>
+                <a:latin typeface="Calibri" pitchFamily="34" charset="0"/>
+                <a:ea typeface="Calibri" pitchFamily="34" charset="-122"/>
+                <a:cs typeface="Calibri" pitchFamily="34" charset="-120"/>
+              </a:rPr>
+              <a:t>Confirmed on 12-lead ECG — 146 bpm, no P waves</a:t>
+            </a:r>
+            <a:endParaRPr lang="en-US" sz="1200" dirty="0"/>
+          </a:p>
+        </p:txBody>
+      </p:sp>
+      <p:pic>
+        <p:nvPicPr>
+          <p:cNvPr id="35" name="Image 7" descr="preencoded.png">    </p:cNvPr>
+          <p:cNvPicPr>
+            <a:picLocks noChangeAspect="1"/>
+          </p:cNvPicPr>
+          <p:nvPr/>
+        </p:nvPicPr>
+        <p:blipFill>
+          <a:blip r:embed="rId8"/>
+          <a:stretch>
+            <a:fillRect/>
+          </a:stretch>
+        </p:blipFill>
+        <p:spPr>
+          <a:xfrm>
+            <a:off x="7296912" y="4535424"/>
+            <a:ext cx="274320" cy="274320"/>
+          </a:xfrm>
+          <a:prstGeom prst="rect">
+            <a:avLst/>
+          </a:prstGeom>
+        </p:spPr>
+      </p:pic>
+      <p:sp>
+        <p:nvSpPr>
+          <p:cNvPr id="36" name="Text 26"/>
+          <p:cNvSpPr/>
+          <p:nvPr/>
+        </p:nvSpPr>
+        <p:spPr>
+          <a:xfrm>
+            <a:off x="7680960" y="4526280"/>
+            <a:ext cx="3794760" cy="457200"/>
+          </a:xfrm>
+          <a:prstGeom prst="rect">
+            <a:avLst/>
+          </a:prstGeom>
+          <a:noFill/>
+          <a:ln/>
+        </p:spPr>
+        <p:txBody>
+          <a:bodyPr wrap="square" lIns="0" tIns="0" rIns="0" bIns="0" rtlCol="0" anchor="t"/>
+          <a:lstStyle/>
+          <a:p>
+            <a:pPr algn="l" indent="0" marL="0">
+              <a:lnSpc>
+                <a:spcPct val="102000"/>
+              </a:lnSpc>
+              <a:buNone/>
+            </a:pPr>
+            <a:r>
+              <a:rPr lang="en-US" sz="1200" dirty="0">
+                <a:solidFill>
+                  <a:srgbClr val="FBD8DF"/>
+                </a:solidFill>
+                <a:latin typeface="Calibri" pitchFamily="34" charset="0"/>
+                <a:ea typeface="Calibri" pitchFamily="34" charset="-122"/>
+                <a:cs typeface="Calibri" pitchFamily="34" charset="-120"/>
+              </a:rPr>
+              <a:t>Structurally normal heart — LVEF 65%, no LA/LV clot</a:t>
+            </a:r>
+            <a:endParaRPr lang="en-US" sz="1200" dirty="0"/>
+          </a:p>
+        </p:txBody>
+      </p:sp>
+      <p:pic>
+        <p:nvPicPr>
+          <p:cNvPr id="37" name="Image 8" descr="preencoded.png">    </p:cNvPr>
+          <p:cNvPicPr>
+            <a:picLocks noChangeAspect="1"/>
+          </p:cNvPicPr>
+          <p:nvPr/>
+        </p:nvPicPr>
+        <p:blipFill>
+          <a:blip r:embed="rId9"/>
+          <a:stretch>
+            <a:fillRect/>
+          </a:stretch>
+        </p:blipFill>
+        <p:spPr>
+          <a:xfrm>
+            <a:off x="7296912" y="5020056"/>
+            <a:ext cx="274320" cy="274320"/>
+          </a:xfrm>
+          <a:prstGeom prst="rect">
+            <a:avLst/>
+          </a:prstGeom>
+        </p:spPr>
+      </p:pic>
+      <p:sp>
+        <p:nvSpPr>
+          <p:cNvPr id="38" name="Text 27"/>
+          <p:cNvSpPr/>
+          <p:nvPr/>
+        </p:nvSpPr>
+        <p:spPr>
+          <a:xfrm>
+            <a:off x="7680960" y="5010912"/>
+            <a:ext cx="3794760" cy="457200"/>
+          </a:xfrm>
+          <a:prstGeom prst="rect">
+            <a:avLst/>
+          </a:prstGeom>
+          <a:noFill/>
+          <a:ln/>
+        </p:spPr>
+        <p:txBody>
+          <a:bodyPr wrap="square" lIns="0" tIns="0" rIns="0" bIns="0" rtlCol="0" anchor="t"/>
+          <a:lstStyle/>
+          <a:p>
+            <a:pPr algn="l" indent="0" marL="0">
+              <a:lnSpc>
+                <a:spcPct val="102000"/>
+              </a:lnSpc>
+              <a:buNone/>
+            </a:pPr>
+            <a:r>
+              <a:rPr lang="en-US" sz="1200" dirty="0">
+                <a:solidFill>
+                  <a:srgbClr val="FBD8DF"/>
+                </a:solidFill>
+                <a:latin typeface="Calibri" pitchFamily="34" charset="0"/>
+                <a:ea typeface="Calibri" pitchFamily="34" charset="-122"/>
+                <a:cs typeface="Calibri" pitchFamily="34" charset="-120"/>
+              </a:rPr>
+              <a:t>Background hypertension</a:t>
+            </a:r>
+            <a:endParaRPr lang="en-US" sz="1200" dirty="0"/>
+          </a:p>
+        </p:txBody>
+      </p:sp>
+      <p:pic>
+        <p:nvPicPr>
+          <p:cNvPr id="39" name="Image 9" descr="preencoded.png">    </p:cNvPr>
+          <p:cNvPicPr>
+            <a:picLocks noChangeAspect="1"/>
+          </p:cNvPicPr>
+          <p:nvPr/>
+        </p:nvPicPr>
+        <p:blipFill>
+          <a:blip r:embed="rId10"/>
+          <a:stretch>
+            <a:fillRect/>
+          </a:stretch>
+        </p:blipFill>
+        <p:spPr>
+          <a:xfrm>
+            <a:off x="7296912" y="5504688"/>
+            <a:ext cx="274320" cy="274320"/>
+          </a:xfrm>
+          <a:prstGeom prst="rect">
+            <a:avLst/>
+          </a:prstGeom>
+        </p:spPr>
+      </p:pic>
+      <p:sp>
+        <p:nvSpPr>
+          <p:cNvPr id="40" name="Text 28"/>
+          <p:cNvSpPr/>
+          <p:nvPr/>
+        </p:nvSpPr>
+        <p:spPr>
+          <a:xfrm>
+            <a:off x="7680960" y="5495544"/>
+            <a:ext cx="3794760" cy="457200"/>
+          </a:xfrm>
+          <a:prstGeom prst="rect">
+            <a:avLst/>
+          </a:prstGeom>
+          <a:noFill/>
+          <a:ln/>
+        </p:spPr>
+        <p:txBody>
+          <a:bodyPr wrap="square" lIns="0" tIns="0" rIns="0" bIns="0" rtlCol="0" anchor="t"/>
+          <a:lstStyle/>
+          <a:p>
+            <a:pPr algn="l" indent="0" marL="0">
+              <a:lnSpc>
+                <a:spcPct val="102000"/>
+              </a:lnSpc>
+              <a:buNone/>
+            </a:pPr>
+            <a:r>
+              <a:rPr lang="en-US" sz="1200" dirty="0">
+                <a:solidFill>
+                  <a:srgbClr val="FBD8DF"/>
+                </a:solidFill>
+                <a:latin typeface="Calibri" pitchFamily="34" charset="0"/>
+                <a:ea typeface="Calibri" pitchFamily="34" charset="-122"/>
+                <a:cs typeface="Calibri" pitchFamily="34" charset="-120"/>
+              </a:rPr>
+              <a:t>Mild normocytic anaemia (incidental)</a:t>
+            </a:r>
+            <a:endParaRPr lang="en-US" sz="1200" dirty="0"/>
+          </a:p>
+        </p:txBody>
+      </p:sp>
+      <p:sp>
+        <p:nvSpPr>
+          <p:cNvPr id="41" name="Text 29"/>
+          <p:cNvSpPr/>
+          <p:nvPr/>
+        </p:nvSpPr>
+        <p:spPr>
+          <a:xfrm>
+            <a:off x="11277295" y="6355080"/>
+            <a:ext cx="548640" cy="320040"/>
+          </a:xfrm>
+          <a:prstGeom prst="rect">
+            <a:avLst/>
+          </a:prstGeom>
+          <a:noFill/>
+          <a:ln/>
+        </p:spPr>
+        <p:txBody>
+          <a:bodyPr wrap="square" rtlCol="0" anchor="t"/>
+          <a:lstStyle/>
+          <a:p>
+            <a:pPr algn="r" indent="0" marL="0">
+              <a:buNone/>
+            </a:pPr>
+            <a:r>
+              <a:rPr lang="en-US" sz="1100" b="1" dirty="0">
+                <a:solidFill>
+                  <a:srgbClr val="6B6B76"/>
+                </a:solidFill>
+                <a:latin typeface="Calibri" pitchFamily="34" charset="0"/>
+                <a:ea typeface="Calibri" pitchFamily="34" charset="-122"/>
+                <a:cs typeface="Calibri" pitchFamily="34" charset="-120"/>
+              </a:rPr>
+              <a:t>18</a:t>
+            </a:r>
+            <a:endParaRPr lang="en-US" sz="1100" dirty="0"/>
+          </a:p>
+        </p:txBody>
+      </p:sp>
+      <p:sp>
+        <p:nvSpPr>
+          <p:cNvPr id="42" name="Text 30"/>
+          <p:cNvSpPr/>
+          <p:nvPr/>
+        </p:nvSpPr>
+        <p:spPr>
+          <a:xfrm>
+            <a:off x="502920" y="6355080"/>
+            <a:ext cx="5486400" cy="320040"/>
+          </a:xfrm>
+          <a:prstGeom prst="rect">
+            <a:avLst/>
+          </a:prstGeom>
+          <a:noFill/>
+          <a:ln/>
+        </p:spPr>
+        <p:txBody>
+          <a:bodyPr wrap="square" rtlCol="0" anchor="t"/>
+          <a:lstStyle/>
+          <a:p>
+            <a:pPr algn="l" indent="0" marL="0">
+              <a:buNone/>
+            </a:pPr>
+            <a:r>
+              <a:rPr lang="en-US" sz="900" dirty="0">
+                <a:solidFill>
+                  <a:srgbClr val="6B6B76"/>
+                </a:solidFill>
+                <a:latin typeface="Calibri" pitchFamily="34" charset="0"/>
+                <a:ea typeface="Calibri" pitchFamily="34" charset="-122"/>
+                <a:cs typeface="Calibri" pitchFamily="34" charset="-120"/>
+              </a:rPr>
+              <a:t>Clinicopathological Conference</a:t>
+            </a:r>
+            <a:endParaRPr lang="en-US" sz="900" dirty="0"/>
+          </a:p>
+        </p:txBody>
+      </p:sp>
+    </p:spTree>
+  </p:cSld>
+  <p:clrMapOvr>
+    <a:masterClrMapping/>
+  </p:clrMapOvr>
+</p:sld>
+</file>
+
+<file path=ppt/slides/slide19.xml><?xml version="1.0" encoding="utf-8"?>
+<p:sld xmlns:a="http://schemas.openxmlformats.org/drawingml/2006/main" xmlns:r="http://schemas.openxmlformats.org/officeDocument/2006/relationships" xmlns:p="http://schemas.openxmlformats.org/presentationml/2006/main">
+  <p:cSld name="Slide 19">
+    <p:bg>
+      <p:bgPr>
+        <a:solidFill>
           <a:srgbClr val="590D22"/>
         </a:solidFill>
       </p:bgPr>
@@ -15577,7 +16609,7 @@
                 <a:ea typeface="Calibri" pitchFamily="34" charset="-122"/>
                 <a:cs typeface="Calibri" pitchFamily="34" charset="-120"/>
               </a:rPr>
-              <a:t>18</a:t>
+              <a:t>19</a:t>
             </a:r>
             <a:endParaRPr lang="en-US" sz="1100" dirty="0"/>
           </a:p>
@@ -18646,7 +19678,7 @@
                 <a:ea typeface="Cambria" pitchFamily="34" charset="-122"/>
                 <a:cs typeface="Cambria" pitchFamily="34" charset="-120"/>
               </a:rPr>
-              <a:t>Medical History</a:t>
+              <a:t>Drug History</a:t>
             </a:r>
             <a:endParaRPr lang="en-US" sz="3000" dirty="0"/>
           </a:p>
@@ -18765,7 +19797,7 @@
                 <a:ea typeface="Cambria" pitchFamily="34" charset="-122"/>
                 <a:cs typeface="Cambria" pitchFamily="34" charset="-120"/>
               </a:rPr>
-              <a:t>Medical</a:t>
+              <a:t>Medications</a:t>
             </a:r>
             <a:endParaRPr lang="en-US" sz="2500" dirty="0"/>
           </a:p>
@@ -18955,11 +19987,11 @@
         <p:spPr>
           <a:xfrm>
             <a:off x="4937760" y="1783080"/>
-            <a:ext cx="6766560" cy="4206240"/>
+            <a:ext cx="6766560" cy="1325880"/>
           </a:xfrm>
           <a:prstGeom prst="roundRect">
             <a:avLst>
-              <a:gd name="adj" fmla="val 2609"/>
+              <a:gd name="adj" fmla="val 6897"/>
             </a:avLst>
           </a:prstGeom>
           <a:solidFill>
@@ -18982,69 +20014,79 @@
       </p:sp>
       <p:sp>
         <p:nvSpPr>
-          <p:cNvPr id="18" name="Text 14"/>
-          <p:cNvSpPr/>
-          <p:nvPr/>
-        </p:nvSpPr>
-        <p:spPr>
-          <a:xfrm>
-            <a:off x="5440680" y="2194560"/>
-            <a:ext cx="5852160" cy="274320"/>
-          </a:xfrm>
-          <a:prstGeom prst="rect">
-            <a:avLst/>
-          </a:prstGeom>
-          <a:noFill/>
-          <a:ln/>
-        </p:spPr>
-        <p:txBody>
-          <a:bodyPr wrap="square" rtlCol="0" anchor="t"/>
-          <a:lstStyle/>
-          <a:p>
-            <a:pPr algn="l" indent="0" marL="0">
-              <a:buNone/>
-            </a:pPr>
-            <a:r>
-              <a:rPr lang="en-US" sz="1250" b="1" spc="200" kern="0" dirty="0">
-                <a:solidFill>
-                  <a:srgbClr val="A4133C"/>
-                </a:solidFill>
-                <a:latin typeface="Calibri" pitchFamily="34" charset="0"/>
-                <a:ea typeface="Calibri" pitchFamily="34" charset="-122"/>
-                <a:cs typeface="Calibri" pitchFamily="34" charset="-120"/>
-              </a:rPr>
-              <a:t>KNOWN COMORBIDITY</a:t>
-            </a:r>
-            <a:endParaRPr lang="en-US" sz="1250" dirty="0"/>
-          </a:p>
-        </p:txBody>
-      </p:sp>
-      <p:sp>
-        <p:nvSpPr>
-          <p:cNvPr id="19" name="Text 15"/>
-          <p:cNvSpPr/>
-          <p:nvPr/>
-        </p:nvSpPr>
-        <p:spPr>
-          <a:xfrm>
-            <a:off x="5440680" y="2606040"/>
-            <a:ext cx="5852160" cy="822960"/>
-          </a:xfrm>
-          <a:prstGeom prst="rect">
-            <a:avLst/>
-          </a:prstGeom>
-          <a:noFill/>
-          <a:ln/>
-        </p:spPr>
-        <p:txBody>
-          <a:bodyPr wrap="square" rtlCol="0" anchor="t"/>
-          <a:lstStyle/>
-          <a:p>
-            <a:pPr algn="l" indent="0" marL="0">
-              <a:buNone/>
-            </a:pPr>
-            <a:r>
-              <a:rPr lang="en-US" sz="4400" b="1" dirty="0">
+          <p:cNvPr id="18" name="Shape 14"/>
+          <p:cNvSpPr/>
+          <p:nvPr/>
+        </p:nvSpPr>
+        <p:spPr>
+          <a:xfrm>
+            <a:off x="5257800" y="2084832"/>
+            <a:ext cx="731520" cy="731520"/>
+          </a:xfrm>
+          <a:prstGeom prst="ellipse">
+            <a:avLst/>
+          </a:prstGeom>
+          <a:solidFill>
+            <a:srgbClr val="FFFFFF"/>
+          </a:solidFill>
+          <a:ln w="12700">
+            <a:solidFill>
+              <a:srgbClr val="FBD8DF"/>
+            </a:solidFill>
+            <a:prstDash val="solid"/>
+          </a:ln>
+        </p:spPr>
+      </p:sp>
+      <p:pic>
+        <p:nvPicPr>
+          <p:cNvPr id="19" name="Image 2" descr="preencoded.png">    </p:cNvPr>
+          <p:cNvPicPr>
+            <a:picLocks noChangeAspect="1"/>
+          </p:cNvPicPr>
+          <p:nvPr/>
+        </p:nvPicPr>
+        <p:blipFill>
+          <a:blip r:embed="rId3"/>
+          <a:stretch>
+            <a:fillRect/>
+          </a:stretch>
+        </p:blipFill>
+        <p:spPr>
+          <a:xfrm>
+            <a:off x="5440680" y="2267712"/>
+            <a:ext cx="365760" cy="365760"/>
+          </a:xfrm>
+          <a:prstGeom prst="rect">
+            <a:avLst/>
+          </a:prstGeom>
+        </p:spPr>
+      </p:pic>
+      <p:sp>
+        <p:nvSpPr>
+          <p:cNvPr id="20" name="Text 15"/>
+          <p:cNvSpPr/>
+          <p:nvPr/>
+        </p:nvSpPr>
+        <p:spPr>
+          <a:xfrm>
+            <a:off x="6217920" y="2039112"/>
+            <a:ext cx="5120640" cy="457200"/>
+          </a:xfrm>
+          <a:prstGeom prst="rect">
+            <a:avLst/>
+          </a:prstGeom>
+          <a:noFill/>
+          <a:ln/>
+        </p:spPr>
+        <p:txBody>
+          <a:bodyPr wrap="square" lIns="0" tIns="0" rIns="0" bIns="0" rtlCol="0" anchor="t"/>
+          <a:lstStyle/>
+          <a:p>
+            <a:pPr algn="l" indent="0" marL="0">
+              <a:buNone/>
+            </a:pPr>
+            <a:r>
+              <a:rPr lang="en-US" sz="2400" b="1" dirty="0">
                 <a:solidFill>
                   <a:srgbClr val="2B2B33"/>
                 </a:solidFill>
@@ -19052,38 +20094,38 @@
                 <a:ea typeface="Cambria" pitchFamily="34" charset="-122"/>
                 <a:cs typeface="Cambria" pitchFamily="34" charset="-120"/>
               </a:rPr>
-              <a:t>Hypertension</a:t>
-            </a:r>
-            <a:endParaRPr lang="en-US" sz="4400" dirty="0"/>
-          </a:p>
-        </p:txBody>
-      </p:sp>
-      <p:sp>
-        <p:nvSpPr>
-          <p:cNvPr id="20" name="Text 16"/>
-          <p:cNvSpPr/>
-          <p:nvPr/>
-        </p:nvSpPr>
-        <p:spPr>
-          <a:xfrm>
-            <a:off x="5458968" y="3611880"/>
-            <a:ext cx="5760720" cy="457200"/>
-          </a:xfrm>
-          <a:prstGeom prst="rect">
-            <a:avLst/>
-          </a:prstGeom>
-          <a:noFill/>
-          <a:ln/>
-        </p:spPr>
-        <p:txBody>
-          <a:bodyPr wrap="square" rtlCol="0" anchor="t"/>
-          <a:lstStyle/>
-          <a:p>
-            <a:pPr algn="l" indent="0" marL="0">
-              <a:buNone/>
-            </a:pPr>
-            <a:r>
-              <a:rPr lang="en-US" sz="1700" i="1" dirty="0">
+              <a:t>Tab Vadil</a:t>
+            </a:r>
+            <a:endParaRPr lang="en-US" sz="2400" dirty="0"/>
+          </a:p>
+        </p:txBody>
+      </p:sp>
+      <p:sp>
+        <p:nvSpPr>
+          <p:cNvPr id="21" name="Text 16"/>
+          <p:cNvSpPr/>
+          <p:nvPr/>
+        </p:nvSpPr>
+        <p:spPr>
+          <a:xfrm>
+            <a:off x="6217920" y="2532888"/>
+            <a:ext cx="5120640" cy="365760"/>
+          </a:xfrm>
+          <a:prstGeom prst="rect">
+            <a:avLst/>
+          </a:prstGeom>
+          <a:noFill/>
+          <a:ln/>
+        </p:spPr>
+        <p:txBody>
+          <a:bodyPr wrap="square" lIns="0" tIns="0" rIns="0" bIns="0" rtlCol="0" anchor="t"/>
+          <a:lstStyle/>
+          <a:p>
+            <a:pPr algn="l" indent="0" marL="0">
+              <a:buNone/>
+            </a:pPr>
+            <a:r>
+              <a:rPr lang="en-US" sz="1450" i="1" dirty="0">
                 <a:solidFill>
                   <a:srgbClr val="6B6B76"/>
                 </a:solidFill>
@@ -19091,44 +20133,212 @@
                 <a:ea typeface="Calibri" pitchFamily="34" charset="-122"/>
                 <a:cs typeface="Calibri" pitchFamily="34" charset="-120"/>
               </a:rPr>
-              <a:t>On oral antihypertensive medication</a:t>
-            </a:r>
-            <a:endParaRPr lang="en-US" sz="1700" dirty="0"/>
-          </a:p>
-        </p:txBody>
-      </p:sp>
-      <p:sp>
-        <p:nvSpPr>
-          <p:cNvPr id="21" name="Shape 17"/>
-          <p:cNvSpPr/>
-          <p:nvPr/>
-        </p:nvSpPr>
-        <p:spPr>
-          <a:xfrm>
-            <a:off x="5440680" y="4572000"/>
-            <a:ext cx="2148840" cy="566928"/>
+              <a:t>Rate / rhythm control</a:t>
+            </a:r>
+            <a:endParaRPr lang="en-US" sz="1450" dirty="0"/>
+          </a:p>
+        </p:txBody>
+      </p:sp>
+      <p:sp>
+        <p:nvSpPr>
+          <p:cNvPr id="22" name="Shape 17"/>
+          <p:cNvSpPr/>
+          <p:nvPr/>
+        </p:nvSpPr>
+        <p:spPr>
+          <a:xfrm>
+            <a:off x="4937760" y="3291840"/>
+            <a:ext cx="6766560" cy="1325880"/>
           </a:xfrm>
           <a:prstGeom prst="roundRect">
             <a:avLst>
-              <a:gd name="adj" fmla="val 50000"/>
+              <a:gd name="adj" fmla="val 6897"/>
             </a:avLst>
           </a:prstGeom>
           <a:solidFill>
-            <a:srgbClr val="A4133C"/>
+            <a:srgbClr val="FFF0F3"/>
           </a:solidFill>
-          <a:ln/>
-        </p:spPr>
-      </p:sp>
-      <p:sp>
-        <p:nvSpPr>
-          <p:cNvPr id="22" name="Text 18"/>
-          <p:cNvSpPr/>
-          <p:nvPr/>
-        </p:nvSpPr>
-        <p:spPr>
-          <a:xfrm>
-            <a:off x="5440680" y="4572000"/>
-            <a:ext cx="2148840" cy="566928"/>
+          <a:ln w="12700">
+            <a:solidFill>
+              <a:srgbClr val="FBD8DF"/>
+            </a:solidFill>
+            <a:prstDash val="solid"/>
+          </a:ln>
+          <a:effectLst>
+            <a:outerShdw sx="100000" sy="100000" kx="0" ky="0" algn="bl" rotWithShape="0" blurRad="127000" dist="50800" dir="5400000">
+              <a:srgbClr val="C9A3AC">
+                <a:alpha val="45000"/>
+              </a:srgbClr>
+            </a:outerShdw>
+          </a:effectLst>
+        </p:spPr>
+      </p:sp>
+      <p:sp>
+        <p:nvSpPr>
+          <p:cNvPr id="23" name="Shape 18"/>
+          <p:cNvSpPr/>
+          <p:nvPr/>
+        </p:nvSpPr>
+        <p:spPr>
+          <a:xfrm>
+            <a:off x="5257800" y="3593592"/>
+            <a:ext cx="731520" cy="731520"/>
+          </a:xfrm>
+          <a:prstGeom prst="ellipse">
+            <a:avLst/>
+          </a:prstGeom>
+          <a:solidFill>
+            <a:srgbClr val="FFFFFF"/>
+          </a:solidFill>
+          <a:ln w="12700">
+            <a:solidFill>
+              <a:srgbClr val="FBD8DF"/>
+            </a:solidFill>
+            <a:prstDash val="solid"/>
+          </a:ln>
+        </p:spPr>
+      </p:sp>
+      <p:pic>
+        <p:nvPicPr>
+          <p:cNvPr id="24" name="Image 3" descr="preencoded.png">    </p:cNvPr>
+          <p:cNvPicPr>
+            <a:picLocks noChangeAspect="1"/>
+          </p:cNvPicPr>
+          <p:nvPr/>
+        </p:nvPicPr>
+        <p:blipFill>
+          <a:blip r:embed="rId4"/>
+          <a:stretch>
+            <a:fillRect/>
+          </a:stretch>
+        </p:blipFill>
+        <p:spPr>
+          <a:xfrm>
+            <a:off x="5440680" y="3776472"/>
+            <a:ext cx="365760" cy="365760"/>
+          </a:xfrm>
+          <a:prstGeom prst="rect">
+            <a:avLst/>
+          </a:prstGeom>
+        </p:spPr>
+      </p:pic>
+      <p:sp>
+        <p:nvSpPr>
+          <p:cNvPr id="25" name="Text 19"/>
+          <p:cNvSpPr/>
+          <p:nvPr/>
+        </p:nvSpPr>
+        <p:spPr>
+          <a:xfrm>
+            <a:off x="6217920" y="3547872"/>
+            <a:ext cx="5120640" cy="457200"/>
+          </a:xfrm>
+          <a:prstGeom prst="rect">
+            <a:avLst/>
+          </a:prstGeom>
+          <a:noFill/>
+          <a:ln/>
+        </p:spPr>
+        <p:txBody>
+          <a:bodyPr wrap="square" lIns="0" tIns="0" rIns="0" bIns="0" rtlCol="0" anchor="t"/>
+          <a:lstStyle/>
+          <a:p>
+            <a:pPr algn="l" indent="0" marL="0">
+              <a:buNone/>
+            </a:pPr>
+            <a:r>
+              <a:rPr lang="en-US" sz="2400" b="1" dirty="0">
+                <a:solidFill>
+                  <a:srgbClr val="2B2B33"/>
+                </a:solidFill>
+                <a:latin typeface="Cambria" pitchFamily="34" charset="0"/>
+                <a:ea typeface="Cambria" pitchFamily="34" charset="-122"/>
+                <a:cs typeface="Cambria" pitchFamily="34" charset="-120"/>
+              </a:rPr>
+              <a:t>Tab Rivaroxaban</a:t>
+            </a:r>
+            <a:endParaRPr lang="en-US" sz="2400" dirty="0"/>
+          </a:p>
+        </p:txBody>
+      </p:sp>
+      <p:sp>
+        <p:nvSpPr>
+          <p:cNvPr id="26" name="Text 20"/>
+          <p:cNvSpPr/>
+          <p:nvPr/>
+        </p:nvSpPr>
+        <p:spPr>
+          <a:xfrm>
+            <a:off x="6217920" y="4041648"/>
+            <a:ext cx="5120640" cy="365760"/>
+          </a:xfrm>
+          <a:prstGeom prst="rect">
+            <a:avLst/>
+          </a:prstGeom>
+          <a:noFill/>
+          <a:ln/>
+        </p:spPr>
+        <p:txBody>
+          <a:bodyPr wrap="square" lIns="0" tIns="0" rIns="0" bIns="0" rtlCol="0" anchor="t"/>
+          <a:lstStyle/>
+          <a:p>
+            <a:pPr algn="l" indent="0" marL="0">
+              <a:buNone/>
+            </a:pPr>
+            <a:r>
+              <a:rPr lang="en-US" sz="1450" i="1" dirty="0">
+                <a:solidFill>
+                  <a:srgbClr val="6B6B76"/>
+                </a:solidFill>
+                <a:latin typeface="Calibri" pitchFamily="34" charset="0"/>
+                <a:ea typeface="Calibri" pitchFamily="34" charset="-122"/>
+                <a:cs typeface="Calibri" pitchFamily="34" charset="-120"/>
+              </a:rPr>
+              <a:t>Oral anticoagulation</a:t>
+            </a:r>
+            <a:endParaRPr lang="en-US" sz="1450" dirty="0"/>
+          </a:p>
+        </p:txBody>
+      </p:sp>
+      <p:sp>
+        <p:nvSpPr>
+          <p:cNvPr id="27" name="Shape 21"/>
+          <p:cNvSpPr/>
+          <p:nvPr/>
+        </p:nvSpPr>
+        <p:spPr>
+          <a:xfrm>
+            <a:off x="4937760" y="4800600"/>
+            <a:ext cx="6766560" cy="1188720"/>
+          </a:xfrm>
+          <a:prstGeom prst="roundRect">
+            <a:avLst>
+              <a:gd name="adj" fmla="val 7692"/>
+            </a:avLst>
+          </a:prstGeom>
+          <a:solidFill>
+            <a:srgbClr val="590D22"/>
+          </a:solidFill>
+          <a:ln/>
+          <a:effectLst>
+            <a:outerShdw sx="100000" sy="100000" kx="0" ky="0" algn="bl" rotWithShape="0" blurRad="127000" dist="50800" dir="5400000">
+              <a:srgbClr val="C9A3AC">
+                <a:alpha val="45000"/>
+              </a:srgbClr>
+            </a:outerShdw>
+          </a:effectLst>
+        </p:spPr>
+      </p:sp>
+      <p:sp>
+        <p:nvSpPr>
+          <p:cNvPr id="28" name="Text 22"/>
+          <p:cNvSpPr/>
+          <p:nvPr/>
+        </p:nvSpPr>
+        <p:spPr>
+          <a:xfrm>
+            <a:off x="5394960" y="4800600"/>
+            <a:ext cx="5852160" cy="1188720"/>
           </a:xfrm>
           <a:prstGeom prst="rect">
             <a:avLst/>
@@ -19140,27 +20350,41 @@
           <a:bodyPr wrap="square" rtlCol="0" anchor="ctr"/>
           <a:lstStyle/>
           <a:p>
-            <a:pPr algn="ctr" indent="0" marL="0">
-              <a:buNone/>
-            </a:pPr>
-            <a:r>
-              <a:rPr lang="en-US" sz="1450" b="1" dirty="0">
-                <a:solidFill>
-                  <a:srgbClr val="FFFFFF"/>
-                </a:solidFill>
-                <a:latin typeface="Calibri" pitchFamily="34" charset="0"/>
-                <a:ea typeface="Calibri" pitchFamily="34" charset="-122"/>
-                <a:cs typeface="Calibri" pitchFamily="34" charset="-120"/>
-              </a:rPr>
-              <a:t>HTN</a:t>
-            </a:r>
-            <a:endParaRPr lang="en-US" sz="1450" dirty="0"/>
-          </a:p>
-        </p:txBody>
-      </p:sp>
-      <p:sp>
-        <p:nvSpPr>
-          <p:cNvPr id="23" name="Text 19"/>
+            <a:pPr algn="l" indent="0" marL="0">
+              <a:buNone/>
+            </a:pPr>
+            <a:r>
+              <a:rPr lang="en-US" sz="1600" b="1" dirty="0">
+                <a:solidFill>
+                  <a:srgbClr val="FF4D6D"/>
+                </a:solidFill>
+                <a:latin typeface="Calibri" pitchFamily="34" charset="0"/>
+                <a:ea typeface="Calibri" pitchFamily="34" charset="-122"/>
+                <a:cs typeface="Calibri" pitchFamily="34" charset="-120"/>
+              </a:rPr>
+              <a:t>Purpose  </a:t>
+            </a:r>
+            <a:pPr algn="l" indent="0" marL="0">
+              <a:buNone/>
+            </a:pPr>
+            <a:r>
+              <a:rPr lang="en-US" sz="1600" dirty="0">
+                <a:solidFill>
+                  <a:srgbClr val="FBD8DF"/>
+                </a:solidFill>
+                <a:latin typeface="Calibri" pitchFamily="34" charset="0"/>
+                <a:ea typeface="Calibri" pitchFamily="34" charset="-122"/>
+                <a:cs typeface="Calibri" pitchFamily="34" charset="-120"/>
+              </a:rPr>
+              <a:t>Symptom control with stroke-risk protection</a:t>
+            </a:r>
+            <a:endParaRPr lang="en-US" sz="1600" dirty="0"/>
+          </a:p>
+        </p:txBody>
+      </p:sp>
+      <p:sp>
+        <p:nvSpPr>
+          <p:cNvPr id="29" name="Text 23"/>
           <p:cNvSpPr/>
           <p:nvPr/>
         </p:nvSpPr>
@@ -19199,7 +20423,7 @@
       </p:sp>
       <p:sp>
         <p:nvSpPr>
-          <p:cNvPr id="24" name="Text 20"/>
+          <p:cNvPr id="30" name="Text 24"/>
           <p:cNvSpPr/>
           <p:nvPr/>
         </p:nvSpPr>
@@ -19389,7 +20613,7 @@
                 <a:ea typeface="Cambria" pitchFamily="34" charset="-122"/>
                 <a:cs typeface="Cambria" pitchFamily="34" charset="-120"/>
               </a:rPr>
-              <a:t>Drug History</a:t>
+              <a:t>Medical History</a:t>
             </a:r>
             <a:endParaRPr lang="en-US" sz="3000" dirty="0"/>
           </a:p>
@@ -19508,7 +20732,7 @@
                 <a:ea typeface="Cambria" pitchFamily="34" charset="-122"/>
                 <a:cs typeface="Cambria" pitchFamily="34" charset="-120"/>
               </a:rPr>
-              <a:t>Medications</a:t>
+              <a:t>Medical</a:t>
             </a:r>
             <a:endParaRPr lang="en-US" sz="2500" dirty="0"/>
           </a:p>
@@ -19698,11 +20922,11 @@
         <p:spPr>
           <a:xfrm>
             <a:off x="4937760" y="1783080"/>
-            <a:ext cx="6766560" cy="1325880"/>
+            <a:ext cx="6766560" cy="4206240"/>
           </a:xfrm>
           <a:prstGeom prst="roundRect">
             <a:avLst>
-              <a:gd name="adj" fmla="val 6897"/>
+              <a:gd name="adj" fmla="val 2609"/>
             </a:avLst>
           </a:prstGeom>
           <a:solidFill>
@@ -19725,79 +20949,69 @@
       </p:sp>
       <p:sp>
         <p:nvSpPr>
-          <p:cNvPr id="18" name="Shape 14"/>
-          <p:cNvSpPr/>
-          <p:nvPr/>
-        </p:nvSpPr>
-        <p:spPr>
-          <a:xfrm>
-            <a:off x="5257800" y="2084832"/>
-            <a:ext cx="731520" cy="731520"/>
-          </a:xfrm>
-          <a:prstGeom prst="ellipse">
-            <a:avLst/>
-          </a:prstGeom>
-          <a:solidFill>
-            <a:srgbClr val="FFFFFF"/>
-          </a:solidFill>
-          <a:ln w="12700">
-            <a:solidFill>
-              <a:srgbClr val="FBD8DF"/>
-            </a:solidFill>
-            <a:prstDash val="solid"/>
-          </a:ln>
-        </p:spPr>
-      </p:sp>
-      <p:pic>
-        <p:nvPicPr>
-          <p:cNvPr id="19" name="Image 2" descr="preencoded.png">    </p:cNvPr>
-          <p:cNvPicPr>
-            <a:picLocks noChangeAspect="1"/>
-          </p:cNvPicPr>
-          <p:nvPr/>
-        </p:nvPicPr>
-        <p:blipFill>
-          <a:blip r:embed="rId3"/>
-          <a:stretch>
-            <a:fillRect/>
-          </a:stretch>
-        </p:blipFill>
-        <p:spPr>
-          <a:xfrm>
-            <a:off x="5440680" y="2267712"/>
-            <a:ext cx="365760" cy="365760"/>
-          </a:xfrm>
-          <a:prstGeom prst="rect">
-            <a:avLst/>
-          </a:prstGeom>
-        </p:spPr>
-      </p:pic>
-      <p:sp>
-        <p:nvSpPr>
-          <p:cNvPr id="20" name="Text 15"/>
-          <p:cNvSpPr/>
-          <p:nvPr/>
-        </p:nvSpPr>
-        <p:spPr>
-          <a:xfrm>
-            <a:off x="6217920" y="2039112"/>
-            <a:ext cx="5120640" cy="457200"/>
-          </a:xfrm>
-          <a:prstGeom prst="rect">
-            <a:avLst/>
-          </a:prstGeom>
-          <a:noFill/>
-          <a:ln/>
-        </p:spPr>
-        <p:txBody>
-          <a:bodyPr wrap="square" lIns="0" tIns="0" rIns="0" bIns="0" rtlCol="0" anchor="t"/>
-          <a:lstStyle/>
-          <a:p>
-            <a:pPr algn="l" indent="0" marL="0">
-              <a:buNone/>
-            </a:pPr>
-            <a:r>
-              <a:rPr lang="en-US" sz="2400" b="1" dirty="0">
+          <p:cNvPr id="18" name="Text 14"/>
+          <p:cNvSpPr/>
+          <p:nvPr/>
+        </p:nvSpPr>
+        <p:spPr>
+          <a:xfrm>
+            <a:off x="5440680" y="2194560"/>
+            <a:ext cx="5852160" cy="274320"/>
+          </a:xfrm>
+          <a:prstGeom prst="rect">
+            <a:avLst/>
+          </a:prstGeom>
+          <a:noFill/>
+          <a:ln/>
+        </p:spPr>
+        <p:txBody>
+          <a:bodyPr wrap="square" rtlCol="0" anchor="t"/>
+          <a:lstStyle/>
+          <a:p>
+            <a:pPr algn="l" indent="0" marL="0">
+              <a:buNone/>
+            </a:pPr>
+            <a:r>
+              <a:rPr lang="en-US" sz="1250" b="1" spc="200" kern="0" dirty="0">
+                <a:solidFill>
+                  <a:srgbClr val="A4133C"/>
+                </a:solidFill>
+                <a:latin typeface="Calibri" pitchFamily="34" charset="0"/>
+                <a:ea typeface="Calibri" pitchFamily="34" charset="-122"/>
+                <a:cs typeface="Calibri" pitchFamily="34" charset="-120"/>
+              </a:rPr>
+              <a:t>KNOWN COMORBIDITY</a:t>
+            </a:r>
+            <a:endParaRPr lang="en-US" sz="1250" dirty="0"/>
+          </a:p>
+        </p:txBody>
+      </p:sp>
+      <p:sp>
+        <p:nvSpPr>
+          <p:cNvPr id="19" name="Text 15"/>
+          <p:cNvSpPr/>
+          <p:nvPr/>
+        </p:nvSpPr>
+        <p:spPr>
+          <a:xfrm>
+            <a:off x="5440680" y="2606040"/>
+            <a:ext cx="5852160" cy="822960"/>
+          </a:xfrm>
+          <a:prstGeom prst="rect">
+            <a:avLst/>
+          </a:prstGeom>
+          <a:noFill/>
+          <a:ln/>
+        </p:spPr>
+        <p:txBody>
+          <a:bodyPr wrap="square" rtlCol="0" anchor="t"/>
+          <a:lstStyle/>
+          <a:p>
+            <a:pPr algn="l" indent="0" marL="0">
+              <a:buNone/>
+            </a:pPr>
+            <a:r>
+              <a:rPr lang="en-US" sz="4400" b="1" dirty="0">
                 <a:solidFill>
                   <a:srgbClr val="2B2B33"/>
                 </a:solidFill>
@@ -19805,38 +21019,38 @@
                 <a:ea typeface="Cambria" pitchFamily="34" charset="-122"/>
                 <a:cs typeface="Cambria" pitchFamily="34" charset="-120"/>
               </a:rPr>
-              <a:t>Tab Vadil</a:t>
-            </a:r>
-            <a:endParaRPr lang="en-US" sz="2400" dirty="0"/>
-          </a:p>
-        </p:txBody>
-      </p:sp>
-      <p:sp>
-        <p:nvSpPr>
-          <p:cNvPr id="21" name="Text 16"/>
-          <p:cNvSpPr/>
-          <p:nvPr/>
-        </p:nvSpPr>
-        <p:spPr>
-          <a:xfrm>
-            <a:off x="6217920" y="2532888"/>
-            <a:ext cx="5120640" cy="365760"/>
-          </a:xfrm>
-          <a:prstGeom prst="rect">
-            <a:avLst/>
-          </a:prstGeom>
-          <a:noFill/>
-          <a:ln/>
-        </p:spPr>
-        <p:txBody>
-          <a:bodyPr wrap="square" lIns="0" tIns="0" rIns="0" bIns="0" rtlCol="0" anchor="t"/>
-          <a:lstStyle/>
-          <a:p>
-            <a:pPr algn="l" indent="0" marL="0">
-              <a:buNone/>
-            </a:pPr>
-            <a:r>
-              <a:rPr lang="en-US" sz="1450" i="1" dirty="0">
+              <a:t>Hypertension</a:t>
+            </a:r>
+            <a:endParaRPr lang="en-US" sz="4400" dirty="0"/>
+          </a:p>
+        </p:txBody>
+      </p:sp>
+      <p:sp>
+        <p:nvSpPr>
+          <p:cNvPr id="20" name="Text 16"/>
+          <p:cNvSpPr/>
+          <p:nvPr/>
+        </p:nvSpPr>
+        <p:spPr>
+          <a:xfrm>
+            <a:off x="5458968" y="3611880"/>
+            <a:ext cx="5760720" cy="457200"/>
+          </a:xfrm>
+          <a:prstGeom prst="rect">
+            <a:avLst/>
+          </a:prstGeom>
+          <a:noFill/>
+          <a:ln/>
+        </p:spPr>
+        <p:txBody>
+          <a:bodyPr wrap="square" rtlCol="0" anchor="t"/>
+          <a:lstStyle/>
+          <a:p>
+            <a:pPr algn="l" indent="0" marL="0">
+              <a:buNone/>
+            </a:pPr>
+            <a:r>
+              <a:rPr lang="en-US" sz="1700" i="1" dirty="0">
                 <a:solidFill>
                   <a:srgbClr val="6B6B76"/>
                 </a:solidFill>
@@ -19844,168 +21058,68 @@
                 <a:ea typeface="Calibri" pitchFamily="34" charset="-122"/>
                 <a:cs typeface="Calibri" pitchFamily="34" charset="-120"/>
               </a:rPr>
-              <a:t>Rate / rhythm control</a:t>
-            </a:r>
-            <a:endParaRPr lang="en-US" sz="1450" dirty="0"/>
-          </a:p>
-        </p:txBody>
-      </p:sp>
-      <p:sp>
-        <p:nvSpPr>
-          <p:cNvPr id="22" name="Shape 17"/>
-          <p:cNvSpPr/>
-          <p:nvPr/>
-        </p:nvSpPr>
-        <p:spPr>
-          <a:xfrm>
-            <a:off x="4937760" y="3291840"/>
-            <a:ext cx="6766560" cy="1325880"/>
+              <a:t>On oral antihypertensive medication</a:t>
+            </a:r>
+            <a:endParaRPr lang="en-US" sz="1700" dirty="0"/>
+          </a:p>
+        </p:txBody>
+      </p:sp>
+      <p:sp>
+        <p:nvSpPr>
+          <p:cNvPr id="21" name="Shape 17"/>
+          <p:cNvSpPr/>
+          <p:nvPr/>
+        </p:nvSpPr>
+        <p:spPr>
+          <a:xfrm>
+            <a:off x="5440680" y="4572000"/>
+            <a:ext cx="2148840" cy="566928"/>
           </a:xfrm>
           <a:prstGeom prst="roundRect">
             <a:avLst>
-              <a:gd name="adj" fmla="val 6897"/>
+              <a:gd name="adj" fmla="val 50000"/>
             </a:avLst>
           </a:prstGeom>
           <a:solidFill>
-            <a:srgbClr val="FFF0F3"/>
+            <a:srgbClr val="A4133C"/>
           </a:solidFill>
-          <a:ln w="12700">
-            <a:solidFill>
-              <a:srgbClr val="FBD8DF"/>
-            </a:solidFill>
-            <a:prstDash val="solid"/>
-          </a:ln>
-          <a:effectLst>
-            <a:outerShdw sx="100000" sy="100000" kx="0" ky="0" algn="bl" rotWithShape="0" blurRad="127000" dist="50800" dir="5400000">
-              <a:srgbClr val="C9A3AC">
-                <a:alpha val="45000"/>
-              </a:srgbClr>
-            </a:outerShdw>
-          </a:effectLst>
-        </p:spPr>
-      </p:sp>
-      <p:sp>
-        <p:nvSpPr>
-          <p:cNvPr id="23" name="Shape 18"/>
-          <p:cNvSpPr/>
-          <p:nvPr/>
-        </p:nvSpPr>
-        <p:spPr>
-          <a:xfrm>
-            <a:off x="5257800" y="3593592"/>
-            <a:ext cx="731520" cy="731520"/>
-          </a:xfrm>
-          <a:prstGeom prst="ellipse">
-            <a:avLst/>
-          </a:prstGeom>
-          <a:solidFill>
-            <a:srgbClr val="FFFFFF"/>
-          </a:solidFill>
-          <a:ln w="12700">
-            <a:solidFill>
-              <a:srgbClr val="FBD8DF"/>
-            </a:solidFill>
-            <a:prstDash val="solid"/>
-          </a:ln>
-        </p:spPr>
-      </p:sp>
-      <p:pic>
-        <p:nvPicPr>
-          <p:cNvPr id="24" name="Image 3" descr="preencoded.png">    </p:cNvPr>
-          <p:cNvPicPr>
-            <a:picLocks noChangeAspect="1"/>
-          </p:cNvPicPr>
-          <p:nvPr/>
-        </p:nvPicPr>
-        <p:blipFill>
-          <a:blip r:embed="rId4"/>
-          <a:stretch>
-            <a:fillRect/>
-          </a:stretch>
-        </p:blipFill>
-        <p:spPr>
-          <a:xfrm>
-            <a:off x="5440680" y="3776472"/>
-            <a:ext cx="365760" cy="365760"/>
-          </a:xfrm>
-          <a:prstGeom prst="rect">
-            <a:avLst/>
-          </a:prstGeom>
-        </p:spPr>
-      </p:pic>
-      <p:sp>
-        <p:nvSpPr>
-          <p:cNvPr id="25" name="Text 19"/>
-          <p:cNvSpPr/>
-          <p:nvPr/>
-        </p:nvSpPr>
-        <p:spPr>
-          <a:xfrm>
-            <a:off x="6217920" y="3547872"/>
-            <a:ext cx="5120640" cy="457200"/>
-          </a:xfrm>
-          <a:prstGeom prst="rect">
-            <a:avLst/>
-          </a:prstGeom>
-          <a:noFill/>
-          <a:ln/>
-        </p:spPr>
-        <p:txBody>
-          <a:bodyPr wrap="square" lIns="0" tIns="0" rIns="0" bIns="0" rtlCol="0" anchor="t"/>
-          <a:lstStyle/>
-          <a:p>
-            <a:pPr algn="l" indent="0" marL="0">
-              <a:buNone/>
-            </a:pPr>
-            <a:r>
-              <a:rPr lang="en-US" sz="2400" b="1" dirty="0">
-                <a:solidFill>
-                  <a:srgbClr val="2B2B33"/>
-                </a:solidFill>
-                <a:latin typeface="Cambria" pitchFamily="34" charset="0"/>
-                <a:ea typeface="Cambria" pitchFamily="34" charset="-122"/>
-                <a:cs typeface="Cambria" pitchFamily="34" charset="-120"/>
-              </a:rPr>
-              <a:t>Tab Rivaroxaban</a:t>
-            </a:r>
-            <a:endParaRPr lang="en-US" sz="2400" dirty="0"/>
-          </a:p>
-        </p:txBody>
-      </p:sp>
-      <p:sp>
-        <p:nvSpPr>
-          <p:cNvPr id="26" name="Text 20"/>
-          <p:cNvSpPr/>
-          <p:nvPr/>
-        </p:nvSpPr>
-        <p:spPr>
-          <a:xfrm>
-            <a:off x="6217920" y="4041648"/>
-            <a:ext cx="5120640" cy="365760"/>
-          </a:xfrm>
-          <a:prstGeom prst="rect">
-            <a:avLst/>
-          </a:prstGeom>
-          <a:noFill/>
-          <a:ln/>
-        </p:spPr>
-        <p:txBody>
-          <a:bodyPr wrap="square" lIns="0" tIns="0" rIns="0" bIns="0" rtlCol="0" anchor="t"/>
-          <a:lstStyle/>
-          <a:p>
-            <a:pPr algn="l" indent="0" marL="0">
-              <a:buNone/>
-            </a:pPr>
-            <a:r>
-              <a:rPr lang="en-US" sz="1450" i="1" dirty="0">
-                <a:solidFill>
-                  <a:srgbClr val="6B6B76"/>
-                </a:solidFill>
-                <a:latin typeface="Calibri" pitchFamily="34" charset="0"/>
-                <a:ea typeface="Calibri" pitchFamily="34" charset="-122"/>
-                <a:cs typeface="Calibri" pitchFamily="34" charset="-120"/>
-              </a:rPr>
-              <a:t>Oral anticoagulation</a:t>
+          <a:ln/>
+        </p:spPr>
+      </p:sp>
+      <p:sp>
+        <p:nvSpPr>
+          <p:cNvPr id="22" name="Text 18"/>
+          <p:cNvSpPr/>
+          <p:nvPr/>
+        </p:nvSpPr>
+        <p:spPr>
+          <a:xfrm>
+            <a:off x="5440680" y="4572000"/>
+            <a:ext cx="2148840" cy="566928"/>
+          </a:xfrm>
+          <a:prstGeom prst="rect">
+            <a:avLst/>
+          </a:prstGeom>
+          <a:noFill/>
+          <a:ln/>
+        </p:spPr>
+        <p:txBody>
+          <a:bodyPr wrap="square" rtlCol="0" anchor="ctr"/>
+          <a:lstStyle/>
+          <a:p>
+            <a:pPr algn="ctr" indent="0" marL="0">
+              <a:buNone/>
+            </a:pPr>
+            <a:r>
+              <a:rPr lang="en-US" sz="1450" b="1" dirty="0">
+                <a:solidFill>
+                  <a:srgbClr val="FFFFFF"/>
+                </a:solidFill>
+                <a:latin typeface="Calibri" pitchFamily="34" charset="0"/>
+                <a:ea typeface="Calibri" pitchFamily="34" charset="-122"/>
+                <a:cs typeface="Calibri" pitchFamily="34" charset="-120"/>
+              </a:rPr>
+              <a:t>HTN</a:t>
             </a:r>
             <a:endParaRPr lang="en-US" sz="1450" dirty="0"/>
           </a:p>
@@ -20013,89 +21127,7 @@
       </p:sp>
       <p:sp>
         <p:nvSpPr>
-          <p:cNvPr id="27" name="Shape 21"/>
-          <p:cNvSpPr/>
-          <p:nvPr/>
-        </p:nvSpPr>
-        <p:spPr>
-          <a:xfrm>
-            <a:off x="4937760" y="4800600"/>
-            <a:ext cx="6766560" cy="1188720"/>
-          </a:xfrm>
-          <a:prstGeom prst="roundRect">
-            <a:avLst>
-              <a:gd name="adj" fmla="val 7692"/>
-            </a:avLst>
-          </a:prstGeom>
-          <a:solidFill>
-            <a:srgbClr val="590D22"/>
-          </a:solidFill>
-          <a:ln/>
-          <a:effectLst>
-            <a:outerShdw sx="100000" sy="100000" kx="0" ky="0" algn="bl" rotWithShape="0" blurRad="127000" dist="50800" dir="5400000">
-              <a:srgbClr val="C9A3AC">
-                <a:alpha val="45000"/>
-              </a:srgbClr>
-            </a:outerShdw>
-          </a:effectLst>
-        </p:spPr>
-      </p:sp>
-      <p:sp>
-        <p:nvSpPr>
-          <p:cNvPr id="28" name="Text 22"/>
-          <p:cNvSpPr/>
-          <p:nvPr/>
-        </p:nvSpPr>
-        <p:spPr>
-          <a:xfrm>
-            <a:off x="5394960" y="4800600"/>
-            <a:ext cx="5852160" cy="1188720"/>
-          </a:xfrm>
-          <a:prstGeom prst="rect">
-            <a:avLst/>
-          </a:prstGeom>
-          <a:noFill/>
-          <a:ln/>
-        </p:spPr>
-        <p:txBody>
-          <a:bodyPr wrap="square" rtlCol="0" anchor="ctr"/>
-          <a:lstStyle/>
-          <a:p>
-            <a:pPr algn="l" indent="0" marL="0">
-              <a:buNone/>
-            </a:pPr>
-            <a:r>
-              <a:rPr lang="en-US" sz="1600" b="1" dirty="0">
-                <a:solidFill>
-                  <a:srgbClr val="FF4D6D"/>
-                </a:solidFill>
-                <a:latin typeface="Calibri" pitchFamily="34" charset="0"/>
-                <a:ea typeface="Calibri" pitchFamily="34" charset="-122"/>
-                <a:cs typeface="Calibri" pitchFamily="34" charset="-120"/>
-              </a:rPr>
-              <a:t>Purpose  </a:t>
-            </a:r>
-            <a:pPr algn="l" indent="0" marL="0">
-              <a:buNone/>
-            </a:pPr>
-            <a:r>
-              <a:rPr lang="en-US" sz="1600" dirty="0">
-                <a:solidFill>
-                  <a:srgbClr val="FBD8DF"/>
-                </a:solidFill>
-                <a:latin typeface="Calibri" pitchFamily="34" charset="0"/>
-                <a:ea typeface="Calibri" pitchFamily="34" charset="-122"/>
-                <a:cs typeface="Calibri" pitchFamily="34" charset="-120"/>
-              </a:rPr>
-              <a:t>Symptom control with stroke-risk protection</a:t>
-            </a:r>
-            <a:endParaRPr lang="en-US" sz="1600" dirty="0"/>
-          </a:p>
-        </p:txBody>
-      </p:sp>
-      <p:sp>
-        <p:nvSpPr>
-          <p:cNvPr id="29" name="Text 23"/>
+          <p:cNvPr id="23" name="Text 19"/>
           <p:cNvSpPr/>
           <p:nvPr/>
         </p:nvSpPr>
@@ -20134,7 +21166,7 @@
       </p:sp>
       <p:sp>
         <p:nvSpPr>
-          <p:cNvPr id="30" name="Text 24"/>
+          <p:cNvPr id="24" name="Text 20"/>
           <p:cNvSpPr/>
           <p:nvPr/>
         </p:nvSpPr>

</xml_diff>

<commit_message>
Split diagnosis into separate Differential and Final Diagnosis slides
Differential Diagnosis is now its own full-width slide (excluded
differentials with reasons), followed by a dedicated dark Final Diagnosis
slide (AF with RVR + supporting evidence). Case deck 20 slides, combined
38 slides.

Co-Authored-By: Claude Opus 4.8 <noreply@anthropic.com>
Claude-Session: https://claude.ai/code/session_01S7QW8AwqyMReKwuqyBkBBv
</commit_message>
<xml_diff>
--- a/presentations/Clinicopathological-Conference.pptx
+++ b/presentations/Clinicopathological-Conference.pptx
@@ -24,9 +24,10 @@
     <p:sldId id="272" r:id="rId18"/>
     <p:sldId id="273" r:id="rId19"/>
     <p:sldId id="274" r:id="rId20"/>
+    <p:sldId id="275" r:id="rId21"/>
   </p:sldIdLst>
   <p:notesMasterIdLst>
-    <p:notesMasterId r:id="rId21"/>
+    <p:notesMasterId r:id="rId22"/>
   </p:notesMasterIdLst>
   <p:sldSz cx="12191695" cy="6858000"/>
   <p:notesSz cx="6858000" cy="12191695"/>
@@ -1512,6 +1513,94 @@
             <a:fld id="{F7021451-1387-4CA6-816F-3879F97B5CBC}" type="slidenum">
               <a:rPr lang="en-US"/>
               <a:t>2</a:t>
+            </a:fld>
+            <a:endParaRPr lang="en-US"/>
+          </a:p>
+        </p:txBody>
+      </p:sp>
+    </p:spTree>
+    <p:extLst>
+      <p:ext uri="{BB962C8B-B14F-4D97-AF65-F5344CB8AC3E}">
+        <p14:creationId xmlns:p14="http://schemas.microsoft.com/office/powerpoint/2010/main" val="1024086991"/>
+      </p:ext>
+    </p:extLst>
+  </p:cSld>
+  <p:clrMapOvr>
+    <a:masterClrMapping/>
+  </p:clrMapOvr>
+</p:notes>
+</file>
+
+<file path=ppt/notesSlides/notesSlide20.xml><?xml version="1.0" encoding="utf-8"?>
+<p:notes xmlns:a="http://schemas.openxmlformats.org/drawingml/2006/main" xmlns:r="http://schemas.openxmlformats.org/officeDocument/2006/relationships" xmlns:p="http://schemas.openxmlformats.org/presentationml/2006/main">
+  <p:cSld>
+    <p:spTree>
+      <p:nvGrpSpPr>
+        <p:cNvPr id="1" name=""/>
+        <p:cNvGrpSpPr/>
+        <p:nvPr/>
+      </p:nvGrpSpPr>
+      <p:grpSpPr>
+        <a:xfrm>
+          <a:off x="0" y="0"/>
+          <a:ext cx="0" cy="0"/>
+          <a:chOff x="0" y="0"/>
+          <a:chExt cx="0" cy="0"/>
+        </a:xfrm>
+      </p:grpSpPr>
+      <p:sp>
+        <p:nvSpPr>
+          <p:cNvPr id="2" name="Slide Image Placeholder 1"/>
+          <p:cNvSpPr>
+            <a:spLocks noGrp="1" noRot="1" noChangeAspect="1"/>
+          </p:cNvSpPr>
+          <p:nvPr>
+            <p:ph type="sldImg"/>
+          </p:nvPr>
+        </p:nvSpPr>
+        <p:spPr/>
+      </p:sp>
+      <p:sp>
+        <p:nvSpPr>
+          <p:cNvPr id="3" name="Notes Placeholder 2"/>
+          <p:cNvSpPr>
+            <a:spLocks noGrp="1"/>
+          </p:cNvSpPr>
+          <p:nvPr>
+            <p:ph type="body" idx="1"/>
+          </p:nvPr>
+        </p:nvSpPr>
+        <p:spPr/>
+        <p:txBody>
+          <a:bodyPr/>
+          <a:lstStyle/>
+          <a:p>
+            <a:r>
+              <a:rPr lang="en-US" dirty="0"/>
+              <a:t/>
+            </a:r>
+            <a:endParaRPr lang="en-US" dirty="0"/>
+          </a:p>
+        </p:txBody>
+      </p:sp>
+      <p:sp>
+        <p:nvSpPr>
+          <p:cNvPr id="4" name="Slide Number Placeholder 3"/>
+          <p:cNvSpPr>
+            <a:spLocks noGrp="1"/>
+          </p:cNvSpPr>
+          <p:nvPr>
+            <p:ph type="sldNum" sz="quarter" idx="10"/>
+          </p:nvPr>
+        </p:nvSpPr>
+        <p:spPr/>
+        <p:txBody>
+          <a:bodyPr/>
+          <a:lstStyle/>
+          <a:p>
+            <a:fld id="{F7021451-1387-4CA6-816F-3879F97B5CBC}" type="slidenum">
+              <a:rPr lang="en-US"/>
+              <a:t>20</a:t>
             </a:fld>
             <a:endParaRPr lang="en-US"/>
           </a:p>
@@ -14619,7 +14708,7 @@
                 <a:ea typeface="Cambria" pitchFamily="34" charset="-122"/>
                 <a:cs typeface="Cambria" pitchFamily="34" charset="-120"/>
               </a:rPr>
-              <a:t>Differential &amp; Final Diagnosis</a:t>
+              <a:t>Differential Diagnosis</a:t>
             </a:r>
             <a:endParaRPr lang="en-US" sz="3000" dirty="0"/>
           </a:p>
@@ -14627,18 +14716,57 @@
       </p:sp>
       <p:sp>
         <p:nvSpPr>
-          <p:cNvPr id="6" name="Shape 3"/>
-          <p:cNvSpPr/>
-          <p:nvPr/>
-        </p:nvSpPr>
-        <p:spPr>
-          <a:xfrm>
-            <a:off x="502920" y="1783080"/>
-            <a:ext cx="6355080" cy="4206240"/>
+          <p:cNvPr id="6" name="Text 3"/>
+          <p:cNvSpPr/>
+          <p:nvPr/>
+        </p:nvSpPr>
+        <p:spPr>
+          <a:xfrm>
+            <a:off x="548640" y="1481328"/>
+            <a:ext cx="10972800" cy="274320"/>
+          </a:xfrm>
+          <a:prstGeom prst="rect">
+            <a:avLst/>
+          </a:prstGeom>
+          <a:noFill/>
+          <a:ln/>
+        </p:spPr>
+        <p:txBody>
+          <a:bodyPr wrap="square" rtlCol="0" anchor="t"/>
+          <a:lstStyle/>
+          <a:p>
+            <a:pPr algn="l" indent="0" marL="0">
+              <a:buNone/>
+            </a:pPr>
+            <a:r>
+              <a:rPr lang="en-US" sz="1350" i="1" dirty="0">
+                <a:solidFill>
+                  <a:srgbClr val="6B6B76"/>
+                </a:solidFill>
+                <a:latin typeface="Calibri" pitchFamily="34" charset="0"/>
+                <a:ea typeface="Calibri" pitchFamily="34" charset="-122"/>
+                <a:cs typeface="Calibri" pitchFamily="34" charset="-120"/>
+              </a:rPr>
+              <a:t>Causes of an irregular tachycardia — each excluded on ECG grounds</a:t>
+            </a:r>
+            <a:endParaRPr lang="en-US" sz="1350" dirty="0"/>
+          </a:p>
+        </p:txBody>
+      </p:sp>
+      <p:sp>
+        <p:nvSpPr>
+          <p:cNvPr id="7" name="Shape 4"/>
+          <p:cNvSpPr/>
+          <p:nvPr/>
+        </p:nvSpPr>
+        <p:spPr>
+          <a:xfrm>
+            <a:off x="502920" y="1874520"/>
+            <a:ext cx="11183112" cy="731520"/>
           </a:xfrm>
           <a:prstGeom prst="roundRect">
             <a:avLst>
-              <a:gd name="adj" fmla="val 2609"/>
+              <a:gd name="adj" fmla="val 12500"/>
             </a:avLst>
           </a:prstGeom>
           <a:solidFill>
@@ -14661,91 +14789,13 @@
       </p:sp>
       <p:sp>
         <p:nvSpPr>
-          <p:cNvPr id="7" name="Text 4"/>
-          <p:cNvSpPr/>
-          <p:nvPr/>
-        </p:nvSpPr>
-        <p:spPr>
-          <a:xfrm>
-            <a:off x="822960" y="2029968"/>
-            <a:ext cx="5669280" cy="274320"/>
-          </a:xfrm>
-          <a:prstGeom prst="rect">
-            <a:avLst/>
-          </a:prstGeom>
-          <a:noFill/>
-          <a:ln/>
-        </p:spPr>
-        <p:txBody>
-          <a:bodyPr wrap="square" rtlCol="0" anchor="t"/>
-          <a:lstStyle/>
-          <a:p>
-            <a:pPr algn="l" indent="0" marL="0">
-              <a:buNone/>
-            </a:pPr>
-            <a:r>
-              <a:rPr lang="en-US" sz="1250" b="1" spc="150" kern="0" dirty="0">
-                <a:solidFill>
-                  <a:srgbClr val="A4133C"/>
-                </a:solidFill>
-                <a:latin typeface="Calibri" pitchFamily="34" charset="0"/>
-                <a:ea typeface="Calibri" pitchFamily="34" charset="-122"/>
-                <a:cs typeface="Calibri" pitchFamily="34" charset="-120"/>
-              </a:rPr>
-              <a:t>DIFFERENTIALS CONSIDERED</a:t>
-            </a:r>
-            <a:endParaRPr lang="en-US" sz="1250" dirty="0"/>
-          </a:p>
-        </p:txBody>
-      </p:sp>
-      <p:sp>
-        <p:nvSpPr>
-          <p:cNvPr id="8" name="Text 5"/>
-          <p:cNvSpPr/>
-          <p:nvPr/>
-        </p:nvSpPr>
-        <p:spPr>
-          <a:xfrm>
-            <a:off x="822960" y="2304288"/>
-            <a:ext cx="5669280" cy="274320"/>
-          </a:xfrm>
-          <a:prstGeom prst="rect">
-            <a:avLst/>
-          </a:prstGeom>
-          <a:noFill/>
-          <a:ln/>
-        </p:spPr>
-        <p:txBody>
-          <a:bodyPr wrap="square" rtlCol="0" anchor="t"/>
-          <a:lstStyle/>
-          <a:p>
-            <a:pPr algn="l" indent="0" marL="0">
-              <a:buNone/>
-            </a:pPr>
-            <a:r>
-              <a:rPr lang="en-US" sz="1250" i="1" dirty="0">
-                <a:solidFill>
-                  <a:srgbClr val="6B6B76"/>
-                </a:solidFill>
-                <a:latin typeface="Calibri" pitchFamily="34" charset="0"/>
-                <a:ea typeface="Calibri" pitchFamily="34" charset="-122"/>
-                <a:cs typeface="Calibri" pitchFamily="34" charset="-120"/>
-              </a:rPr>
-              <a:t>Causes of an irregular tachycardia</a:t>
-            </a:r>
-            <a:endParaRPr lang="en-US" sz="1250" dirty="0"/>
-          </a:p>
-        </p:txBody>
-      </p:sp>
-      <p:sp>
-        <p:nvSpPr>
-          <p:cNvPr id="9" name="Shape 6"/>
-          <p:cNvSpPr/>
-          <p:nvPr/>
-        </p:nvSpPr>
-        <p:spPr>
-          <a:xfrm>
-            <a:off x="868680" y="2779776"/>
+          <p:cNvPr id="8" name="Shape 5"/>
+          <p:cNvSpPr/>
+          <p:nvPr/>
+        </p:nvSpPr>
+        <p:spPr>
+          <a:xfrm>
+            <a:off x="777240" y="2048256"/>
             <a:ext cx="384048" cy="384048"/>
           </a:xfrm>
           <a:prstGeom prst="ellipse">
@@ -14764,7 +14814,7 @@
       </p:sp>
       <p:pic>
         <p:nvPicPr>
-          <p:cNvPr id="10" name="Image 1" descr="preencoded.png">    </p:cNvPr>
+          <p:cNvPr id="9" name="Image 1" descr="preencoded.png">    </p:cNvPr>
           <p:cNvPicPr>
             <a:picLocks noChangeAspect="1"/>
           </p:cNvPicPr>
@@ -14778,7 +14828,7 @@
         </p:blipFill>
         <p:spPr>
           <a:xfrm>
-            <a:off x="941832" y="2852928"/>
+            <a:off x="850392" y="2121408"/>
             <a:ext cx="237744" cy="237744"/>
           </a:xfrm>
           <a:prstGeom prst="rect">
@@ -14788,30 +14838,30 @@
       </p:pic>
       <p:sp>
         <p:nvSpPr>
-          <p:cNvPr id="11" name="Text 7"/>
-          <p:cNvSpPr/>
-          <p:nvPr/>
-        </p:nvSpPr>
-        <p:spPr>
-          <a:xfrm>
-            <a:off x="1417320" y="2706624"/>
-            <a:ext cx="5212080" cy="292608"/>
-          </a:xfrm>
-          <a:prstGeom prst="rect">
-            <a:avLst/>
-          </a:prstGeom>
-          <a:noFill/>
-          <a:ln/>
-        </p:spPr>
-        <p:txBody>
-          <a:bodyPr wrap="square" lIns="0" tIns="0" rIns="0" bIns="0" rtlCol="0" anchor="t"/>
-          <a:lstStyle/>
-          <a:p>
-            <a:pPr algn="l" indent="0" marL="0">
-              <a:buNone/>
-            </a:pPr>
-            <a:r>
-              <a:rPr lang="en-US" sz="1550" b="1" dirty="0">
+          <p:cNvPr id="10" name="Text 6"/>
+          <p:cNvSpPr/>
+          <p:nvPr/>
+        </p:nvSpPr>
+        <p:spPr>
+          <a:xfrm>
+            <a:off x="1371600" y="1874520"/>
+            <a:ext cx="3977640" cy="731520"/>
+          </a:xfrm>
+          <a:prstGeom prst="rect">
+            <a:avLst/>
+          </a:prstGeom>
+          <a:noFill/>
+          <a:ln/>
+        </p:spPr>
+        <p:txBody>
+          <a:bodyPr wrap="square" lIns="0" tIns="0" rIns="0" bIns="0" rtlCol="0" anchor="ctr"/>
+          <a:lstStyle/>
+          <a:p>
+            <a:pPr algn="l" indent="0" marL="0">
+              <a:buNone/>
+            </a:pPr>
+            <a:r>
+              <a:rPr lang="en-US" sz="1700" b="1" dirty="0">
                 <a:solidFill>
                   <a:srgbClr val="2B2B33"/>
                 </a:solidFill>
@@ -14821,9 +14871,32 @@
               </a:rPr>
               <a:t>Atrial flutter</a:t>
             </a:r>
-            <a:endParaRPr lang="en-US" sz="1550" dirty="0"/>
-          </a:p>
-        </p:txBody>
+            <a:endParaRPr lang="en-US" sz="1700" dirty="0"/>
+          </a:p>
+        </p:txBody>
+      </p:sp>
+      <p:sp>
+        <p:nvSpPr>
+          <p:cNvPr id="11" name="Shape 7"/>
+          <p:cNvSpPr/>
+          <p:nvPr/>
+        </p:nvSpPr>
+        <p:spPr>
+          <a:xfrm>
+            <a:off x="5440680" y="2020824"/>
+            <a:ext cx="0" cy="438912"/>
+          </a:xfrm>
+          <a:prstGeom prst="line">
+            <a:avLst/>
+          </a:prstGeom>
+          <a:noFill/>
+          <a:ln w="12700">
+            <a:solidFill>
+              <a:srgbClr val="FBD8DF"/>
+            </a:solidFill>
+            <a:prstDash val="solid"/>
+          </a:ln>
+        </p:spPr>
       </p:sp>
       <p:sp>
         <p:nvSpPr>
@@ -14833,24 +14906,24 @@
         </p:nvSpPr>
         <p:spPr>
           <a:xfrm>
-            <a:off x="1417320" y="2999232"/>
-            <a:ext cx="5257800" cy="274320"/>
-          </a:xfrm>
-          <a:prstGeom prst="rect">
-            <a:avLst/>
-          </a:prstGeom>
-          <a:noFill/>
-          <a:ln/>
-        </p:spPr>
-        <p:txBody>
-          <a:bodyPr wrap="square" lIns="0" tIns="0" rIns="0" bIns="0" rtlCol="0" anchor="t"/>
-          <a:lstStyle/>
-          <a:p>
-            <a:pPr algn="l" indent="0" marL="0">
-              <a:buNone/>
-            </a:pPr>
-            <a:r>
-              <a:rPr lang="en-US" sz="1200" dirty="0">
+            <a:off x="5669280" y="1874520"/>
+            <a:ext cx="5806440" cy="731520"/>
+          </a:xfrm>
+          <a:prstGeom prst="rect">
+            <a:avLst/>
+          </a:prstGeom>
+          <a:noFill/>
+          <a:ln/>
+        </p:spPr>
+        <p:txBody>
+          <a:bodyPr wrap="square" lIns="0" tIns="0" rIns="0" bIns="0" rtlCol="0" anchor="ctr"/>
+          <a:lstStyle/>
+          <a:p>
+            <a:pPr algn="l" indent="0" marL="0">
+              <a:buNone/>
+            </a:pPr>
+            <a:r>
+              <a:rPr lang="en-US" sz="1400" dirty="0">
                 <a:solidFill>
                   <a:srgbClr val="6B6B76"/>
                 </a:solidFill>
@@ -14858,9 +14931,9 @@
                 <a:ea typeface="Calibri" pitchFamily="34" charset="-122"/>
                 <a:cs typeface="Calibri" pitchFamily="34" charset="-120"/>
               </a:rPr>
-              <a:t>No sawtooth flutter waves; R–R irregular</a:t>
-            </a:r>
-            <a:endParaRPr lang="en-US" sz="1200" dirty="0"/>
+              <a:t>No sawtooth flutter waves; R–R interval is irregular</a:t>
+            </a:r>
+            <a:endParaRPr lang="en-US" sz="1400" dirty="0"/>
           </a:p>
         </p:txBody>
       </p:sp>
@@ -14872,7 +14945,41 @@
         </p:nvSpPr>
         <p:spPr>
           <a:xfrm>
-            <a:off x="868680" y="3401568"/>
+            <a:off x="502920" y="2688336"/>
+            <a:ext cx="11183112" cy="731520"/>
+          </a:xfrm>
+          <a:prstGeom prst="roundRect">
+            <a:avLst>
+              <a:gd name="adj" fmla="val 12500"/>
+            </a:avLst>
+          </a:prstGeom>
+          <a:solidFill>
+            <a:srgbClr val="FFF0F3"/>
+          </a:solidFill>
+          <a:ln w="12700">
+            <a:solidFill>
+              <a:srgbClr val="FBD8DF"/>
+            </a:solidFill>
+            <a:prstDash val="solid"/>
+          </a:ln>
+          <a:effectLst>
+            <a:outerShdw sx="100000" sy="100000" kx="0" ky="0" algn="bl" rotWithShape="0" blurRad="127000" dist="50800" dir="5400000">
+              <a:srgbClr val="C9A3AC">
+                <a:alpha val="45000"/>
+              </a:srgbClr>
+            </a:outerShdw>
+          </a:effectLst>
+        </p:spPr>
+      </p:sp>
+      <p:sp>
+        <p:nvSpPr>
+          <p:cNvPr id="14" name="Shape 10"/>
+          <p:cNvSpPr/>
+          <p:nvPr/>
+        </p:nvSpPr>
+        <p:spPr>
+          <a:xfrm>
+            <a:off x="777240" y="2862072"/>
             <a:ext cx="384048" cy="384048"/>
           </a:xfrm>
           <a:prstGeom prst="ellipse">
@@ -14891,7 +14998,7 @@
       </p:sp>
       <p:pic>
         <p:nvPicPr>
-          <p:cNvPr id="14" name="Image 2" descr="preencoded.png">    </p:cNvPr>
+          <p:cNvPr id="15" name="Image 2" descr="preencoded.png">    </p:cNvPr>
           <p:cNvPicPr>
             <a:picLocks noChangeAspect="1"/>
           </p:cNvPicPr>
@@ -14905,7 +15012,7 @@
         </p:blipFill>
         <p:spPr>
           <a:xfrm>
-            <a:off x="941832" y="3474720"/>
+            <a:off x="850392" y="2935224"/>
             <a:ext cx="237744" cy="237744"/>
           </a:xfrm>
           <a:prstGeom prst="rect">
@@ -14915,30 +15022,30 @@
       </p:pic>
       <p:sp>
         <p:nvSpPr>
-          <p:cNvPr id="15" name="Text 10"/>
-          <p:cNvSpPr/>
-          <p:nvPr/>
-        </p:nvSpPr>
-        <p:spPr>
-          <a:xfrm>
-            <a:off x="1417320" y="3328416"/>
-            <a:ext cx="5212080" cy="292608"/>
-          </a:xfrm>
-          <a:prstGeom prst="rect">
-            <a:avLst/>
-          </a:prstGeom>
-          <a:noFill/>
-          <a:ln/>
-        </p:spPr>
-        <p:txBody>
-          <a:bodyPr wrap="square" lIns="0" tIns="0" rIns="0" bIns="0" rtlCol="0" anchor="t"/>
-          <a:lstStyle/>
-          <a:p>
-            <a:pPr algn="l" indent="0" marL="0">
-              <a:buNone/>
-            </a:pPr>
-            <a:r>
-              <a:rPr lang="en-US" sz="1550" b="1" dirty="0">
+          <p:cNvPr id="16" name="Text 11"/>
+          <p:cNvSpPr/>
+          <p:nvPr/>
+        </p:nvSpPr>
+        <p:spPr>
+          <a:xfrm>
+            <a:off x="1371600" y="2688336"/>
+            <a:ext cx="3977640" cy="731520"/>
+          </a:xfrm>
+          <a:prstGeom prst="rect">
+            <a:avLst/>
+          </a:prstGeom>
+          <a:noFill/>
+          <a:ln/>
+        </p:spPr>
+        <p:txBody>
+          <a:bodyPr wrap="square" lIns="0" tIns="0" rIns="0" bIns="0" rtlCol="0" anchor="ctr"/>
+          <a:lstStyle/>
+          <a:p>
+            <a:pPr algn="l" indent="0" marL="0">
+              <a:buNone/>
+            </a:pPr>
+            <a:r>
+              <a:rPr lang="en-US" sz="1700" b="1" dirty="0">
                 <a:solidFill>
                   <a:srgbClr val="2B2B33"/>
                 </a:solidFill>
@@ -14948,36 +15055,59 @@
               </a:rPr>
               <a:t>Multifocal atrial tachycardia</a:t>
             </a:r>
-            <a:endParaRPr lang="en-US" sz="1550" dirty="0"/>
-          </a:p>
-        </p:txBody>
-      </p:sp>
-      <p:sp>
-        <p:nvSpPr>
-          <p:cNvPr id="16" name="Text 11"/>
-          <p:cNvSpPr/>
-          <p:nvPr/>
-        </p:nvSpPr>
-        <p:spPr>
-          <a:xfrm>
-            <a:off x="1417320" y="3621024"/>
-            <a:ext cx="5257800" cy="274320"/>
-          </a:xfrm>
-          <a:prstGeom prst="rect">
-            <a:avLst/>
-          </a:prstGeom>
-          <a:noFill/>
-          <a:ln/>
-        </p:spPr>
-        <p:txBody>
-          <a:bodyPr wrap="square" lIns="0" tIns="0" rIns="0" bIns="0" rtlCol="0" anchor="t"/>
-          <a:lstStyle/>
-          <a:p>
-            <a:pPr algn="l" indent="0" marL="0">
-              <a:buNone/>
-            </a:pPr>
-            <a:r>
-              <a:rPr lang="en-US" sz="1200" dirty="0">
+            <a:endParaRPr lang="en-US" sz="1700" dirty="0"/>
+          </a:p>
+        </p:txBody>
+      </p:sp>
+      <p:sp>
+        <p:nvSpPr>
+          <p:cNvPr id="17" name="Shape 12"/>
+          <p:cNvSpPr/>
+          <p:nvPr/>
+        </p:nvSpPr>
+        <p:spPr>
+          <a:xfrm>
+            <a:off x="5440680" y="2834640"/>
+            <a:ext cx="0" cy="438912"/>
+          </a:xfrm>
+          <a:prstGeom prst="line">
+            <a:avLst/>
+          </a:prstGeom>
+          <a:noFill/>
+          <a:ln w="12700">
+            <a:solidFill>
+              <a:srgbClr val="FBD8DF"/>
+            </a:solidFill>
+            <a:prstDash val="solid"/>
+          </a:ln>
+        </p:spPr>
+      </p:sp>
+      <p:sp>
+        <p:nvSpPr>
+          <p:cNvPr id="18" name="Text 13"/>
+          <p:cNvSpPr/>
+          <p:nvPr/>
+        </p:nvSpPr>
+        <p:spPr>
+          <a:xfrm>
+            <a:off x="5669280" y="2688336"/>
+            <a:ext cx="5806440" cy="731520"/>
+          </a:xfrm>
+          <a:prstGeom prst="rect">
+            <a:avLst/>
+          </a:prstGeom>
+          <a:noFill/>
+          <a:ln/>
+        </p:spPr>
+        <p:txBody>
+          <a:bodyPr wrap="square" lIns="0" tIns="0" rIns="0" bIns="0" rtlCol="0" anchor="ctr"/>
+          <a:lstStyle/>
+          <a:p>
+            <a:pPr algn="l" indent="0" marL="0">
+              <a:buNone/>
+            </a:pPr>
+            <a:r>
+              <a:rPr lang="en-US" sz="1400" dirty="0">
                 <a:solidFill>
                   <a:srgbClr val="6B6B76"/>
                 </a:solidFill>
@@ -14985,21 +15115,55 @@
                 <a:ea typeface="Calibri" pitchFamily="34" charset="-122"/>
                 <a:cs typeface="Calibri" pitchFamily="34" charset="-120"/>
               </a:rPr>
-              <a:t>No ≥ 3 differing P-wave morphologies</a:t>
-            </a:r>
-            <a:endParaRPr lang="en-US" sz="1200" dirty="0"/>
-          </a:p>
-        </p:txBody>
-      </p:sp>
-      <p:sp>
-        <p:nvSpPr>
-          <p:cNvPr id="17" name="Shape 12"/>
-          <p:cNvSpPr/>
-          <p:nvPr/>
-        </p:nvSpPr>
-        <p:spPr>
-          <a:xfrm>
-            <a:off x="868680" y="4023360"/>
+              <a:t>No ≥ 3 differing P-wave morphologies present</a:t>
+            </a:r>
+            <a:endParaRPr lang="en-US" sz="1400" dirty="0"/>
+          </a:p>
+        </p:txBody>
+      </p:sp>
+      <p:sp>
+        <p:nvSpPr>
+          <p:cNvPr id="19" name="Shape 14"/>
+          <p:cNvSpPr/>
+          <p:nvPr/>
+        </p:nvSpPr>
+        <p:spPr>
+          <a:xfrm>
+            <a:off x="502920" y="3502152"/>
+            <a:ext cx="11183112" cy="731520"/>
+          </a:xfrm>
+          <a:prstGeom prst="roundRect">
+            <a:avLst>
+              <a:gd name="adj" fmla="val 12500"/>
+            </a:avLst>
+          </a:prstGeom>
+          <a:solidFill>
+            <a:srgbClr val="FFF0F3"/>
+          </a:solidFill>
+          <a:ln w="12700">
+            <a:solidFill>
+              <a:srgbClr val="FBD8DF"/>
+            </a:solidFill>
+            <a:prstDash val="solid"/>
+          </a:ln>
+          <a:effectLst>
+            <a:outerShdw sx="100000" sy="100000" kx="0" ky="0" algn="bl" rotWithShape="0" blurRad="127000" dist="50800" dir="5400000">
+              <a:srgbClr val="C9A3AC">
+                <a:alpha val="45000"/>
+              </a:srgbClr>
+            </a:outerShdw>
+          </a:effectLst>
+        </p:spPr>
+      </p:sp>
+      <p:sp>
+        <p:nvSpPr>
+          <p:cNvPr id="20" name="Shape 15"/>
+          <p:cNvSpPr/>
+          <p:nvPr/>
+        </p:nvSpPr>
+        <p:spPr>
+          <a:xfrm>
+            <a:off x="777240" y="3675888"/>
             <a:ext cx="384048" cy="384048"/>
           </a:xfrm>
           <a:prstGeom prst="ellipse">
@@ -15018,7 +15182,7 @@
       </p:sp>
       <p:pic>
         <p:nvPicPr>
-          <p:cNvPr id="18" name="Image 3" descr="preencoded.png">    </p:cNvPr>
+          <p:cNvPr id="21" name="Image 3" descr="preencoded.png">    </p:cNvPr>
           <p:cNvPicPr>
             <a:picLocks noChangeAspect="1"/>
           </p:cNvPicPr>
@@ -15032,7 +15196,7 @@
         </p:blipFill>
         <p:spPr>
           <a:xfrm>
-            <a:off x="941832" y="4096512"/>
+            <a:off x="850392" y="3749040"/>
             <a:ext cx="237744" cy="237744"/>
           </a:xfrm>
           <a:prstGeom prst="rect">
@@ -15042,30 +15206,30 @@
       </p:pic>
       <p:sp>
         <p:nvSpPr>
-          <p:cNvPr id="19" name="Text 13"/>
-          <p:cNvSpPr/>
-          <p:nvPr/>
-        </p:nvSpPr>
-        <p:spPr>
-          <a:xfrm>
-            <a:off x="1417320" y="3950208"/>
-            <a:ext cx="5212080" cy="292608"/>
-          </a:xfrm>
-          <a:prstGeom prst="rect">
-            <a:avLst/>
-          </a:prstGeom>
-          <a:noFill/>
-          <a:ln/>
-        </p:spPr>
-        <p:txBody>
-          <a:bodyPr wrap="square" lIns="0" tIns="0" rIns="0" bIns="0" rtlCol="0" anchor="t"/>
-          <a:lstStyle/>
-          <a:p>
-            <a:pPr algn="l" indent="0" marL="0">
-              <a:buNone/>
-            </a:pPr>
-            <a:r>
-              <a:rPr lang="en-US" sz="1550" b="1" dirty="0">
+          <p:cNvPr id="22" name="Text 16"/>
+          <p:cNvSpPr/>
+          <p:nvPr/>
+        </p:nvSpPr>
+        <p:spPr>
+          <a:xfrm>
+            <a:off x="1371600" y="3502152"/>
+            <a:ext cx="3977640" cy="731520"/>
+          </a:xfrm>
+          <a:prstGeom prst="rect">
+            <a:avLst/>
+          </a:prstGeom>
+          <a:noFill/>
+          <a:ln/>
+        </p:spPr>
+        <p:txBody>
+          <a:bodyPr wrap="square" lIns="0" tIns="0" rIns="0" bIns="0" rtlCol="0" anchor="ctr"/>
+          <a:lstStyle/>
+          <a:p>
+            <a:pPr algn="l" indent="0" marL="0">
+              <a:buNone/>
+            </a:pPr>
+            <a:r>
+              <a:rPr lang="en-US" sz="1700" b="1" dirty="0">
                 <a:solidFill>
                   <a:srgbClr val="2B2B33"/>
                 </a:solidFill>
@@ -15075,36 +15239,59 @@
               </a:rPr>
               <a:t>Frequent atrial ectopics</a:t>
             </a:r>
-            <a:endParaRPr lang="en-US" sz="1550" dirty="0"/>
-          </a:p>
-        </p:txBody>
-      </p:sp>
-      <p:sp>
-        <p:nvSpPr>
-          <p:cNvPr id="20" name="Text 14"/>
-          <p:cNvSpPr/>
-          <p:nvPr/>
-        </p:nvSpPr>
-        <p:spPr>
-          <a:xfrm>
-            <a:off x="1417320" y="4242816"/>
-            <a:ext cx="5257800" cy="274320"/>
-          </a:xfrm>
-          <a:prstGeom prst="rect">
-            <a:avLst/>
-          </a:prstGeom>
-          <a:noFill/>
-          <a:ln/>
-        </p:spPr>
-        <p:txBody>
-          <a:bodyPr wrap="square" lIns="0" tIns="0" rIns="0" bIns="0" rtlCol="0" anchor="t"/>
-          <a:lstStyle/>
-          <a:p>
-            <a:pPr algn="l" indent="0" marL="0">
-              <a:buNone/>
-            </a:pPr>
-            <a:r>
-              <a:rPr lang="en-US" sz="1200" dirty="0">
+            <a:endParaRPr lang="en-US" sz="1700" dirty="0"/>
+          </a:p>
+        </p:txBody>
+      </p:sp>
+      <p:sp>
+        <p:nvSpPr>
+          <p:cNvPr id="23" name="Shape 17"/>
+          <p:cNvSpPr/>
+          <p:nvPr/>
+        </p:nvSpPr>
+        <p:spPr>
+          <a:xfrm>
+            <a:off x="5440680" y="3648456"/>
+            <a:ext cx="0" cy="438912"/>
+          </a:xfrm>
+          <a:prstGeom prst="line">
+            <a:avLst/>
+          </a:prstGeom>
+          <a:noFill/>
+          <a:ln w="12700">
+            <a:solidFill>
+              <a:srgbClr val="FBD8DF"/>
+            </a:solidFill>
+            <a:prstDash val="solid"/>
+          </a:ln>
+        </p:spPr>
+      </p:sp>
+      <p:sp>
+        <p:nvSpPr>
+          <p:cNvPr id="24" name="Text 18"/>
+          <p:cNvSpPr/>
+          <p:nvPr/>
+        </p:nvSpPr>
+        <p:spPr>
+          <a:xfrm>
+            <a:off x="5669280" y="3502152"/>
+            <a:ext cx="5806440" cy="731520"/>
+          </a:xfrm>
+          <a:prstGeom prst="rect">
+            <a:avLst/>
+          </a:prstGeom>
+          <a:noFill/>
+          <a:ln/>
+        </p:spPr>
+        <p:txBody>
+          <a:bodyPr wrap="square" lIns="0" tIns="0" rIns="0" bIns="0" rtlCol="0" anchor="ctr"/>
+          <a:lstStyle/>
+          <a:p>
+            <a:pPr algn="l" indent="0" marL="0">
+              <a:buNone/>
+            </a:pPr>
+            <a:r>
+              <a:rPr lang="en-US" sz="1400" dirty="0">
                 <a:solidFill>
                   <a:srgbClr val="6B6B76"/>
                 </a:solidFill>
@@ -15112,21 +15299,55 @@
                 <a:ea typeface="Calibri" pitchFamily="34" charset="-122"/>
                 <a:cs typeface="Calibri" pitchFamily="34" charset="-120"/>
               </a:rPr>
-              <a:t>No discrete P waves before each QRS</a:t>
-            </a:r>
-            <a:endParaRPr lang="en-US" sz="1200" dirty="0"/>
-          </a:p>
-        </p:txBody>
-      </p:sp>
-      <p:sp>
-        <p:nvSpPr>
-          <p:cNvPr id="21" name="Shape 15"/>
-          <p:cNvSpPr/>
-          <p:nvPr/>
-        </p:nvSpPr>
-        <p:spPr>
-          <a:xfrm>
-            <a:off x="868680" y="4645152"/>
+              <a:t>No discrete P waves preceding each QRS complex</a:t>
+            </a:r>
+            <a:endParaRPr lang="en-US" sz="1400" dirty="0"/>
+          </a:p>
+        </p:txBody>
+      </p:sp>
+      <p:sp>
+        <p:nvSpPr>
+          <p:cNvPr id="25" name="Shape 19"/>
+          <p:cNvSpPr/>
+          <p:nvPr/>
+        </p:nvSpPr>
+        <p:spPr>
+          <a:xfrm>
+            <a:off x="502920" y="4315968"/>
+            <a:ext cx="11183112" cy="731520"/>
+          </a:xfrm>
+          <a:prstGeom prst="roundRect">
+            <a:avLst>
+              <a:gd name="adj" fmla="val 12500"/>
+            </a:avLst>
+          </a:prstGeom>
+          <a:solidFill>
+            <a:srgbClr val="FFF0F3"/>
+          </a:solidFill>
+          <a:ln w="12700">
+            <a:solidFill>
+              <a:srgbClr val="FBD8DF"/>
+            </a:solidFill>
+            <a:prstDash val="solid"/>
+          </a:ln>
+          <a:effectLst>
+            <a:outerShdw sx="100000" sy="100000" kx="0" ky="0" algn="bl" rotWithShape="0" blurRad="127000" dist="50800" dir="5400000">
+              <a:srgbClr val="C9A3AC">
+                <a:alpha val="45000"/>
+              </a:srgbClr>
+            </a:outerShdw>
+          </a:effectLst>
+        </p:spPr>
+      </p:sp>
+      <p:sp>
+        <p:nvSpPr>
+          <p:cNvPr id="26" name="Shape 20"/>
+          <p:cNvSpPr/>
+          <p:nvPr/>
+        </p:nvSpPr>
+        <p:spPr>
+          <a:xfrm>
+            <a:off x="777240" y="4489704"/>
             <a:ext cx="384048" cy="384048"/>
           </a:xfrm>
           <a:prstGeom prst="ellipse">
@@ -15145,7 +15366,7 @@
       </p:sp>
       <p:pic>
         <p:nvPicPr>
-          <p:cNvPr id="22" name="Image 4" descr="preencoded.png">    </p:cNvPr>
+          <p:cNvPr id="27" name="Image 4" descr="preencoded.png">    </p:cNvPr>
           <p:cNvPicPr>
             <a:picLocks noChangeAspect="1"/>
           </p:cNvPicPr>
@@ -15159,7 +15380,7 @@
         </p:blipFill>
         <p:spPr>
           <a:xfrm>
-            <a:off x="941832" y="4718304"/>
+            <a:off x="850392" y="4562856"/>
             <a:ext cx="237744" cy="237744"/>
           </a:xfrm>
           <a:prstGeom prst="rect">
@@ -15169,30 +15390,30 @@
       </p:pic>
       <p:sp>
         <p:nvSpPr>
-          <p:cNvPr id="23" name="Text 16"/>
-          <p:cNvSpPr/>
-          <p:nvPr/>
-        </p:nvSpPr>
-        <p:spPr>
-          <a:xfrm>
-            <a:off x="1417320" y="4572000"/>
-            <a:ext cx="5212080" cy="292608"/>
-          </a:xfrm>
-          <a:prstGeom prst="rect">
-            <a:avLst/>
-          </a:prstGeom>
-          <a:noFill/>
-          <a:ln/>
-        </p:spPr>
-        <p:txBody>
-          <a:bodyPr wrap="square" lIns="0" tIns="0" rIns="0" bIns="0" rtlCol="0" anchor="t"/>
-          <a:lstStyle/>
-          <a:p>
-            <a:pPr algn="l" indent="0" marL="0">
-              <a:buNone/>
-            </a:pPr>
-            <a:r>
-              <a:rPr lang="en-US" sz="1550" b="1" dirty="0">
+          <p:cNvPr id="28" name="Text 21"/>
+          <p:cNvSpPr/>
+          <p:nvPr/>
+        </p:nvSpPr>
+        <p:spPr>
+          <a:xfrm>
+            <a:off x="1371600" y="4315968"/>
+            <a:ext cx="3977640" cy="731520"/>
+          </a:xfrm>
+          <a:prstGeom prst="rect">
+            <a:avLst/>
+          </a:prstGeom>
+          <a:noFill/>
+          <a:ln/>
+        </p:spPr>
+        <p:txBody>
+          <a:bodyPr wrap="square" lIns="0" tIns="0" rIns="0" bIns="0" rtlCol="0" anchor="ctr"/>
+          <a:lstStyle/>
+          <a:p>
+            <a:pPr algn="l" indent="0" marL="0">
+              <a:buNone/>
+            </a:pPr>
+            <a:r>
+              <a:rPr lang="en-US" sz="1700" b="1" dirty="0">
                 <a:solidFill>
                   <a:srgbClr val="2B2B33"/>
                 </a:solidFill>
@@ -15202,36 +15423,59 @@
               </a:rPr>
               <a:t>AVNRT / AVRT (SVT)</a:t>
             </a:r>
-            <a:endParaRPr lang="en-US" sz="1550" dirty="0"/>
-          </a:p>
-        </p:txBody>
-      </p:sp>
-      <p:sp>
-        <p:nvSpPr>
-          <p:cNvPr id="24" name="Text 17"/>
-          <p:cNvSpPr/>
-          <p:nvPr/>
-        </p:nvSpPr>
-        <p:spPr>
-          <a:xfrm>
-            <a:off x="1417320" y="4864608"/>
-            <a:ext cx="5257800" cy="274320"/>
-          </a:xfrm>
-          <a:prstGeom prst="rect">
-            <a:avLst/>
-          </a:prstGeom>
-          <a:noFill/>
-          <a:ln/>
-        </p:spPr>
-        <p:txBody>
-          <a:bodyPr wrap="square" lIns="0" tIns="0" rIns="0" bIns="0" rtlCol="0" anchor="t"/>
-          <a:lstStyle/>
-          <a:p>
-            <a:pPr algn="l" indent="0" marL="0">
-              <a:buNone/>
-            </a:pPr>
-            <a:r>
-              <a:rPr lang="en-US" sz="1200" dirty="0">
+            <a:endParaRPr lang="en-US" sz="1700" dirty="0"/>
+          </a:p>
+        </p:txBody>
+      </p:sp>
+      <p:sp>
+        <p:nvSpPr>
+          <p:cNvPr id="29" name="Shape 22"/>
+          <p:cNvSpPr/>
+          <p:nvPr/>
+        </p:nvSpPr>
+        <p:spPr>
+          <a:xfrm>
+            <a:off x="5440680" y="4462272"/>
+            <a:ext cx="0" cy="438912"/>
+          </a:xfrm>
+          <a:prstGeom prst="line">
+            <a:avLst/>
+          </a:prstGeom>
+          <a:noFill/>
+          <a:ln w="12700">
+            <a:solidFill>
+              <a:srgbClr val="FBD8DF"/>
+            </a:solidFill>
+            <a:prstDash val="solid"/>
+          </a:ln>
+        </p:spPr>
+      </p:sp>
+      <p:sp>
+        <p:nvSpPr>
+          <p:cNvPr id="30" name="Text 23"/>
+          <p:cNvSpPr/>
+          <p:nvPr/>
+        </p:nvSpPr>
+        <p:spPr>
+          <a:xfrm>
+            <a:off x="5669280" y="4315968"/>
+            <a:ext cx="5806440" cy="731520"/>
+          </a:xfrm>
+          <a:prstGeom prst="rect">
+            <a:avLst/>
+          </a:prstGeom>
+          <a:noFill/>
+          <a:ln/>
+        </p:spPr>
+        <p:txBody>
+          <a:bodyPr wrap="square" lIns="0" tIns="0" rIns="0" bIns="0" rtlCol="0" anchor="ctr"/>
+          <a:lstStyle/>
+          <a:p>
+            <a:pPr algn="l" indent="0" marL="0">
+              <a:buNone/>
+            </a:pPr>
+            <a:r>
+              <a:rPr lang="en-US" sz="1400" dirty="0">
                 <a:solidFill>
                   <a:srgbClr val="6B6B76"/>
                 </a:solidFill>
@@ -15239,21 +15483,55 @@
                 <a:ea typeface="Calibri" pitchFamily="34" charset="-122"/>
                 <a:cs typeface="Calibri" pitchFamily="34" charset="-120"/>
               </a:rPr>
-              <a:t>Regular in SVT — here rhythm is irregular</a:t>
-            </a:r>
-            <a:endParaRPr lang="en-US" sz="1200" dirty="0"/>
-          </a:p>
-        </p:txBody>
-      </p:sp>
-      <p:sp>
-        <p:nvSpPr>
-          <p:cNvPr id="25" name="Shape 18"/>
-          <p:cNvSpPr/>
-          <p:nvPr/>
-        </p:nvSpPr>
-        <p:spPr>
-          <a:xfrm>
-            <a:off x="868680" y="5266944"/>
+              <a:t>Paroxysmal SVT is regular — here the rhythm is irregular</a:t>
+            </a:r>
+            <a:endParaRPr lang="en-US" sz="1400" dirty="0"/>
+          </a:p>
+        </p:txBody>
+      </p:sp>
+      <p:sp>
+        <p:nvSpPr>
+          <p:cNvPr id="31" name="Shape 24"/>
+          <p:cNvSpPr/>
+          <p:nvPr/>
+        </p:nvSpPr>
+        <p:spPr>
+          <a:xfrm>
+            <a:off x="502920" y="5129784"/>
+            <a:ext cx="11183112" cy="731520"/>
+          </a:xfrm>
+          <a:prstGeom prst="roundRect">
+            <a:avLst>
+              <a:gd name="adj" fmla="val 12500"/>
+            </a:avLst>
+          </a:prstGeom>
+          <a:solidFill>
+            <a:srgbClr val="FFF0F3"/>
+          </a:solidFill>
+          <a:ln w="12700">
+            <a:solidFill>
+              <a:srgbClr val="FBD8DF"/>
+            </a:solidFill>
+            <a:prstDash val="solid"/>
+          </a:ln>
+          <a:effectLst>
+            <a:outerShdw sx="100000" sy="100000" kx="0" ky="0" algn="bl" rotWithShape="0" blurRad="127000" dist="50800" dir="5400000">
+              <a:srgbClr val="C9A3AC">
+                <a:alpha val="45000"/>
+              </a:srgbClr>
+            </a:outerShdw>
+          </a:effectLst>
+        </p:spPr>
+      </p:sp>
+      <p:sp>
+        <p:nvSpPr>
+          <p:cNvPr id="32" name="Shape 25"/>
+          <p:cNvSpPr/>
+          <p:nvPr/>
+        </p:nvSpPr>
+        <p:spPr>
+          <a:xfrm>
+            <a:off x="777240" y="5303520"/>
             <a:ext cx="384048" cy="384048"/>
           </a:xfrm>
           <a:prstGeom prst="ellipse">
@@ -15272,7 +15550,7 @@
       </p:sp>
       <p:pic>
         <p:nvPicPr>
-          <p:cNvPr id="26" name="Image 5" descr="preencoded.png">    </p:cNvPr>
+          <p:cNvPr id="33" name="Image 5" descr="preencoded.png">    </p:cNvPr>
           <p:cNvPicPr>
             <a:picLocks noChangeAspect="1"/>
           </p:cNvPicPr>
@@ -15286,7 +15564,7 @@
         </p:blipFill>
         <p:spPr>
           <a:xfrm>
-            <a:off x="941832" y="5340096"/>
+            <a:off x="850392" y="5376672"/>
             <a:ext cx="237744" cy="237744"/>
           </a:xfrm>
           <a:prstGeom prst="rect">
@@ -15296,30 +15574,30 @@
       </p:pic>
       <p:sp>
         <p:nvSpPr>
-          <p:cNvPr id="27" name="Text 19"/>
-          <p:cNvSpPr/>
-          <p:nvPr/>
-        </p:nvSpPr>
-        <p:spPr>
-          <a:xfrm>
-            <a:off x="1417320" y="5193792"/>
-            <a:ext cx="5212080" cy="292608"/>
-          </a:xfrm>
-          <a:prstGeom prst="rect">
-            <a:avLst/>
-          </a:prstGeom>
-          <a:noFill/>
-          <a:ln/>
-        </p:spPr>
-        <p:txBody>
-          <a:bodyPr wrap="square" lIns="0" tIns="0" rIns="0" bIns="0" rtlCol="0" anchor="t"/>
-          <a:lstStyle/>
-          <a:p>
-            <a:pPr algn="l" indent="0" marL="0">
-              <a:buNone/>
-            </a:pPr>
-            <a:r>
-              <a:rPr lang="en-US" sz="1550" b="1" dirty="0">
+          <p:cNvPr id="34" name="Text 26"/>
+          <p:cNvSpPr/>
+          <p:nvPr/>
+        </p:nvSpPr>
+        <p:spPr>
+          <a:xfrm>
+            <a:off x="1371600" y="5129784"/>
+            <a:ext cx="3977640" cy="731520"/>
+          </a:xfrm>
+          <a:prstGeom prst="rect">
+            <a:avLst/>
+          </a:prstGeom>
+          <a:noFill/>
+          <a:ln/>
+        </p:spPr>
+        <p:txBody>
+          <a:bodyPr wrap="square" lIns="0" tIns="0" rIns="0" bIns="0" rtlCol="0" anchor="ctr"/>
+          <a:lstStyle/>
+          <a:p>
+            <a:pPr algn="l" indent="0" marL="0">
+              <a:buNone/>
+            </a:pPr>
+            <a:r>
+              <a:rPr lang="en-US" sz="1700" b="1" dirty="0">
                 <a:solidFill>
                   <a:srgbClr val="2B2B33"/>
                 </a:solidFill>
@@ -15329,169 +15607,20 @@
               </a:rPr>
               <a:t>Sinus tachycardia + ectopics</a:t>
             </a:r>
-            <a:endParaRPr lang="en-US" sz="1550" dirty="0"/>
-          </a:p>
-        </p:txBody>
-      </p:sp>
-      <p:sp>
-        <p:nvSpPr>
-          <p:cNvPr id="28" name="Text 20"/>
-          <p:cNvSpPr/>
-          <p:nvPr/>
-        </p:nvSpPr>
-        <p:spPr>
-          <a:xfrm>
-            <a:off x="1417320" y="5486400"/>
-            <a:ext cx="5257800" cy="274320"/>
-          </a:xfrm>
-          <a:prstGeom prst="rect">
-            <a:avLst/>
-          </a:prstGeom>
-          <a:noFill/>
-          <a:ln/>
-        </p:spPr>
-        <p:txBody>
-          <a:bodyPr wrap="square" lIns="0" tIns="0" rIns="0" bIns="0" rtlCol="0" anchor="t"/>
-          <a:lstStyle/>
-          <a:p>
-            <a:pPr algn="l" indent="0" marL="0">
-              <a:buNone/>
-            </a:pPr>
-            <a:r>
-              <a:rPr lang="en-US" sz="1200" dirty="0">
-                <a:solidFill>
-                  <a:srgbClr val="6B6B76"/>
-                </a:solidFill>
-                <a:latin typeface="Calibri" pitchFamily="34" charset="0"/>
-                <a:ea typeface="Calibri" pitchFamily="34" charset="-122"/>
-                <a:cs typeface="Calibri" pitchFamily="34" charset="-120"/>
-              </a:rPr>
-              <a:t>P waves absent; irregularly irregular</a:t>
-            </a:r>
-            <a:endParaRPr lang="en-US" sz="1200" dirty="0"/>
-          </a:p>
-        </p:txBody>
-      </p:sp>
-      <p:sp>
-        <p:nvSpPr>
-          <p:cNvPr id="29" name="Shape 21"/>
-          <p:cNvSpPr/>
-          <p:nvPr/>
-        </p:nvSpPr>
-        <p:spPr>
-          <a:xfrm>
-            <a:off x="6995160" y="1783080"/>
-            <a:ext cx="4690872" cy="4206240"/>
-          </a:xfrm>
-          <a:prstGeom prst="roundRect">
-            <a:avLst>
-              <a:gd name="adj" fmla="val 2609"/>
-            </a:avLst>
-          </a:prstGeom>
-          <a:solidFill>
-            <a:srgbClr val="590D22"/>
-          </a:solidFill>
-          <a:ln/>
-          <a:effectLst>
-            <a:outerShdw sx="100000" sy="100000" kx="0" ky="0" algn="bl" rotWithShape="0" blurRad="127000" dist="50800" dir="5400000">
-              <a:srgbClr val="C9A3AC">
-                <a:alpha val="45000"/>
-              </a:srgbClr>
-            </a:outerShdw>
-          </a:effectLst>
-        </p:spPr>
-      </p:sp>
-      <p:sp>
-        <p:nvSpPr>
-          <p:cNvPr id="30" name="Text 22"/>
-          <p:cNvSpPr/>
-          <p:nvPr/>
-        </p:nvSpPr>
-        <p:spPr>
-          <a:xfrm>
-            <a:off x="7296912" y="2048256"/>
-            <a:ext cx="4114800" cy="274320"/>
-          </a:xfrm>
-          <a:prstGeom prst="rect">
-            <a:avLst/>
-          </a:prstGeom>
-          <a:noFill/>
-          <a:ln/>
-        </p:spPr>
-        <p:txBody>
-          <a:bodyPr wrap="square" rtlCol="0" anchor="t"/>
-          <a:lstStyle/>
-          <a:p>
-            <a:pPr algn="l" indent="0" marL="0">
-              <a:buNone/>
-            </a:pPr>
-            <a:r>
-              <a:rPr lang="en-US" sz="1250" b="1" spc="200" kern="0" dirty="0">
-                <a:solidFill>
-                  <a:srgbClr val="FF4D6D"/>
-                </a:solidFill>
-                <a:latin typeface="Calibri" pitchFamily="34" charset="0"/>
-                <a:ea typeface="Calibri" pitchFamily="34" charset="-122"/>
-                <a:cs typeface="Calibri" pitchFamily="34" charset="-120"/>
-              </a:rPr>
-              <a:t>FINAL DIAGNOSIS</a:t>
-            </a:r>
-            <a:endParaRPr lang="en-US" sz="1250" dirty="0"/>
-          </a:p>
-        </p:txBody>
-      </p:sp>
-      <p:sp>
-        <p:nvSpPr>
-          <p:cNvPr id="31" name="Text 23"/>
-          <p:cNvSpPr/>
-          <p:nvPr/>
-        </p:nvSpPr>
-        <p:spPr>
-          <a:xfrm>
-            <a:off x="7296912" y="2377440"/>
-            <a:ext cx="4160520" cy="1371600"/>
-          </a:xfrm>
-          <a:prstGeom prst="rect">
-            <a:avLst/>
-          </a:prstGeom>
-          <a:noFill/>
-          <a:ln/>
-        </p:spPr>
-        <p:txBody>
-          <a:bodyPr wrap="square" rtlCol="0" anchor="t"/>
-          <a:lstStyle/>
-          <a:p>
-            <a:pPr algn="l" indent="0" marL="0">
-              <a:lnSpc>
-                <a:spcPct val="100000"/>
-              </a:lnSpc>
-              <a:buNone/>
-            </a:pPr>
-            <a:r>
-              <a:rPr lang="en-US" sz="2400" b="1" dirty="0">
-                <a:solidFill>
-                  <a:srgbClr val="FFFFFF"/>
-                </a:solidFill>
-                <a:latin typeface="Cambria" pitchFamily="34" charset="0"/>
-                <a:ea typeface="Cambria" pitchFamily="34" charset="-122"/>
-                <a:cs typeface="Cambria" pitchFamily="34" charset="-120"/>
-              </a:rPr>
-              <a:t>Atrial Fibrillation with Rapid Ventricular Response</a:t>
-            </a:r>
-            <a:endParaRPr lang="en-US" sz="2400" dirty="0"/>
-          </a:p>
-        </p:txBody>
-      </p:sp>
-      <p:sp>
-        <p:nvSpPr>
-          <p:cNvPr id="32" name="Shape 24"/>
-          <p:cNvSpPr/>
-          <p:nvPr/>
-        </p:nvSpPr>
-        <p:spPr>
-          <a:xfrm>
-            <a:off x="7296912" y="3858768"/>
-            <a:ext cx="4114800" cy="0"/>
+            <a:endParaRPr lang="en-US" sz="1700" dirty="0"/>
+          </a:p>
+        </p:txBody>
+      </p:sp>
+      <p:sp>
+        <p:nvSpPr>
+          <p:cNvPr id="35" name="Shape 27"/>
+          <p:cNvSpPr/>
+          <p:nvPr/>
+        </p:nvSpPr>
+        <p:spPr>
+          <a:xfrm>
+            <a:off x="5440680" y="5276088"/>
+            <a:ext cx="0" cy="438912"/>
           </a:xfrm>
           <a:prstGeom prst="line">
             <a:avLst/>
@@ -15499,279 +15628,54 @@
           <a:noFill/>
           <a:ln w="12700">
             <a:solidFill>
-              <a:srgbClr val="7A2233"/>
+              <a:srgbClr val="FBD8DF"/>
             </a:solidFill>
             <a:prstDash val="solid"/>
           </a:ln>
         </p:spPr>
       </p:sp>
-      <p:pic>
-        <p:nvPicPr>
-          <p:cNvPr id="33" name="Image 6" descr="preencoded.png">    </p:cNvPr>
-          <p:cNvPicPr>
-            <a:picLocks noChangeAspect="1"/>
-          </p:cNvPicPr>
-          <p:nvPr/>
-        </p:nvPicPr>
-        <p:blipFill>
-          <a:blip r:embed="rId7"/>
-          <a:stretch>
-            <a:fillRect/>
-          </a:stretch>
-        </p:blipFill>
-        <p:spPr>
-          <a:xfrm>
-            <a:off x="7296912" y="4050792"/>
-            <a:ext cx="274320" cy="274320"/>
-          </a:xfrm>
-          <a:prstGeom prst="rect">
-            <a:avLst/>
-          </a:prstGeom>
-        </p:spPr>
-      </p:pic>
-      <p:sp>
-        <p:nvSpPr>
-          <p:cNvPr id="34" name="Text 25"/>
-          <p:cNvSpPr/>
-          <p:nvPr/>
-        </p:nvSpPr>
-        <p:spPr>
-          <a:xfrm>
-            <a:off x="7680960" y="4041648"/>
-            <a:ext cx="3794760" cy="457200"/>
-          </a:xfrm>
-          <a:prstGeom prst="rect">
-            <a:avLst/>
-          </a:prstGeom>
-          <a:noFill/>
-          <a:ln/>
-        </p:spPr>
-        <p:txBody>
-          <a:bodyPr wrap="square" lIns="0" tIns="0" rIns="0" bIns="0" rtlCol="0" anchor="t"/>
-          <a:lstStyle/>
-          <a:p>
-            <a:pPr algn="l" indent="0" marL="0">
-              <a:lnSpc>
-                <a:spcPct val="102000"/>
-              </a:lnSpc>
-              <a:buNone/>
-            </a:pPr>
-            <a:r>
-              <a:rPr lang="en-US" sz="1200" dirty="0">
-                <a:solidFill>
-                  <a:srgbClr val="FBD8DF"/>
-                </a:solidFill>
-                <a:latin typeface="Calibri" pitchFamily="34" charset="0"/>
-                <a:ea typeface="Calibri" pitchFamily="34" charset="-122"/>
-                <a:cs typeface="Calibri" pitchFamily="34" charset="-120"/>
-              </a:rPr>
-              <a:t>Confirmed on 12-lead ECG — 146 bpm, no P waves</a:t>
-            </a:r>
-            <a:endParaRPr lang="en-US" sz="1200" dirty="0"/>
-          </a:p>
-        </p:txBody>
-      </p:sp>
-      <p:pic>
-        <p:nvPicPr>
-          <p:cNvPr id="35" name="Image 7" descr="preencoded.png">    </p:cNvPr>
-          <p:cNvPicPr>
-            <a:picLocks noChangeAspect="1"/>
-          </p:cNvPicPr>
-          <p:nvPr/>
-        </p:nvPicPr>
-        <p:blipFill>
-          <a:blip r:embed="rId8"/>
-          <a:stretch>
-            <a:fillRect/>
-          </a:stretch>
-        </p:blipFill>
-        <p:spPr>
-          <a:xfrm>
-            <a:off x="7296912" y="4535424"/>
-            <a:ext cx="274320" cy="274320"/>
-          </a:xfrm>
-          <a:prstGeom prst="rect">
-            <a:avLst/>
-          </a:prstGeom>
-        </p:spPr>
-      </p:pic>
-      <p:sp>
-        <p:nvSpPr>
-          <p:cNvPr id="36" name="Text 26"/>
-          <p:cNvSpPr/>
-          <p:nvPr/>
-        </p:nvSpPr>
-        <p:spPr>
-          <a:xfrm>
-            <a:off x="7680960" y="4526280"/>
-            <a:ext cx="3794760" cy="457200"/>
-          </a:xfrm>
-          <a:prstGeom prst="rect">
-            <a:avLst/>
-          </a:prstGeom>
-          <a:noFill/>
-          <a:ln/>
-        </p:spPr>
-        <p:txBody>
-          <a:bodyPr wrap="square" lIns="0" tIns="0" rIns="0" bIns="0" rtlCol="0" anchor="t"/>
-          <a:lstStyle/>
-          <a:p>
-            <a:pPr algn="l" indent="0" marL="0">
-              <a:lnSpc>
-                <a:spcPct val="102000"/>
-              </a:lnSpc>
-              <a:buNone/>
-            </a:pPr>
-            <a:r>
-              <a:rPr lang="en-US" sz="1200" dirty="0">
-                <a:solidFill>
-                  <a:srgbClr val="FBD8DF"/>
-                </a:solidFill>
-                <a:latin typeface="Calibri" pitchFamily="34" charset="0"/>
-                <a:ea typeface="Calibri" pitchFamily="34" charset="-122"/>
-                <a:cs typeface="Calibri" pitchFamily="34" charset="-120"/>
-              </a:rPr>
-              <a:t>Structurally normal heart — LVEF 65%, no LA/LV clot</a:t>
-            </a:r>
-            <a:endParaRPr lang="en-US" sz="1200" dirty="0"/>
-          </a:p>
-        </p:txBody>
-      </p:sp>
-      <p:pic>
-        <p:nvPicPr>
-          <p:cNvPr id="37" name="Image 8" descr="preencoded.png">    </p:cNvPr>
-          <p:cNvPicPr>
-            <a:picLocks noChangeAspect="1"/>
-          </p:cNvPicPr>
-          <p:nvPr/>
-        </p:nvPicPr>
-        <p:blipFill>
-          <a:blip r:embed="rId9"/>
-          <a:stretch>
-            <a:fillRect/>
-          </a:stretch>
-        </p:blipFill>
-        <p:spPr>
-          <a:xfrm>
-            <a:off x="7296912" y="5020056"/>
-            <a:ext cx="274320" cy="274320"/>
-          </a:xfrm>
-          <a:prstGeom prst="rect">
-            <a:avLst/>
-          </a:prstGeom>
-        </p:spPr>
-      </p:pic>
-      <p:sp>
-        <p:nvSpPr>
-          <p:cNvPr id="38" name="Text 27"/>
-          <p:cNvSpPr/>
-          <p:nvPr/>
-        </p:nvSpPr>
-        <p:spPr>
-          <a:xfrm>
-            <a:off x="7680960" y="5010912"/>
-            <a:ext cx="3794760" cy="457200"/>
-          </a:xfrm>
-          <a:prstGeom prst="rect">
-            <a:avLst/>
-          </a:prstGeom>
-          <a:noFill/>
-          <a:ln/>
-        </p:spPr>
-        <p:txBody>
-          <a:bodyPr wrap="square" lIns="0" tIns="0" rIns="0" bIns="0" rtlCol="0" anchor="t"/>
-          <a:lstStyle/>
-          <a:p>
-            <a:pPr algn="l" indent="0" marL="0">
-              <a:lnSpc>
-                <a:spcPct val="102000"/>
-              </a:lnSpc>
-              <a:buNone/>
-            </a:pPr>
-            <a:r>
-              <a:rPr lang="en-US" sz="1200" dirty="0">
-                <a:solidFill>
-                  <a:srgbClr val="FBD8DF"/>
-                </a:solidFill>
-                <a:latin typeface="Calibri" pitchFamily="34" charset="0"/>
-                <a:ea typeface="Calibri" pitchFamily="34" charset="-122"/>
-                <a:cs typeface="Calibri" pitchFamily="34" charset="-120"/>
-              </a:rPr>
-              <a:t>Background hypertension</a:t>
-            </a:r>
-            <a:endParaRPr lang="en-US" sz="1200" dirty="0"/>
-          </a:p>
-        </p:txBody>
-      </p:sp>
-      <p:pic>
-        <p:nvPicPr>
-          <p:cNvPr id="39" name="Image 9" descr="preencoded.png">    </p:cNvPr>
-          <p:cNvPicPr>
-            <a:picLocks noChangeAspect="1"/>
-          </p:cNvPicPr>
-          <p:nvPr/>
-        </p:nvPicPr>
-        <p:blipFill>
-          <a:blip r:embed="rId10"/>
-          <a:stretch>
-            <a:fillRect/>
-          </a:stretch>
-        </p:blipFill>
-        <p:spPr>
-          <a:xfrm>
-            <a:off x="7296912" y="5504688"/>
-            <a:ext cx="274320" cy="274320"/>
-          </a:xfrm>
-          <a:prstGeom prst="rect">
-            <a:avLst/>
-          </a:prstGeom>
-        </p:spPr>
-      </p:pic>
-      <p:sp>
-        <p:nvSpPr>
-          <p:cNvPr id="40" name="Text 28"/>
-          <p:cNvSpPr/>
-          <p:nvPr/>
-        </p:nvSpPr>
-        <p:spPr>
-          <a:xfrm>
-            <a:off x="7680960" y="5495544"/>
-            <a:ext cx="3794760" cy="457200"/>
-          </a:xfrm>
-          <a:prstGeom prst="rect">
-            <a:avLst/>
-          </a:prstGeom>
-          <a:noFill/>
-          <a:ln/>
-        </p:spPr>
-        <p:txBody>
-          <a:bodyPr wrap="square" lIns="0" tIns="0" rIns="0" bIns="0" rtlCol="0" anchor="t"/>
-          <a:lstStyle/>
-          <a:p>
-            <a:pPr algn="l" indent="0" marL="0">
-              <a:lnSpc>
-                <a:spcPct val="102000"/>
-              </a:lnSpc>
-              <a:buNone/>
-            </a:pPr>
-            <a:r>
-              <a:rPr lang="en-US" sz="1200" dirty="0">
-                <a:solidFill>
-                  <a:srgbClr val="FBD8DF"/>
-                </a:solidFill>
-                <a:latin typeface="Calibri" pitchFamily="34" charset="0"/>
-                <a:ea typeface="Calibri" pitchFamily="34" charset="-122"/>
-                <a:cs typeface="Calibri" pitchFamily="34" charset="-120"/>
-              </a:rPr>
-              <a:t>Mild normocytic anaemia (incidental)</a:t>
-            </a:r>
-            <a:endParaRPr lang="en-US" sz="1200" dirty="0"/>
-          </a:p>
-        </p:txBody>
-      </p:sp>
-      <p:sp>
-        <p:nvSpPr>
-          <p:cNvPr id="41" name="Text 29"/>
+      <p:sp>
+        <p:nvSpPr>
+          <p:cNvPr id="36" name="Text 28"/>
+          <p:cNvSpPr/>
+          <p:nvPr/>
+        </p:nvSpPr>
+        <p:spPr>
+          <a:xfrm>
+            <a:off x="5669280" y="5129784"/>
+            <a:ext cx="5806440" cy="731520"/>
+          </a:xfrm>
+          <a:prstGeom prst="rect">
+            <a:avLst/>
+          </a:prstGeom>
+          <a:noFill/>
+          <a:ln/>
+        </p:spPr>
+        <p:txBody>
+          <a:bodyPr wrap="square" lIns="0" tIns="0" rIns="0" bIns="0" rtlCol="0" anchor="ctr"/>
+          <a:lstStyle/>
+          <a:p>
+            <a:pPr algn="l" indent="0" marL="0">
+              <a:buNone/>
+            </a:pPr>
+            <a:r>
+              <a:rPr lang="en-US" sz="1400" dirty="0">
+                <a:solidFill>
+                  <a:srgbClr val="6B6B76"/>
+                </a:solidFill>
+                <a:latin typeface="Calibri" pitchFamily="34" charset="0"/>
+                <a:ea typeface="Calibri" pitchFamily="34" charset="-122"/>
+                <a:cs typeface="Calibri" pitchFamily="34" charset="-120"/>
+              </a:rPr>
+              <a:t>P waves absent; rhythm is irregularly irregular</a:t>
+            </a:r>
+            <a:endParaRPr lang="en-US" sz="1400" dirty="0"/>
+          </a:p>
+        </p:txBody>
+      </p:sp>
+      <p:sp>
+        <p:nvSpPr>
+          <p:cNvPr id="37" name="Text 29"/>
           <p:cNvSpPr/>
           <p:nvPr/>
         </p:nvSpPr>
@@ -15810,7 +15714,7 @@
       </p:sp>
       <p:sp>
         <p:nvSpPr>
-          <p:cNvPr id="42" name="Text 30"/>
+          <p:cNvPr id="38" name="Text 30"/>
           <p:cNvSpPr/>
           <p:nvPr/>
         </p:nvSpPr>
@@ -15895,7 +15799,7 @@
           </a:prstGeom>
           <a:solidFill>
             <a:srgbClr val="3A0A17">
-              <a:alpha val="65000"/>
+              <a:alpha val="68000"/>
             </a:srgbClr>
           </a:solidFill>
           <a:ln/>
@@ -15911,7 +15815,7 @@
         </p:nvPicPr>
         <p:blipFill>
           <a:blip r:embed="rId1">
-            <a:alphaModFix amt="10000"/>
+            <a:alphaModFix amt="9000"/>
           </a:blip>
           <a:stretch>
             <a:fillRect/>
@@ -15919,8 +15823,8 @@
         </p:blipFill>
         <p:spPr>
           <a:xfrm>
-            <a:off x="7863840" y="3108960"/>
-            <a:ext cx="4754880" cy="4754880"/>
+            <a:off x="8138160" y="3200400"/>
+            <a:ext cx="4663440" cy="4663440"/>
           </a:xfrm>
           <a:prstGeom prst="rect">
             <a:avLst/>
@@ -15996,7 +15900,7 @@
               <a:buNone/>
             </a:pPr>
             <a:r>
-              <a:rPr lang="en-US" sz="1700" b="1" spc="250" kern="0" dirty="0">
+              <a:rPr lang="en-US" sz="1700" b="1" spc="300" kern="0" dirty="0">
                 <a:solidFill>
                   <a:srgbClr val="FF4D6D"/>
                 </a:solidFill>
@@ -16004,7 +15908,7 @@
                 <a:ea typeface="Calibri" pitchFamily="34" charset="-122"/>
                 <a:cs typeface="Calibri" pitchFamily="34" charset="-120"/>
               </a:rPr>
-              <a:t>HOSPITAL COURSE &amp; OUTCOME</a:t>
+              <a:t>FINAL DIAGNOSIS</a:t>
             </a:r>
             <a:endParaRPr lang="en-US" sz="1700" dirty="0"/>
           </a:p>
@@ -16018,8 +15922,8 @@
         </p:nvSpPr>
         <p:spPr>
           <a:xfrm>
-            <a:off x="640080" y="1965960"/>
-            <a:ext cx="10058400" cy="914400"/>
+            <a:off x="640080" y="1783080"/>
+            <a:ext cx="10698480" cy="1600200"/>
           </a:xfrm>
           <a:prstGeom prst="rect">
             <a:avLst/>
@@ -16032,10 +15936,13 @@
           <a:lstStyle/>
           <a:p>
             <a:pPr algn="l" indent="0" marL="0">
-              <a:buNone/>
-            </a:pPr>
-            <a:r>
-              <a:rPr lang="en-US" sz="5600" b="1" dirty="0">
+              <a:lnSpc>
+                <a:spcPct val="100000"/>
+              </a:lnSpc>
+              <a:buNone/>
+            </a:pPr>
+            <a:r>
+              <a:rPr lang="en-US" sz="4400" b="1" dirty="0">
                 <a:solidFill>
                   <a:srgbClr val="FFFFFF"/>
                 </a:solidFill>
@@ -16043,9 +15950,9 @@
                 <a:ea typeface="Cambria" pitchFamily="34" charset="-122"/>
                 <a:cs typeface="Cambria" pitchFamily="34" charset="-120"/>
               </a:rPr>
-              <a:t>Clinically Improved</a:t>
-            </a:r>
-            <a:endParaRPr lang="en-US" sz="5600" dirty="0"/>
+              <a:t>Atrial Fibrillation with Rapid Ventricular Response</a:t>
+            </a:r>
+            <a:endParaRPr lang="en-US" sz="4400" dirty="0"/>
           </a:p>
         </p:txBody>
       </p:sp>
@@ -16057,17 +15964,17 @@
         </p:nvSpPr>
         <p:spPr>
           <a:xfrm>
-            <a:off x="685800" y="3200400"/>
-            <a:ext cx="3749040" cy="1554480"/>
+            <a:off x="685800" y="3611880"/>
+            <a:ext cx="5394960" cy="1005840"/>
           </a:xfrm>
           <a:prstGeom prst="roundRect">
             <a:avLst>
-              <a:gd name="adj" fmla="val 7059"/>
+              <a:gd name="adj" fmla="val 10909"/>
             </a:avLst>
           </a:prstGeom>
           <a:solidFill>
             <a:srgbClr val="FFFFFF">
-              <a:alpha val="8000"/>
+              <a:alpha val="9000"/>
             </a:srgbClr>
           </a:solidFill>
           <a:ln w="12700">
@@ -16076,13 +15983,6 @@
             </a:solidFill>
             <a:prstDash val="solid"/>
           </a:ln>
-          <a:effectLst>
-            <a:outerShdw sx="100000" sy="100000" kx="0" ky="0" algn="bl" rotWithShape="0" blurRad="101600" dist="38100" dir="5400000">
-              <a:srgbClr val="8A8A8A">
-                <a:alpha val="35000"/>
-              </a:srgbClr>
-            </a:outerShdw>
-          </a:effectLst>
         </p:spPr>
       </p:sp>
       <p:sp>
@@ -16093,52 +15993,28 @@
         </p:nvSpPr>
         <p:spPr>
           <a:xfrm>
-            <a:off x="960120" y="3657600"/>
-            <a:ext cx="640080" cy="640080"/>
+            <a:off x="941832" y="3895344"/>
+            <a:ext cx="438912" cy="438912"/>
           </a:xfrm>
           <a:prstGeom prst="ellipse">
             <a:avLst/>
           </a:prstGeom>
           <a:solidFill>
-            <a:srgbClr val="FFFFFF"/>
+            <a:srgbClr val="2E7D32"/>
           </a:solidFill>
           <a:ln/>
         </p:spPr>
       </p:sp>
-      <p:pic>
-        <p:nvPicPr>
-          <p:cNvPr id="10" name="Image 2" descr="preencoded.png">    </p:cNvPr>
-          <p:cNvPicPr>
-            <a:picLocks noChangeAspect="1"/>
-          </p:cNvPicPr>
-          <p:nvPr/>
-        </p:nvPicPr>
-        <p:blipFill>
-          <a:blip r:embed="rId3"/>
-          <a:stretch>
-            <a:fillRect/>
-          </a:stretch>
-        </p:blipFill>
-        <p:spPr>
-          <a:xfrm>
-            <a:off x="1088136" y="3785616"/>
-            <a:ext cx="384048" cy="384048"/>
-          </a:xfrm>
-          <a:prstGeom prst="rect">
-            <a:avLst/>
-          </a:prstGeom>
-        </p:spPr>
-      </p:pic>
-      <p:sp>
-        <p:nvSpPr>
-          <p:cNvPr id="11" name="Text 6"/>
-          <p:cNvSpPr/>
-          <p:nvPr/>
-        </p:nvSpPr>
-        <p:spPr>
-          <a:xfrm>
-            <a:off x="1737360" y="3493008"/>
-            <a:ext cx="2560320" cy="457200"/>
+      <p:sp>
+        <p:nvSpPr>
+          <p:cNvPr id="10" name="Text 6"/>
+          <p:cNvSpPr/>
+          <p:nvPr/>
+        </p:nvSpPr>
+        <p:spPr>
+          <a:xfrm>
+            <a:off x="1554480" y="3794760"/>
+            <a:ext cx="4297680" cy="365760"/>
           </a:xfrm>
           <a:prstGeom prst="rect">
             <a:avLst/>
@@ -16154,7 +16030,7 @@
               <a:buNone/>
             </a:pPr>
             <a:r>
-              <a:rPr lang="en-US" sz="1900" b="1" dirty="0">
+              <a:rPr lang="en-US" sz="1800" b="1" dirty="0">
                 <a:solidFill>
                   <a:srgbClr val="FFFFFF"/>
                 </a:solidFill>
@@ -16162,31 +16038,31 @@
                 <a:ea typeface="Cambria" pitchFamily="34" charset="-122"/>
                 <a:cs typeface="Cambria" pitchFamily="34" charset="-120"/>
               </a:rPr>
-              <a:t>Symptoms settled</a:t>
-            </a:r>
-            <a:endParaRPr lang="en-US" sz="1900" dirty="0"/>
-          </a:p>
-        </p:txBody>
-      </p:sp>
-      <p:sp>
-        <p:nvSpPr>
-          <p:cNvPr id="12" name="Text 7"/>
-          <p:cNvSpPr/>
-          <p:nvPr/>
-        </p:nvSpPr>
-        <p:spPr>
-          <a:xfrm>
-            <a:off x="1737360" y="3950208"/>
-            <a:ext cx="2606040" cy="640080"/>
-          </a:xfrm>
-          <a:prstGeom prst="rect">
-            <a:avLst/>
-          </a:prstGeom>
-          <a:noFill/>
-          <a:ln/>
-        </p:spPr>
-        <p:txBody>
-          <a:bodyPr wrap="square" lIns="0" tIns="0" rIns="0" bIns="0" rtlCol="0" anchor="t"/>
+              <a:t>Confirmed on 12-lead ECG</a:t>
+            </a:r>
+            <a:endParaRPr lang="en-US" sz="1800" dirty="0"/>
+          </a:p>
+        </p:txBody>
+      </p:sp>
+      <p:sp>
+        <p:nvSpPr>
+          <p:cNvPr id="11" name="Text 7"/>
+          <p:cNvSpPr/>
+          <p:nvPr/>
+        </p:nvSpPr>
+        <p:spPr>
+          <a:xfrm>
+            <a:off x="1554480" y="4160520"/>
+            <a:ext cx="4297680" cy="329184"/>
+          </a:xfrm>
+          <a:prstGeom prst="rect">
+            <a:avLst/>
+          </a:prstGeom>
+          <a:noFill/>
+          <a:ln/>
+        </p:spPr>
+        <p:txBody>
+          <a:bodyPr wrap="square" lIns="0" tIns="0" rIns="0" bIns="0" rtlCol="0" anchor="ctr"/>
           <a:lstStyle/>
           <a:p>
             <a:pPr algn="l" indent="0" marL="0">
@@ -16201,7 +16077,7 @@
                 <a:ea typeface="Calibri" pitchFamily="34" charset="-122"/>
                 <a:cs typeface="Calibri" pitchFamily="34" charset="-120"/>
               </a:rPr>
-              <a:t>Rhythm &amp; symptoms controlled</a:t>
+              <a:t>146 bpm · irregularly irregular · no P waves</a:t>
             </a:r>
             <a:endParaRPr lang="en-US" sz="1250" dirty="0"/>
           </a:p>
@@ -16209,23 +16085,23 @@
       </p:sp>
       <p:sp>
         <p:nvSpPr>
-          <p:cNvPr id="13" name="Shape 8"/>
-          <p:cNvSpPr/>
-          <p:nvPr/>
-        </p:nvSpPr>
-        <p:spPr>
-          <a:xfrm>
-            <a:off x="4709160" y="3200400"/>
-            <a:ext cx="3749040" cy="1554480"/>
+          <p:cNvPr id="12" name="Shape 8"/>
+          <p:cNvSpPr/>
+          <p:nvPr/>
+        </p:nvSpPr>
+        <p:spPr>
+          <a:xfrm>
+            <a:off x="6263640" y="3611880"/>
+            <a:ext cx="5394960" cy="1005840"/>
           </a:xfrm>
           <a:prstGeom prst="roundRect">
             <a:avLst>
-              <a:gd name="adj" fmla="val 7059"/>
+              <a:gd name="adj" fmla="val 10909"/>
             </a:avLst>
           </a:prstGeom>
           <a:solidFill>
             <a:srgbClr val="FFFFFF">
-              <a:alpha val="8000"/>
+              <a:alpha val="9000"/>
             </a:srgbClr>
           </a:solidFill>
           <a:ln w="12700">
@@ -16234,69 +16110,38 @@
             </a:solidFill>
             <a:prstDash val="solid"/>
           </a:ln>
-          <a:effectLst>
-            <a:outerShdw sx="100000" sy="100000" kx="0" ky="0" algn="bl" rotWithShape="0" blurRad="101600" dist="38100" dir="5400000">
-              <a:srgbClr val="8A8A8A">
-                <a:alpha val="35000"/>
-              </a:srgbClr>
-            </a:outerShdw>
-          </a:effectLst>
-        </p:spPr>
-      </p:sp>
-      <p:sp>
-        <p:nvSpPr>
-          <p:cNvPr id="14" name="Shape 9"/>
-          <p:cNvSpPr/>
-          <p:nvPr/>
-        </p:nvSpPr>
-        <p:spPr>
-          <a:xfrm>
-            <a:off x="4983480" y="3657600"/>
-            <a:ext cx="640080" cy="640080"/>
+        </p:spPr>
+      </p:sp>
+      <p:sp>
+        <p:nvSpPr>
+          <p:cNvPr id="13" name="Shape 9"/>
+          <p:cNvSpPr/>
+          <p:nvPr/>
+        </p:nvSpPr>
+        <p:spPr>
+          <a:xfrm>
+            <a:off x="6519672" y="3895344"/>
+            <a:ext cx="438912" cy="438912"/>
           </a:xfrm>
           <a:prstGeom prst="ellipse">
             <a:avLst/>
           </a:prstGeom>
           <a:solidFill>
-            <a:srgbClr val="FFFFFF"/>
+            <a:srgbClr val="2E7D32"/>
           </a:solidFill>
           <a:ln/>
         </p:spPr>
       </p:sp>
-      <p:pic>
-        <p:nvPicPr>
-          <p:cNvPr id="15" name="Image 3" descr="preencoded.png">    </p:cNvPr>
-          <p:cNvPicPr>
-            <a:picLocks noChangeAspect="1"/>
-          </p:cNvPicPr>
-          <p:nvPr/>
-        </p:nvPicPr>
-        <p:blipFill>
-          <a:blip r:embed="rId4"/>
-          <a:stretch>
-            <a:fillRect/>
-          </a:stretch>
-        </p:blipFill>
-        <p:spPr>
-          <a:xfrm>
-            <a:off x="5111496" y="3785616"/>
-            <a:ext cx="384048" cy="384048"/>
-          </a:xfrm>
-          <a:prstGeom prst="rect">
-            <a:avLst/>
-          </a:prstGeom>
-        </p:spPr>
-      </p:pic>
-      <p:sp>
-        <p:nvSpPr>
-          <p:cNvPr id="16" name="Text 10"/>
-          <p:cNvSpPr/>
-          <p:nvPr/>
-        </p:nvSpPr>
-        <p:spPr>
-          <a:xfrm>
-            <a:off x="5760720" y="3493008"/>
-            <a:ext cx="2560320" cy="457200"/>
+      <p:sp>
+        <p:nvSpPr>
+          <p:cNvPr id="14" name="Text 10"/>
+          <p:cNvSpPr/>
+          <p:nvPr/>
+        </p:nvSpPr>
+        <p:spPr>
+          <a:xfrm>
+            <a:off x="7132320" y="3794760"/>
+            <a:ext cx="4297680" cy="365760"/>
           </a:xfrm>
           <a:prstGeom prst="rect">
             <a:avLst/>
@@ -16312,7 +16157,7 @@
               <a:buNone/>
             </a:pPr>
             <a:r>
-              <a:rPr lang="en-US" sz="1900" b="1" dirty="0">
+              <a:rPr lang="en-US" sz="1800" b="1" dirty="0">
                 <a:solidFill>
                   <a:srgbClr val="FFFFFF"/>
                 </a:solidFill>
@@ -16320,31 +16165,31 @@
                 <a:ea typeface="Cambria" pitchFamily="34" charset="-122"/>
                 <a:cs typeface="Cambria" pitchFamily="34" charset="-120"/>
               </a:rPr>
-              <a:t>Discharged home</a:t>
-            </a:r>
-            <a:endParaRPr lang="en-US" sz="1900" dirty="0"/>
-          </a:p>
-        </p:txBody>
-      </p:sp>
-      <p:sp>
-        <p:nvSpPr>
-          <p:cNvPr id="17" name="Text 11"/>
-          <p:cNvSpPr/>
-          <p:nvPr/>
-        </p:nvSpPr>
-        <p:spPr>
-          <a:xfrm>
-            <a:off x="5760720" y="3950208"/>
-            <a:ext cx="2606040" cy="640080"/>
-          </a:xfrm>
-          <a:prstGeom prst="rect">
-            <a:avLst/>
-          </a:prstGeom>
-          <a:noFill/>
-          <a:ln/>
-        </p:spPr>
-        <p:txBody>
-          <a:bodyPr wrap="square" lIns="0" tIns="0" rIns="0" bIns="0" rtlCol="0" anchor="t"/>
+              <a:t>Structurally normal heart</a:t>
+            </a:r>
+            <a:endParaRPr lang="en-US" sz="1800" dirty="0"/>
+          </a:p>
+        </p:txBody>
+      </p:sp>
+      <p:sp>
+        <p:nvSpPr>
+          <p:cNvPr id="15" name="Text 11"/>
+          <p:cNvSpPr/>
+          <p:nvPr/>
+        </p:nvSpPr>
+        <p:spPr>
+          <a:xfrm>
+            <a:off x="7132320" y="4160520"/>
+            <a:ext cx="4297680" cy="329184"/>
+          </a:xfrm>
+          <a:prstGeom prst="rect">
+            <a:avLst/>
+          </a:prstGeom>
+          <a:noFill/>
+          <a:ln/>
+        </p:spPr>
+        <p:txBody>
+          <a:bodyPr wrap="square" lIns="0" tIns="0" rIns="0" bIns="0" rtlCol="0" anchor="ctr"/>
           <a:lstStyle/>
           <a:p>
             <a:pPr algn="l" indent="0" marL="0">
@@ -16359,7 +16204,7 @@
                 <a:ea typeface="Calibri" pitchFamily="34" charset="-122"/>
                 <a:cs typeface="Calibri" pitchFamily="34" charset="-120"/>
               </a:rPr>
-              <a:t>Stable for outpatient follow-up</a:t>
+              <a:t>LVEF 65% · no clot in LA or LV</a:t>
             </a:r>
             <a:endParaRPr lang="en-US" sz="1250" dirty="0"/>
           </a:p>
@@ -16367,24 +16212,28 @@
       </p:sp>
       <p:sp>
         <p:nvSpPr>
-          <p:cNvPr id="18" name="Shape 12"/>
-          <p:cNvSpPr/>
-          <p:nvPr/>
-        </p:nvSpPr>
-        <p:spPr>
-          <a:xfrm>
-            <a:off x="731520" y="5486400"/>
-            <a:ext cx="2020824" cy="0"/>
-          </a:xfrm>
-          <a:prstGeom prst="line">
-            <a:avLst/>
-          </a:prstGeom>
-          <a:noFill/>
-          <a:ln w="28575">
+          <p:cNvPr id="16" name="Shape 12"/>
+          <p:cNvSpPr/>
+          <p:nvPr/>
+        </p:nvSpPr>
+        <p:spPr>
+          <a:xfrm>
+            <a:off x="685800" y="4764024"/>
+            <a:ext cx="5394960" cy="1005840"/>
+          </a:xfrm>
+          <a:prstGeom prst="roundRect">
+            <a:avLst>
+              <a:gd name="adj" fmla="val 10909"/>
+            </a:avLst>
+          </a:prstGeom>
+          <a:solidFill>
+            <a:srgbClr val="FFFFFF">
+              <a:alpha val="9000"/>
+            </a:srgbClr>
+          </a:solidFill>
+          <a:ln w="12700">
             <a:solidFill>
-              <a:srgbClr val="FF4D6D">
-                <a:alpha val="95000"/>
-              </a:srgbClr>
+              <a:srgbClr val="FF4D6D"/>
             </a:solidFill>
             <a:prstDash val="solid"/>
           </a:ln>
@@ -16392,24 +16241,126 @@
       </p:sp>
       <p:sp>
         <p:nvSpPr>
-          <p:cNvPr id="19" name="Shape 13"/>
-          <p:cNvSpPr/>
-          <p:nvPr/>
-        </p:nvSpPr>
-        <p:spPr>
-          <a:xfrm flipV="1">
-            <a:off x="2752344" y="5340096"/>
-            <a:ext cx="356616" cy="146304"/>
-          </a:xfrm>
-          <a:prstGeom prst="line">
-            <a:avLst/>
-          </a:prstGeom>
-          <a:noFill/>
-          <a:ln w="28575">
+          <p:cNvPr id="17" name="Shape 13"/>
+          <p:cNvSpPr/>
+          <p:nvPr/>
+        </p:nvSpPr>
+        <p:spPr>
+          <a:xfrm>
+            <a:off x="941832" y="5047488"/>
+            <a:ext cx="438912" cy="438912"/>
+          </a:xfrm>
+          <a:prstGeom prst="ellipse">
+            <a:avLst/>
+          </a:prstGeom>
+          <a:solidFill>
+            <a:srgbClr val="2E7D32"/>
+          </a:solidFill>
+          <a:ln/>
+        </p:spPr>
+      </p:sp>
+      <p:sp>
+        <p:nvSpPr>
+          <p:cNvPr id="18" name="Text 14"/>
+          <p:cNvSpPr/>
+          <p:nvPr/>
+        </p:nvSpPr>
+        <p:spPr>
+          <a:xfrm>
+            <a:off x="1554480" y="4946904"/>
+            <a:ext cx="4297680" cy="365760"/>
+          </a:xfrm>
+          <a:prstGeom prst="rect">
+            <a:avLst/>
+          </a:prstGeom>
+          <a:noFill/>
+          <a:ln/>
+        </p:spPr>
+        <p:txBody>
+          <a:bodyPr wrap="square" lIns="0" tIns="0" rIns="0" bIns="0" rtlCol="0" anchor="ctr"/>
+          <a:lstStyle/>
+          <a:p>
+            <a:pPr algn="l" indent="0" marL="0">
+              <a:buNone/>
+            </a:pPr>
+            <a:r>
+              <a:rPr lang="en-US" sz="1800" b="1" dirty="0">
+                <a:solidFill>
+                  <a:srgbClr val="FFFFFF"/>
+                </a:solidFill>
+                <a:latin typeface="Cambria" pitchFamily="34" charset="0"/>
+                <a:ea typeface="Cambria" pitchFamily="34" charset="-122"/>
+                <a:cs typeface="Cambria" pitchFamily="34" charset="-120"/>
+              </a:rPr>
+              <a:t>Background hypertension</a:t>
+            </a:r>
+            <a:endParaRPr lang="en-US" sz="1800" dirty="0"/>
+          </a:p>
+        </p:txBody>
+      </p:sp>
+      <p:sp>
+        <p:nvSpPr>
+          <p:cNvPr id="19" name="Text 15"/>
+          <p:cNvSpPr/>
+          <p:nvPr/>
+        </p:nvSpPr>
+        <p:spPr>
+          <a:xfrm>
+            <a:off x="1554480" y="5312664"/>
+            <a:ext cx="4297680" cy="329184"/>
+          </a:xfrm>
+          <a:prstGeom prst="rect">
+            <a:avLst/>
+          </a:prstGeom>
+          <a:noFill/>
+          <a:ln/>
+        </p:spPr>
+        <p:txBody>
+          <a:bodyPr wrap="square" lIns="0" tIns="0" rIns="0" bIns="0" rtlCol="0" anchor="ctr"/>
+          <a:lstStyle/>
+          <a:p>
+            <a:pPr algn="l" indent="0" marL="0">
+              <a:buNone/>
+            </a:pPr>
+            <a:r>
+              <a:rPr lang="en-US" sz="1250" i="1" dirty="0">
+                <a:solidFill>
+                  <a:srgbClr val="FBD8DF"/>
+                </a:solidFill>
+                <a:latin typeface="Calibri" pitchFamily="34" charset="0"/>
+                <a:ea typeface="Calibri" pitchFamily="34" charset="-122"/>
+                <a:cs typeface="Calibri" pitchFamily="34" charset="-120"/>
+              </a:rPr>
+              <a:t>Established comorbidity</a:t>
+            </a:r>
+            <a:endParaRPr lang="en-US" sz="1250" dirty="0"/>
+          </a:p>
+        </p:txBody>
+      </p:sp>
+      <p:sp>
+        <p:nvSpPr>
+          <p:cNvPr id="20" name="Shape 16"/>
+          <p:cNvSpPr/>
+          <p:nvPr/>
+        </p:nvSpPr>
+        <p:spPr>
+          <a:xfrm>
+            <a:off x="6263640" y="4764024"/>
+            <a:ext cx="5394960" cy="1005840"/>
+          </a:xfrm>
+          <a:prstGeom prst="roundRect">
+            <a:avLst>
+              <a:gd name="adj" fmla="val 10909"/>
+            </a:avLst>
+          </a:prstGeom>
+          <a:solidFill>
+            <a:srgbClr val="FFFFFF">
+              <a:alpha val="9000"/>
+            </a:srgbClr>
+          </a:solidFill>
+          <a:ln w="12700">
             <a:solidFill>
-              <a:srgbClr val="FF4D6D">
-                <a:alpha val="95000"/>
-              </a:srgbClr>
+              <a:srgbClr val="FF4D6D"/>
             </a:solidFill>
             <a:prstDash val="solid"/>
           </a:ln>
@@ -16417,171 +16368,105 @@
       </p:sp>
       <p:sp>
         <p:nvSpPr>
-          <p:cNvPr id="20" name="Shape 14"/>
-          <p:cNvSpPr/>
-          <p:nvPr/>
-        </p:nvSpPr>
-        <p:spPr>
-          <a:xfrm>
-            <a:off x="3108960" y="5340096"/>
-            <a:ext cx="356616" cy="457200"/>
-          </a:xfrm>
-          <a:prstGeom prst="line">
-            <a:avLst/>
-          </a:prstGeom>
-          <a:noFill/>
-          <a:ln w="28575">
-            <a:solidFill>
-              <a:srgbClr val="FF4D6D">
-                <a:alpha val="95000"/>
-              </a:srgbClr>
-            </a:solidFill>
-            <a:prstDash val="solid"/>
-          </a:ln>
-        </p:spPr>
-      </p:sp>
-      <p:sp>
-        <p:nvSpPr>
-          <p:cNvPr id="21" name="Shape 15"/>
-          <p:cNvSpPr/>
-          <p:nvPr/>
-        </p:nvSpPr>
-        <p:spPr>
-          <a:xfrm flipV="1">
-            <a:off x="3465576" y="4983480"/>
-            <a:ext cx="356616" cy="813816"/>
-          </a:xfrm>
-          <a:prstGeom prst="line">
-            <a:avLst/>
-          </a:prstGeom>
-          <a:noFill/>
-          <a:ln w="28575">
-            <a:solidFill>
-              <a:srgbClr val="FF4D6D">
-                <a:alpha val="95000"/>
-              </a:srgbClr>
-            </a:solidFill>
-            <a:prstDash val="solid"/>
-          </a:ln>
-        </p:spPr>
-      </p:sp>
-      <p:sp>
-        <p:nvSpPr>
-          <p:cNvPr id="22" name="Shape 16"/>
-          <p:cNvSpPr/>
-          <p:nvPr/>
-        </p:nvSpPr>
-        <p:spPr>
-          <a:xfrm>
-            <a:off x="3822192" y="4983480"/>
-            <a:ext cx="356616" cy="685800"/>
-          </a:xfrm>
-          <a:prstGeom prst="line">
-            <a:avLst/>
-          </a:prstGeom>
-          <a:noFill/>
-          <a:ln w="28575">
-            <a:solidFill>
-              <a:srgbClr val="FF4D6D">
-                <a:alpha val="95000"/>
-              </a:srgbClr>
-            </a:solidFill>
-            <a:prstDash val="solid"/>
-          </a:ln>
-        </p:spPr>
-      </p:sp>
-      <p:sp>
-        <p:nvSpPr>
-          <p:cNvPr id="23" name="Shape 17"/>
-          <p:cNvSpPr/>
-          <p:nvPr/>
-        </p:nvSpPr>
-        <p:spPr>
-          <a:xfrm flipV="1">
-            <a:off x="4178808" y="5486400"/>
-            <a:ext cx="356616" cy="182880"/>
-          </a:xfrm>
-          <a:prstGeom prst="line">
-            <a:avLst/>
-          </a:prstGeom>
-          <a:noFill/>
-          <a:ln w="28575">
-            <a:solidFill>
-              <a:srgbClr val="FF4D6D">
-                <a:alpha val="95000"/>
-              </a:srgbClr>
-            </a:solidFill>
-            <a:prstDash val="solid"/>
-          </a:ln>
-        </p:spPr>
-      </p:sp>
-      <p:sp>
-        <p:nvSpPr>
-          <p:cNvPr id="24" name="Shape 18"/>
-          <p:cNvSpPr/>
-          <p:nvPr/>
-        </p:nvSpPr>
-        <p:spPr>
-          <a:xfrm>
-            <a:off x="4535424" y="5486400"/>
-            <a:ext cx="2139696" cy="0"/>
-          </a:xfrm>
-          <a:prstGeom prst="line">
-            <a:avLst/>
-          </a:prstGeom>
-          <a:noFill/>
-          <a:ln w="28575">
-            <a:solidFill>
-              <a:srgbClr val="FF4D6D">
-                <a:alpha val="95000"/>
-              </a:srgbClr>
-            </a:solidFill>
-            <a:prstDash val="solid"/>
-          </a:ln>
-        </p:spPr>
-      </p:sp>
-      <p:sp>
-        <p:nvSpPr>
-          <p:cNvPr id="25" name="Text 19"/>
-          <p:cNvSpPr/>
-          <p:nvPr/>
-        </p:nvSpPr>
-        <p:spPr>
-          <a:xfrm>
-            <a:off x="685800" y="5715000"/>
-            <a:ext cx="5486400" cy="548640"/>
-          </a:xfrm>
-          <a:prstGeom prst="rect">
-            <a:avLst/>
-          </a:prstGeom>
-          <a:noFill/>
-          <a:ln/>
-        </p:spPr>
-        <p:txBody>
-          <a:bodyPr wrap="square" rtlCol="0" anchor="t"/>
-          <a:lstStyle/>
-          <a:p>
-            <a:pPr algn="l" indent="0" marL="0">
-              <a:buNone/>
-            </a:pPr>
-            <a:r>
-              <a:rPr lang="en-US" sz="2600" b="1" i="1" dirty="0">
-                <a:solidFill>
-                  <a:srgbClr val="FBD8DF"/>
+          <p:cNvPr id="21" name="Shape 17"/>
+          <p:cNvSpPr/>
+          <p:nvPr/>
+        </p:nvSpPr>
+        <p:spPr>
+          <a:xfrm>
+            <a:off x="6519672" y="5047488"/>
+            <a:ext cx="438912" cy="438912"/>
+          </a:xfrm>
+          <a:prstGeom prst="ellipse">
+            <a:avLst/>
+          </a:prstGeom>
+          <a:solidFill>
+            <a:srgbClr val="2E7D32"/>
+          </a:solidFill>
+          <a:ln/>
+        </p:spPr>
+      </p:sp>
+      <p:sp>
+        <p:nvSpPr>
+          <p:cNvPr id="22" name="Text 18"/>
+          <p:cNvSpPr/>
+          <p:nvPr/>
+        </p:nvSpPr>
+        <p:spPr>
+          <a:xfrm>
+            <a:off x="7132320" y="4946904"/>
+            <a:ext cx="4297680" cy="365760"/>
+          </a:xfrm>
+          <a:prstGeom prst="rect">
+            <a:avLst/>
+          </a:prstGeom>
+          <a:noFill/>
+          <a:ln/>
+        </p:spPr>
+        <p:txBody>
+          <a:bodyPr wrap="square" lIns="0" tIns="0" rIns="0" bIns="0" rtlCol="0" anchor="ctr"/>
+          <a:lstStyle/>
+          <a:p>
+            <a:pPr algn="l" indent="0" marL="0">
+              <a:buNone/>
+            </a:pPr>
+            <a:r>
+              <a:rPr lang="en-US" sz="1800" b="1" dirty="0">
+                <a:solidFill>
+                  <a:srgbClr val="FFFFFF"/>
                 </a:solidFill>
                 <a:latin typeface="Cambria" pitchFamily="34" charset="0"/>
                 <a:ea typeface="Cambria" pitchFamily="34" charset="-122"/>
                 <a:cs typeface="Cambria" pitchFamily="34" charset="-120"/>
               </a:rPr>
-              <a:t>Thank you</a:t>
-            </a:r>
-            <a:endParaRPr lang="en-US" sz="2600" dirty="0"/>
-          </a:p>
-        </p:txBody>
-      </p:sp>
-      <p:sp>
-        <p:nvSpPr>
-          <p:cNvPr id="26" name="Text 20"/>
+              <a:t>Mild normocytic anaemia</a:t>
+            </a:r>
+            <a:endParaRPr lang="en-US" sz="1800" dirty="0"/>
+          </a:p>
+        </p:txBody>
+      </p:sp>
+      <p:sp>
+        <p:nvSpPr>
+          <p:cNvPr id="23" name="Text 19"/>
+          <p:cNvSpPr/>
+          <p:nvPr/>
+        </p:nvSpPr>
+        <p:spPr>
+          <a:xfrm>
+            <a:off x="7132320" y="5312664"/>
+            <a:ext cx="4297680" cy="329184"/>
+          </a:xfrm>
+          <a:prstGeom prst="rect">
+            <a:avLst/>
+          </a:prstGeom>
+          <a:noFill/>
+          <a:ln/>
+        </p:spPr>
+        <p:txBody>
+          <a:bodyPr wrap="square" lIns="0" tIns="0" rIns="0" bIns="0" rtlCol="0" anchor="ctr"/>
+          <a:lstStyle/>
+          <a:p>
+            <a:pPr algn="l" indent="0" marL="0">
+              <a:buNone/>
+            </a:pPr>
+            <a:r>
+              <a:rPr lang="en-US" sz="1250" i="1" dirty="0">
+                <a:solidFill>
+                  <a:srgbClr val="FBD8DF"/>
+                </a:solidFill>
+                <a:latin typeface="Calibri" pitchFamily="34" charset="0"/>
+                <a:ea typeface="Calibri" pitchFamily="34" charset="-122"/>
+                <a:cs typeface="Calibri" pitchFamily="34" charset="-120"/>
+              </a:rPr>
+              <a:t>Incidental haematology finding</a:t>
+            </a:r>
+            <a:endParaRPr lang="en-US" sz="1250" dirty="0"/>
+          </a:p>
+        </p:txBody>
+      </p:sp>
+      <p:sp>
+        <p:nvSpPr>
+          <p:cNvPr id="24" name="Text 20"/>
           <p:cNvSpPr/>
           <p:nvPr/>
         </p:nvSpPr>
@@ -16620,7 +16505,7 @@
       </p:sp>
       <p:sp>
         <p:nvSpPr>
-          <p:cNvPr id="27" name="Text 21"/>
+          <p:cNvPr id="25" name="Text 21"/>
           <p:cNvSpPr/>
           <p:nvPr/>
         </p:nvSpPr>
@@ -17860,6 +17745,816 @@
               <a:rPr lang="en-US" sz="900" dirty="0">
                 <a:solidFill>
                   <a:srgbClr val="6B6B76"/>
+                </a:solidFill>
+                <a:latin typeface="Calibri" pitchFamily="34" charset="0"/>
+                <a:ea typeface="Calibri" pitchFamily="34" charset="-122"/>
+                <a:cs typeface="Calibri" pitchFamily="34" charset="-120"/>
+              </a:rPr>
+              <a:t>Clinicopathological Conference</a:t>
+            </a:r>
+            <a:endParaRPr lang="en-US" sz="900" dirty="0"/>
+          </a:p>
+        </p:txBody>
+      </p:sp>
+    </p:spTree>
+  </p:cSld>
+  <p:clrMapOvr>
+    <a:masterClrMapping/>
+  </p:clrMapOvr>
+</p:sld>
+</file>
+
+<file path=ppt/slides/slide20.xml><?xml version="1.0" encoding="utf-8"?>
+<p:sld xmlns:a="http://schemas.openxmlformats.org/drawingml/2006/main" xmlns:r="http://schemas.openxmlformats.org/officeDocument/2006/relationships" xmlns:p="http://schemas.openxmlformats.org/presentationml/2006/main">
+  <p:cSld name="Slide 20">
+    <p:bg>
+      <p:bgPr>
+        <a:solidFill>
+          <a:srgbClr val="590D22"/>
+        </a:solidFill>
+      </p:bgPr>
+    </p:bg>
+    <p:spTree>
+      <p:nvGrpSpPr>
+        <p:cNvPr id="1" name=""/>
+        <p:cNvGrpSpPr/>
+        <p:nvPr/>
+      </p:nvGrpSpPr>
+      <p:grpSpPr>
+        <a:xfrm>
+          <a:off x="0" y="0"/>
+          <a:ext cx="0" cy="0"/>
+          <a:chOff x="0" y="0"/>
+          <a:chExt cx="0" cy="0"/>
+        </a:xfrm>
+      </p:grpSpPr>
+      <p:sp>
+        <p:nvSpPr>
+          <p:cNvPr id="2" name="Shape 0"/>
+          <p:cNvSpPr/>
+          <p:nvPr/>
+        </p:nvSpPr>
+        <p:spPr>
+          <a:xfrm>
+            <a:off x="0" y="0"/>
+            <a:ext cx="12191695" cy="6858000"/>
+          </a:xfrm>
+          <a:prstGeom prst="rect">
+            <a:avLst/>
+          </a:prstGeom>
+          <a:solidFill>
+            <a:srgbClr val="3A0A17">
+              <a:alpha val="65000"/>
+            </a:srgbClr>
+          </a:solidFill>
+          <a:ln/>
+        </p:spPr>
+      </p:sp>
+      <p:pic>
+        <p:nvPicPr>
+          <p:cNvPr id="3" name="Image 0" descr="preencoded.png">    </p:cNvPr>
+          <p:cNvPicPr>
+            <a:picLocks noChangeAspect="1"/>
+          </p:cNvPicPr>
+          <p:nvPr/>
+        </p:nvPicPr>
+        <p:blipFill>
+          <a:blip r:embed="rId1">
+            <a:alphaModFix amt="10000"/>
+          </a:blip>
+          <a:stretch>
+            <a:fillRect/>
+          </a:stretch>
+        </p:blipFill>
+        <p:spPr>
+          <a:xfrm>
+            <a:off x="7863840" y="3108960"/>
+            <a:ext cx="4754880" cy="4754880"/>
+          </a:xfrm>
+          <a:prstGeom prst="rect">
+            <a:avLst/>
+          </a:prstGeom>
+        </p:spPr>
+      </p:pic>
+      <p:sp>
+        <p:nvSpPr>
+          <p:cNvPr id="4" name="Shape 1"/>
+          <p:cNvSpPr/>
+          <p:nvPr/>
+        </p:nvSpPr>
+        <p:spPr>
+          <a:xfrm>
+            <a:off x="685800" y="777240"/>
+            <a:ext cx="960120" cy="960120"/>
+          </a:xfrm>
+          <a:prstGeom prst="ellipse">
+            <a:avLst/>
+          </a:prstGeom>
+          <a:solidFill>
+            <a:srgbClr val="A4133C"/>
+          </a:solidFill>
+          <a:ln/>
+        </p:spPr>
+      </p:sp>
+      <p:pic>
+        <p:nvPicPr>
+          <p:cNvPr id="5" name="Image 1" descr="preencoded.png">    </p:cNvPr>
+          <p:cNvPicPr>
+            <a:picLocks noChangeAspect="1"/>
+          </p:cNvPicPr>
+          <p:nvPr/>
+        </p:nvPicPr>
+        <p:blipFill>
+          <a:blip r:embed="rId2"/>
+          <a:stretch>
+            <a:fillRect/>
+          </a:stretch>
+        </p:blipFill>
+        <p:spPr>
+          <a:xfrm>
+            <a:off x="896112" y="987552"/>
+            <a:ext cx="548640" cy="548640"/>
+          </a:xfrm>
+          <a:prstGeom prst="rect">
+            <a:avLst/>
+          </a:prstGeom>
+        </p:spPr>
+      </p:pic>
+      <p:sp>
+        <p:nvSpPr>
+          <p:cNvPr id="6" name="Text 2"/>
+          <p:cNvSpPr/>
+          <p:nvPr/>
+        </p:nvSpPr>
+        <p:spPr>
+          <a:xfrm>
+            <a:off x="1828800" y="960120"/>
+            <a:ext cx="8229600" cy="548640"/>
+          </a:xfrm>
+          <a:prstGeom prst="rect">
+            <a:avLst/>
+          </a:prstGeom>
+          <a:noFill/>
+          <a:ln/>
+        </p:spPr>
+        <p:txBody>
+          <a:bodyPr wrap="square" rtlCol="0" anchor="ctr"/>
+          <a:lstStyle/>
+          <a:p>
+            <a:pPr algn="l" indent="0" marL="0">
+              <a:buNone/>
+            </a:pPr>
+            <a:r>
+              <a:rPr lang="en-US" sz="1700" b="1" spc="250" kern="0" dirty="0">
+                <a:solidFill>
+                  <a:srgbClr val="FF4D6D"/>
+                </a:solidFill>
+                <a:latin typeface="Calibri" pitchFamily="34" charset="0"/>
+                <a:ea typeface="Calibri" pitchFamily="34" charset="-122"/>
+                <a:cs typeface="Calibri" pitchFamily="34" charset="-120"/>
+              </a:rPr>
+              <a:t>HOSPITAL COURSE &amp; OUTCOME</a:t>
+            </a:r>
+            <a:endParaRPr lang="en-US" sz="1700" dirty="0"/>
+          </a:p>
+        </p:txBody>
+      </p:sp>
+      <p:sp>
+        <p:nvSpPr>
+          <p:cNvPr id="7" name="Text 3"/>
+          <p:cNvSpPr/>
+          <p:nvPr/>
+        </p:nvSpPr>
+        <p:spPr>
+          <a:xfrm>
+            <a:off x="640080" y="1965960"/>
+            <a:ext cx="10058400" cy="914400"/>
+          </a:xfrm>
+          <a:prstGeom prst="rect">
+            <a:avLst/>
+          </a:prstGeom>
+          <a:noFill/>
+          <a:ln/>
+        </p:spPr>
+        <p:txBody>
+          <a:bodyPr wrap="square" rtlCol="0" anchor="t"/>
+          <a:lstStyle/>
+          <a:p>
+            <a:pPr algn="l" indent="0" marL="0">
+              <a:buNone/>
+            </a:pPr>
+            <a:r>
+              <a:rPr lang="en-US" sz="5600" b="1" dirty="0">
+                <a:solidFill>
+                  <a:srgbClr val="FFFFFF"/>
+                </a:solidFill>
+                <a:latin typeface="Cambria" pitchFamily="34" charset="0"/>
+                <a:ea typeface="Cambria" pitchFamily="34" charset="-122"/>
+                <a:cs typeface="Cambria" pitchFamily="34" charset="-120"/>
+              </a:rPr>
+              <a:t>Clinically Improved</a:t>
+            </a:r>
+            <a:endParaRPr lang="en-US" sz="5600" dirty="0"/>
+          </a:p>
+        </p:txBody>
+      </p:sp>
+      <p:sp>
+        <p:nvSpPr>
+          <p:cNvPr id="8" name="Shape 4"/>
+          <p:cNvSpPr/>
+          <p:nvPr/>
+        </p:nvSpPr>
+        <p:spPr>
+          <a:xfrm>
+            <a:off x="685800" y="3200400"/>
+            <a:ext cx="3749040" cy="1554480"/>
+          </a:xfrm>
+          <a:prstGeom prst="roundRect">
+            <a:avLst>
+              <a:gd name="adj" fmla="val 7059"/>
+            </a:avLst>
+          </a:prstGeom>
+          <a:solidFill>
+            <a:srgbClr val="FFFFFF">
+              <a:alpha val="8000"/>
+            </a:srgbClr>
+          </a:solidFill>
+          <a:ln w="12700">
+            <a:solidFill>
+              <a:srgbClr val="FF4D6D"/>
+            </a:solidFill>
+            <a:prstDash val="solid"/>
+          </a:ln>
+          <a:effectLst>
+            <a:outerShdw sx="100000" sy="100000" kx="0" ky="0" algn="bl" rotWithShape="0" blurRad="101600" dist="38100" dir="5400000">
+              <a:srgbClr val="8A8A8A">
+                <a:alpha val="35000"/>
+              </a:srgbClr>
+            </a:outerShdw>
+          </a:effectLst>
+        </p:spPr>
+      </p:sp>
+      <p:sp>
+        <p:nvSpPr>
+          <p:cNvPr id="9" name="Shape 5"/>
+          <p:cNvSpPr/>
+          <p:nvPr/>
+        </p:nvSpPr>
+        <p:spPr>
+          <a:xfrm>
+            <a:off x="960120" y="3657600"/>
+            <a:ext cx="640080" cy="640080"/>
+          </a:xfrm>
+          <a:prstGeom prst="ellipse">
+            <a:avLst/>
+          </a:prstGeom>
+          <a:solidFill>
+            <a:srgbClr val="FFFFFF"/>
+          </a:solidFill>
+          <a:ln/>
+        </p:spPr>
+      </p:sp>
+      <p:pic>
+        <p:nvPicPr>
+          <p:cNvPr id="10" name="Image 2" descr="preencoded.png">    </p:cNvPr>
+          <p:cNvPicPr>
+            <a:picLocks noChangeAspect="1"/>
+          </p:cNvPicPr>
+          <p:nvPr/>
+        </p:nvPicPr>
+        <p:blipFill>
+          <a:blip r:embed="rId3"/>
+          <a:stretch>
+            <a:fillRect/>
+          </a:stretch>
+        </p:blipFill>
+        <p:spPr>
+          <a:xfrm>
+            <a:off x="1088136" y="3785616"/>
+            <a:ext cx="384048" cy="384048"/>
+          </a:xfrm>
+          <a:prstGeom prst="rect">
+            <a:avLst/>
+          </a:prstGeom>
+        </p:spPr>
+      </p:pic>
+      <p:sp>
+        <p:nvSpPr>
+          <p:cNvPr id="11" name="Text 6"/>
+          <p:cNvSpPr/>
+          <p:nvPr/>
+        </p:nvSpPr>
+        <p:spPr>
+          <a:xfrm>
+            <a:off x="1737360" y="3493008"/>
+            <a:ext cx="2560320" cy="457200"/>
+          </a:xfrm>
+          <a:prstGeom prst="rect">
+            <a:avLst/>
+          </a:prstGeom>
+          <a:noFill/>
+          <a:ln/>
+        </p:spPr>
+        <p:txBody>
+          <a:bodyPr wrap="square" lIns="0" tIns="0" rIns="0" bIns="0" rtlCol="0" anchor="ctr"/>
+          <a:lstStyle/>
+          <a:p>
+            <a:pPr algn="l" indent="0" marL="0">
+              <a:buNone/>
+            </a:pPr>
+            <a:r>
+              <a:rPr lang="en-US" sz="1900" b="1" dirty="0">
+                <a:solidFill>
+                  <a:srgbClr val="FFFFFF"/>
+                </a:solidFill>
+                <a:latin typeface="Cambria" pitchFamily="34" charset="0"/>
+                <a:ea typeface="Cambria" pitchFamily="34" charset="-122"/>
+                <a:cs typeface="Cambria" pitchFamily="34" charset="-120"/>
+              </a:rPr>
+              <a:t>Symptoms settled</a:t>
+            </a:r>
+            <a:endParaRPr lang="en-US" sz="1900" dirty="0"/>
+          </a:p>
+        </p:txBody>
+      </p:sp>
+      <p:sp>
+        <p:nvSpPr>
+          <p:cNvPr id="12" name="Text 7"/>
+          <p:cNvSpPr/>
+          <p:nvPr/>
+        </p:nvSpPr>
+        <p:spPr>
+          <a:xfrm>
+            <a:off x="1737360" y="3950208"/>
+            <a:ext cx="2606040" cy="640080"/>
+          </a:xfrm>
+          <a:prstGeom prst="rect">
+            <a:avLst/>
+          </a:prstGeom>
+          <a:noFill/>
+          <a:ln/>
+        </p:spPr>
+        <p:txBody>
+          <a:bodyPr wrap="square" lIns="0" tIns="0" rIns="0" bIns="0" rtlCol="0" anchor="t"/>
+          <a:lstStyle/>
+          <a:p>
+            <a:pPr algn="l" indent="0" marL="0">
+              <a:buNone/>
+            </a:pPr>
+            <a:r>
+              <a:rPr lang="en-US" sz="1250" i="1" dirty="0">
+                <a:solidFill>
+                  <a:srgbClr val="FBD8DF"/>
+                </a:solidFill>
+                <a:latin typeface="Calibri" pitchFamily="34" charset="0"/>
+                <a:ea typeface="Calibri" pitchFamily="34" charset="-122"/>
+                <a:cs typeface="Calibri" pitchFamily="34" charset="-120"/>
+              </a:rPr>
+              <a:t>Rhythm &amp; symptoms controlled</a:t>
+            </a:r>
+            <a:endParaRPr lang="en-US" sz="1250" dirty="0"/>
+          </a:p>
+        </p:txBody>
+      </p:sp>
+      <p:sp>
+        <p:nvSpPr>
+          <p:cNvPr id="13" name="Shape 8"/>
+          <p:cNvSpPr/>
+          <p:nvPr/>
+        </p:nvSpPr>
+        <p:spPr>
+          <a:xfrm>
+            <a:off x="4709160" y="3200400"/>
+            <a:ext cx="3749040" cy="1554480"/>
+          </a:xfrm>
+          <a:prstGeom prst="roundRect">
+            <a:avLst>
+              <a:gd name="adj" fmla="val 7059"/>
+            </a:avLst>
+          </a:prstGeom>
+          <a:solidFill>
+            <a:srgbClr val="FFFFFF">
+              <a:alpha val="8000"/>
+            </a:srgbClr>
+          </a:solidFill>
+          <a:ln w="12700">
+            <a:solidFill>
+              <a:srgbClr val="FF4D6D"/>
+            </a:solidFill>
+            <a:prstDash val="solid"/>
+          </a:ln>
+          <a:effectLst>
+            <a:outerShdw sx="100000" sy="100000" kx="0" ky="0" algn="bl" rotWithShape="0" blurRad="101600" dist="38100" dir="5400000">
+              <a:srgbClr val="8A8A8A">
+                <a:alpha val="35000"/>
+              </a:srgbClr>
+            </a:outerShdw>
+          </a:effectLst>
+        </p:spPr>
+      </p:sp>
+      <p:sp>
+        <p:nvSpPr>
+          <p:cNvPr id="14" name="Shape 9"/>
+          <p:cNvSpPr/>
+          <p:nvPr/>
+        </p:nvSpPr>
+        <p:spPr>
+          <a:xfrm>
+            <a:off x="4983480" y="3657600"/>
+            <a:ext cx="640080" cy="640080"/>
+          </a:xfrm>
+          <a:prstGeom prst="ellipse">
+            <a:avLst/>
+          </a:prstGeom>
+          <a:solidFill>
+            <a:srgbClr val="FFFFFF"/>
+          </a:solidFill>
+          <a:ln/>
+        </p:spPr>
+      </p:sp>
+      <p:pic>
+        <p:nvPicPr>
+          <p:cNvPr id="15" name="Image 3" descr="preencoded.png">    </p:cNvPr>
+          <p:cNvPicPr>
+            <a:picLocks noChangeAspect="1"/>
+          </p:cNvPicPr>
+          <p:nvPr/>
+        </p:nvPicPr>
+        <p:blipFill>
+          <a:blip r:embed="rId4"/>
+          <a:stretch>
+            <a:fillRect/>
+          </a:stretch>
+        </p:blipFill>
+        <p:spPr>
+          <a:xfrm>
+            <a:off x="5111496" y="3785616"/>
+            <a:ext cx="384048" cy="384048"/>
+          </a:xfrm>
+          <a:prstGeom prst="rect">
+            <a:avLst/>
+          </a:prstGeom>
+        </p:spPr>
+      </p:pic>
+      <p:sp>
+        <p:nvSpPr>
+          <p:cNvPr id="16" name="Text 10"/>
+          <p:cNvSpPr/>
+          <p:nvPr/>
+        </p:nvSpPr>
+        <p:spPr>
+          <a:xfrm>
+            <a:off x="5760720" y="3493008"/>
+            <a:ext cx="2560320" cy="457200"/>
+          </a:xfrm>
+          <a:prstGeom prst="rect">
+            <a:avLst/>
+          </a:prstGeom>
+          <a:noFill/>
+          <a:ln/>
+        </p:spPr>
+        <p:txBody>
+          <a:bodyPr wrap="square" lIns="0" tIns="0" rIns="0" bIns="0" rtlCol="0" anchor="ctr"/>
+          <a:lstStyle/>
+          <a:p>
+            <a:pPr algn="l" indent="0" marL="0">
+              <a:buNone/>
+            </a:pPr>
+            <a:r>
+              <a:rPr lang="en-US" sz="1900" b="1" dirty="0">
+                <a:solidFill>
+                  <a:srgbClr val="FFFFFF"/>
+                </a:solidFill>
+                <a:latin typeface="Cambria" pitchFamily="34" charset="0"/>
+                <a:ea typeface="Cambria" pitchFamily="34" charset="-122"/>
+                <a:cs typeface="Cambria" pitchFamily="34" charset="-120"/>
+              </a:rPr>
+              <a:t>Discharged home</a:t>
+            </a:r>
+            <a:endParaRPr lang="en-US" sz="1900" dirty="0"/>
+          </a:p>
+        </p:txBody>
+      </p:sp>
+      <p:sp>
+        <p:nvSpPr>
+          <p:cNvPr id="17" name="Text 11"/>
+          <p:cNvSpPr/>
+          <p:nvPr/>
+        </p:nvSpPr>
+        <p:spPr>
+          <a:xfrm>
+            <a:off x="5760720" y="3950208"/>
+            <a:ext cx="2606040" cy="640080"/>
+          </a:xfrm>
+          <a:prstGeom prst="rect">
+            <a:avLst/>
+          </a:prstGeom>
+          <a:noFill/>
+          <a:ln/>
+        </p:spPr>
+        <p:txBody>
+          <a:bodyPr wrap="square" lIns="0" tIns="0" rIns="0" bIns="0" rtlCol="0" anchor="t"/>
+          <a:lstStyle/>
+          <a:p>
+            <a:pPr algn="l" indent="0" marL="0">
+              <a:buNone/>
+            </a:pPr>
+            <a:r>
+              <a:rPr lang="en-US" sz="1250" i="1" dirty="0">
+                <a:solidFill>
+                  <a:srgbClr val="FBD8DF"/>
+                </a:solidFill>
+                <a:latin typeface="Calibri" pitchFamily="34" charset="0"/>
+                <a:ea typeface="Calibri" pitchFamily="34" charset="-122"/>
+                <a:cs typeface="Calibri" pitchFamily="34" charset="-120"/>
+              </a:rPr>
+              <a:t>Stable for outpatient follow-up</a:t>
+            </a:r>
+            <a:endParaRPr lang="en-US" sz="1250" dirty="0"/>
+          </a:p>
+        </p:txBody>
+      </p:sp>
+      <p:sp>
+        <p:nvSpPr>
+          <p:cNvPr id="18" name="Shape 12"/>
+          <p:cNvSpPr/>
+          <p:nvPr/>
+        </p:nvSpPr>
+        <p:spPr>
+          <a:xfrm>
+            <a:off x="731520" y="5486400"/>
+            <a:ext cx="2020824" cy="0"/>
+          </a:xfrm>
+          <a:prstGeom prst="line">
+            <a:avLst/>
+          </a:prstGeom>
+          <a:noFill/>
+          <a:ln w="28575">
+            <a:solidFill>
+              <a:srgbClr val="FF4D6D">
+                <a:alpha val="95000"/>
+              </a:srgbClr>
+            </a:solidFill>
+            <a:prstDash val="solid"/>
+          </a:ln>
+        </p:spPr>
+      </p:sp>
+      <p:sp>
+        <p:nvSpPr>
+          <p:cNvPr id="19" name="Shape 13"/>
+          <p:cNvSpPr/>
+          <p:nvPr/>
+        </p:nvSpPr>
+        <p:spPr>
+          <a:xfrm flipV="1">
+            <a:off x="2752344" y="5340096"/>
+            <a:ext cx="356616" cy="146304"/>
+          </a:xfrm>
+          <a:prstGeom prst="line">
+            <a:avLst/>
+          </a:prstGeom>
+          <a:noFill/>
+          <a:ln w="28575">
+            <a:solidFill>
+              <a:srgbClr val="FF4D6D">
+                <a:alpha val="95000"/>
+              </a:srgbClr>
+            </a:solidFill>
+            <a:prstDash val="solid"/>
+          </a:ln>
+        </p:spPr>
+      </p:sp>
+      <p:sp>
+        <p:nvSpPr>
+          <p:cNvPr id="20" name="Shape 14"/>
+          <p:cNvSpPr/>
+          <p:nvPr/>
+        </p:nvSpPr>
+        <p:spPr>
+          <a:xfrm>
+            <a:off x="3108960" y="5340096"/>
+            <a:ext cx="356616" cy="457200"/>
+          </a:xfrm>
+          <a:prstGeom prst="line">
+            <a:avLst/>
+          </a:prstGeom>
+          <a:noFill/>
+          <a:ln w="28575">
+            <a:solidFill>
+              <a:srgbClr val="FF4D6D">
+                <a:alpha val="95000"/>
+              </a:srgbClr>
+            </a:solidFill>
+            <a:prstDash val="solid"/>
+          </a:ln>
+        </p:spPr>
+      </p:sp>
+      <p:sp>
+        <p:nvSpPr>
+          <p:cNvPr id="21" name="Shape 15"/>
+          <p:cNvSpPr/>
+          <p:nvPr/>
+        </p:nvSpPr>
+        <p:spPr>
+          <a:xfrm flipV="1">
+            <a:off x="3465576" y="4983480"/>
+            <a:ext cx="356616" cy="813816"/>
+          </a:xfrm>
+          <a:prstGeom prst="line">
+            <a:avLst/>
+          </a:prstGeom>
+          <a:noFill/>
+          <a:ln w="28575">
+            <a:solidFill>
+              <a:srgbClr val="FF4D6D">
+                <a:alpha val="95000"/>
+              </a:srgbClr>
+            </a:solidFill>
+            <a:prstDash val="solid"/>
+          </a:ln>
+        </p:spPr>
+      </p:sp>
+      <p:sp>
+        <p:nvSpPr>
+          <p:cNvPr id="22" name="Shape 16"/>
+          <p:cNvSpPr/>
+          <p:nvPr/>
+        </p:nvSpPr>
+        <p:spPr>
+          <a:xfrm>
+            <a:off x="3822192" y="4983480"/>
+            <a:ext cx="356616" cy="685800"/>
+          </a:xfrm>
+          <a:prstGeom prst="line">
+            <a:avLst/>
+          </a:prstGeom>
+          <a:noFill/>
+          <a:ln w="28575">
+            <a:solidFill>
+              <a:srgbClr val="FF4D6D">
+                <a:alpha val="95000"/>
+              </a:srgbClr>
+            </a:solidFill>
+            <a:prstDash val="solid"/>
+          </a:ln>
+        </p:spPr>
+      </p:sp>
+      <p:sp>
+        <p:nvSpPr>
+          <p:cNvPr id="23" name="Shape 17"/>
+          <p:cNvSpPr/>
+          <p:nvPr/>
+        </p:nvSpPr>
+        <p:spPr>
+          <a:xfrm flipV="1">
+            <a:off x="4178808" y="5486400"/>
+            <a:ext cx="356616" cy="182880"/>
+          </a:xfrm>
+          <a:prstGeom prst="line">
+            <a:avLst/>
+          </a:prstGeom>
+          <a:noFill/>
+          <a:ln w="28575">
+            <a:solidFill>
+              <a:srgbClr val="FF4D6D">
+                <a:alpha val="95000"/>
+              </a:srgbClr>
+            </a:solidFill>
+            <a:prstDash val="solid"/>
+          </a:ln>
+        </p:spPr>
+      </p:sp>
+      <p:sp>
+        <p:nvSpPr>
+          <p:cNvPr id="24" name="Shape 18"/>
+          <p:cNvSpPr/>
+          <p:nvPr/>
+        </p:nvSpPr>
+        <p:spPr>
+          <a:xfrm>
+            <a:off x="4535424" y="5486400"/>
+            <a:ext cx="2139696" cy="0"/>
+          </a:xfrm>
+          <a:prstGeom prst="line">
+            <a:avLst/>
+          </a:prstGeom>
+          <a:noFill/>
+          <a:ln w="28575">
+            <a:solidFill>
+              <a:srgbClr val="FF4D6D">
+                <a:alpha val="95000"/>
+              </a:srgbClr>
+            </a:solidFill>
+            <a:prstDash val="solid"/>
+          </a:ln>
+        </p:spPr>
+      </p:sp>
+      <p:sp>
+        <p:nvSpPr>
+          <p:cNvPr id="25" name="Text 19"/>
+          <p:cNvSpPr/>
+          <p:nvPr/>
+        </p:nvSpPr>
+        <p:spPr>
+          <a:xfrm>
+            <a:off x="685800" y="5715000"/>
+            <a:ext cx="5486400" cy="548640"/>
+          </a:xfrm>
+          <a:prstGeom prst="rect">
+            <a:avLst/>
+          </a:prstGeom>
+          <a:noFill/>
+          <a:ln/>
+        </p:spPr>
+        <p:txBody>
+          <a:bodyPr wrap="square" rtlCol="0" anchor="t"/>
+          <a:lstStyle/>
+          <a:p>
+            <a:pPr algn="l" indent="0" marL="0">
+              <a:buNone/>
+            </a:pPr>
+            <a:r>
+              <a:rPr lang="en-US" sz="2600" b="1" i="1" dirty="0">
+                <a:solidFill>
+                  <a:srgbClr val="FBD8DF"/>
+                </a:solidFill>
+                <a:latin typeface="Cambria" pitchFamily="34" charset="0"/>
+                <a:ea typeface="Cambria" pitchFamily="34" charset="-122"/>
+                <a:cs typeface="Cambria" pitchFamily="34" charset="-120"/>
+              </a:rPr>
+              <a:t>Thank you</a:t>
+            </a:r>
+            <a:endParaRPr lang="en-US" sz="2600" dirty="0"/>
+          </a:p>
+        </p:txBody>
+      </p:sp>
+      <p:sp>
+        <p:nvSpPr>
+          <p:cNvPr id="26" name="Text 20"/>
+          <p:cNvSpPr/>
+          <p:nvPr/>
+        </p:nvSpPr>
+        <p:spPr>
+          <a:xfrm>
+            <a:off x="11277295" y="6355080"/>
+            <a:ext cx="548640" cy="320040"/>
+          </a:xfrm>
+          <a:prstGeom prst="rect">
+            <a:avLst/>
+          </a:prstGeom>
+          <a:noFill/>
+          <a:ln/>
+        </p:spPr>
+        <p:txBody>
+          <a:bodyPr wrap="square" rtlCol="0" anchor="t"/>
+          <a:lstStyle/>
+          <a:p>
+            <a:pPr algn="r" indent="0" marL="0">
+              <a:buNone/>
+            </a:pPr>
+            <a:r>
+              <a:rPr lang="en-US" sz="1100" b="1" dirty="0">
+                <a:solidFill>
+                  <a:srgbClr val="FBD8DF"/>
+                </a:solidFill>
+                <a:latin typeface="Calibri" pitchFamily="34" charset="0"/>
+                <a:ea typeface="Calibri" pitchFamily="34" charset="-122"/>
+                <a:cs typeface="Calibri" pitchFamily="34" charset="-120"/>
+              </a:rPr>
+              <a:t>20</a:t>
+            </a:r>
+            <a:endParaRPr lang="en-US" sz="1100" dirty="0"/>
+          </a:p>
+        </p:txBody>
+      </p:sp>
+      <p:sp>
+        <p:nvSpPr>
+          <p:cNvPr id="27" name="Text 21"/>
+          <p:cNvSpPr/>
+          <p:nvPr/>
+        </p:nvSpPr>
+        <p:spPr>
+          <a:xfrm>
+            <a:off x="502920" y="6355080"/>
+            <a:ext cx="5486400" cy="320040"/>
+          </a:xfrm>
+          <a:prstGeom prst="rect">
+            <a:avLst/>
+          </a:prstGeom>
+          <a:noFill/>
+          <a:ln/>
+        </p:spPr>
+        <p:txBody>
+          <a:bodyPr wrap="square" rtlCol="0" anchor="t"/>
+          <a:lstStyle/>
+          <a:p>
+            <a:pPr algn="l" indent="0" marL="0">
+              <a:buNone/>
+            </a:pPr>
+            <a:r>
+              <a:rPr lang="en-US" sz="900" dirty="0">
+                <a:solidFill>
+                  <a:srgbClr val="FBD8DF"/>
                 </a:solidFill>
                 <a:latin typeface="Calibri" pitchFamily="34" charset="0"/>
                 <a:ea typeface="Calibri" pitchFamily="34" charset="-122"/>

</xml_diff>